<commit_message>
Verify cloud persistence and fresh-workspace browser flow
</commit_message>
<xml_diff>
--- a/docs/delivery/Invoice_Studio_SLT.pptx
+++ b/docs/delivery/Invoice_Studio_SLT.pptx
@@ -3155,7 +3155,7 @@
         <p:spPr>
           <a:xfrm>
             <a:off x="548640" y="868680"/>
-            <a:ext cx="10972800" cy="914400"/>
+            <a:ext cx="10972800" cy="1188720"/>
           </a:xfrm>
           <a:prstGeom prst="rect">
             <a:avLst/>
@@ -3519,7 +3519,7 @@
         <p:spPr>
           <a:xfrm>
             <a:off x="548640" y="868680"/>
-            <a:ext cx="10972800" cy="914400"/>
+            <a:ext cx="10972800" cy="1188720"/>
           </a:xfrm>
           <a:prstGeom prst="rect">
             <a:avLst/>
@@ -3689,24 +3689,24 @@
         <p:spPr>
           <a:xfrm>
             <a:off x="731520" y="2304288"/>
-            <a:ext cx="3215640" cy="640080"/>
-          </a:xfrm>
-          <a:prstGeom prst="rect">
-            <a:avLst/>
-          </a:prstGeom>
-          <a:noFill/>
-        </p:spPr>
-        <p:txBody>
-          <a:bodyPr wrap="square" lIns="109728" rIns="109728">
-            <a:spAutoFit/>
-          </a:bodyPr>
-          <a:lstStyle/>
-          <a:p>
-            <a:pPr>
-              <a:spcAft>
-                <a:spcPts val="1200"/>
-              </a:spcAft>
-              <a:defRPr sz="2200" b="1">
+            <a:ext cx="3215640" cy="960120"/>
+          </a:xfrm>
+          <a:prstGeom prst="rect">
+            <a:avLst/>
+          </a:prstGeom>
+          <a:noFill/>
+        </p:spPr>
+        <p:txBody>
+          <a:bodyPr wrap="square" lIns="109728" rIns="109728">
+            <a:spAutoFit/>
+          </a:bodyPr>
+          <a:lstStyle/>
+          <a:p>
+            <a:pPr>
+              <a:spcAft>
+                <a:spcPts val="1200"/>
+              </a:spcAft>
+              <a:defRPr sz="2100" b="1">
                 <a:solidFill>
                   <a:srgbClr val="037E83"/>
                 </a:solidFill>
@@ -3722,7 +3722,7 @@
               <a:spcAft>
                 <a:spcPts val="1200"/>
               </a:spcAft>
-              <a:defRPr sz="2200" b="1">
+              <a:defRPr sz="2100" b="1">
                 <a:solidFill>
                   <a:srgbClr val="037E83"/>
                 </a:solidFill>
@@ -3743,8 +3743,8 @@
         </p:nvSpPr>
         <p:spPr>
           <a:xfrm>
-            <a:off x="731520" y="3063240"/>
-            <a:ext cx="3215640" cy="2194560"/>
+            <a:off x="731520" y="3383280"/>
+            <a:ext cx="3215640" cy="2011680"/>
           </a:xfrm>
           <a:prstGeom prst="rect">
             <a:avLst/>
@@ -3836,24 +3836,24 @@
         <p:spPr>
           <a:xfrm>
             <a:off x="4386072" y="2304288"/>
-            <a:ext cx="3215640" cy="640080"/>
-          </a:xfrm>
-          <a:prstGeom prst="rect">
-            <a:avLst/>
-          </a:prstGeom>
-          <a:noFill/>
-        </p:spPr>
-        <p:txBody>
-          <a:bodyPr wrap="square" lIns="109728" rIns="109728">
-            <a:spAutoFit/>
-          </a:bodyPr>
-          <a:lstStyle/>
-          <a:p>
-            <a:pPr>
-              <a:spcAft>
-                <a:spcPts val="1200"/>
-              </a:spcAft>
-              <a:defRPr sz="2200" b="1">
+            <a:ext cx="3215640" cy="960120"/>
+          </a:xfrm>
+          <a:prstGeom prst="rect">
+            <a:avLst/>
+          </a:prstGeom>
+          <a:noFill/>
+        </p:spPr>
+        <p:txBody>
+          <a:bodyPr wrap="square" lIns="109728" rIns="109728">
+            <a:spAutoFit/>
+          </a:bodyPr>
+          <a:lstStyle/>
+          <a:p>
+            <a:pPr>
+              <a:spcAft>
+                <a:spcPts val="1200"/>
+              </a:spcAft>
+              <a:defRPr sz="2100" b="1">
                 <a:solidFill>
                   <a:srgbClr val="037E83"/>
                 </a:solidFill>
@@ -3869,7 +3869,7 @@
               <a:spcAft>
                 <a:spcPts val="1200"/>
               </a:spcAft>
-              <a:defRPr sz="2200" b="1">
+              <a:defRPr sz="2100" b="1">
                 <a:solidFill>
                   <a:srgbClr val="037E83"/>
                 </a:solidFill>
@@ -3890,8 +3890,8 @@
         </p:nvSpPr>
         <p:spPr>
           <a:xfrm>
-            <a:off x="4386072" y="3063240"/>
-            <a:ext cx="3215640" cy="2194560"/>
+            <a:off x="4386072" y="3383280"/>
+            <a:ext cx="3215640" cy="2011680"/>
           </a:xfrm>
           <a:prstGeom prst="rect">
             <a:avLst/>
@@ -3983,24 +3983,24 @@
         <p:spPr>
           <a:xfrm>
             <a:off x="8040624" y="2304288"/>
-            <a:ext cx="3215640" cy="640080"/>
-          </a:xfrm>
-          <a:prstGeom prst="rect">
-            <a:avLst/>
-          </a:prstGeom>
-          <a:noFill/>
-        </p:spPr>
-        <p:txBody>
-          <a:bodyPr wrap="square" lIns="109728" rIns="109728">
-            <a:spAutoFit/>
-          </a:bodyPr>
-          <a:lstStyle/>
-          <a:p>
-            <a:pPr>
-              <a:spcAft>
-                <a:spcPts val="1200"/>
-              </a:spcAft>
-              <a:defRPr sz="2200" b="1">
+            <a:ext cx="3215640" cy="960120"/>
+          </a:xfrm>
+          <a:prstGeom prst="rect">
+            <a:avLst/>
+          </a:prstGeom>
+          <a:noFill/>
+        </p:spPr>
+        <p:txBody>
+          <a:bodyPr wrap="square" lIns="109728" rIns="109728">
+            <a:spAutoFit/>
+          </a:bodyPr>
+          <a:lstStyle/>
+          <a:p>
+            <a:pPr>
+              <a:spcAft>
+                <a:spcPts val="1200"/>
+              </a:spcAft>
+              <a:defRPr sz="2100" b="1">
                 <a:solidFill>
                   <a:srgbClr val="037E83"/>
                 </a:solidFill>
@@ -4016,7 +4016,7 @@
               <a:spcAft>
                 <a:spcPts val="1200"/>
               </a:spcAft>
-              <a:defRPr sz="2200" b="1">
+              <a:defRPr sz="2100" b="1">
                 <a:solidFill>
                   <a:srgbClr val="037E83"/>
                 </a:solidFill>
@@ -4037,8 +4037,8 @@
         </p:nvSpPr>
         <p:spPr>
           <a:xfrm>
-            <a:off x="8040624" y="3063240"/>
-            <a:ext cx="3215640" cy="2194560"/>
+            <a:off x="8040624" y="3383280"/>
+            <a:ext cx="3215640" cy="2011680"/>
           </a:xfrm>
           <a:prstGeom prst="rect">
             <a:avLst/>
@@ -4181,7 +4181,7 @@
         <p:spPr>
           <a:xfrm>
             <a:off x="548640" y="868680"/>
-            <a:ext cx="10972800" cy="914400"/>
+            <a:ext cx="10972800" cy="1188720"/>
           </a:xfrm>
           <a:prstGeom prst="rect">
             <a:avLst/>
@@ -4351,24 +4351,24 @@
         <p:spPr>
           <a:xfrm>
             <a:off x="731520" y="2304288"/>
-            <a:ext cx="3215640" cy="640080"/>
-          </a:xfrm>
-          <a:prstGeom prst="rect">
-            <a:avLst/>
-          </a:prstGeom>
-          <a:noFill/>
-        </p:spPr>
-        <p:txBody>
-          <a:bodyPr wrap="square" lIns="109728" rIns="109728">
-            <a:spAutoFit/>
-          </a:bodyPr>
-          <a:lstStyle/>
-          <a:p>
-            <a:pPr>
-              <a:spcAft>
-                <a:spcPts val="1200"/>
-              </a:spcAft>
-              <a:defRPr sz="2200" b="1">
+            <a:ext cx="3215640" cy="960120"/>
+          </a:xfrm>
+          <a:prstGeom prst="rect">
+            <a:avLst/>
+          </a:prstGeom>
+          <a:noFill/>
+        </p:spPr>
+        <p:txBody>
+          <a:bodyPr wrap="square" lIns="109728" rIns="109728">
+            <a:spAutoFit/>
+          </a:bodyPr>
+          <a:lstStyle/>
+          <a:p>
+            <a:pPr>
+              <a:spcAft>
+                <a:spcPts val="1200"/>
+              </a:spcAft>
+              <a:defRPr sz="2100" b="1">
                 <a:solidFill>
                   <a:srgbClr val="037E83"/>
                 </a:solidFill>
@@ -4389,8 +4389,8 @@
         </p:nvSpPr>
         <p:spPr>
           <a:xfrm>
-            <a:off x="731520" y="3063240"/>
-            <a:ext cx="3215640" cy="2194560"/>
+            <a:off x="731520" y="3383280"/>
+            <a:ext cx="3215640" cy="2011680"/>
           </a:xfrm>
           <a:prstGeom prst="rect">
             <a:avLst/>
@@ -4482,24 +4482,24 @@
         <p:spPr>
           <a:xfrm>
             <a:off x="4386072" y="2304288"/>
-            <a:ext cx="3215640" cy="640080"/>
-          </a:xfrm>
-          <a:prstGeom prst="rect">
-            <a:avLst/>
-          </a:prstGeom>
-          <a:noFill/>
-        </p:spPr>
-        <p:txBody>
-          <a:bodyPr wrap="square" lIns="109728" rIns="109728">
-            <a:spAutoFit/>
-          </a:bodyPr>
-          <a:lstStyle/>
-          <a:p>
-            <a:pPr>
-              <a:spcAft>
-                <a:spcPts val="1200"/>
-              </a:spcAft>
-              <a:defRPr sz="2200" b="1">
+            <a:ext cx="3215640" cy="960120"/>
+          </a:xfrm>
+          <a:prstGeom prst="rect">
+            <a:avLst/>
+          </a:prstGeom>
+          <a:noFill/>
+        </p:spPr>
+        <p:txBody>
+          <a:bodyPr wrap="square" lIns="109728" rIns="109728">
+            <a:spAutoFit/>
+          </a:bodyPr>
+          <a:lstStyle/>
+          <a:p>
+            <a:pPr>
+              <a:spcAft>
+                <a:spcPts val="1200"/>
+              </a:spcAft>
+              <a:defRPr sz="2100" b="1">
                 <a:solidFill>
                   <a:srgbClr val="037E83"/>
                 </a:solidFill>
@@ -4520,8 +4520,8 @@
         </p:nvSpPr>
         <p:spPr>
           <a:xfrm>
-            <a:off x="4386072" y="3063240"/>
-            <a:ext cx="3215640" cy="2194560"/>
+            <a:off x="4386072" y="3383280"/>
+            <a:ext cx="3215640" cy="2011680"/>
           </a:xfrm>
           <a:prstGeom prst="rect">
             <a:avLst/>
@@ -4613,24 +4613,24 @@
         <p:spPr>
           <a:xfrm>
             <a:off x="8040624" y="2304288"/>
-            <a:ext cx="3215640" cy="640080"/>
-          </a:xfrm>
-          <a:prstGeom prst="rect">
-            <a:avLst/>
-          </a:prstGeom>
-          <a:noFill/>
-        </p:spPr>
-        <p:txBody>
-          <a:bodyPr wrap="square" lIns="109728" rIns="109728">
-            <a:spAutoFit/>
-          </a:bodyPr>
-          <a:lstStyle/>
-          <a:p>
-            <a:pPr>
-              <a:spcAft>
-                <a:spcPts val="1200"/>
-              </a:spcAft>
-              <a:defRPr sz="2200" b="1">
+            <a:ext cx="3215640" cy="960120"/>
+          </a:xfrm>
+          <a:prstGeom prst="rect">
+            <a:avLst/>
+          </a:prstGeom>
+          <a:noFill/>
+        </p:spPr>
+        <p:txBody>
+          <a:bodyPr wrap="square" lIns="109728" rIns="109728">
+            <a:spAutoFit/>
+          </a:bodyPr>
+          <a:lstStyle/>
+          <a:p>
+            <a:pPr>
+              <a:spcAft>
+                <a:spcPts val="1200"/>
+              </a:spcAft>
+              <a:defRPr sz="2100" b="1">
                 <a:solidFill>
                   <a:srgbClr val="037E83"/>
                 </a:solidFill>
@@ -4651,8 +4651,8 @@
         </p:nvSpPr>
         <p:spPr>
           <a:xfrm>
-            <a:off x="8040624" y="3063240"/>
-            <a:ext cx="3215640" cy="2194560"/>
+            <a:off x="8040624" y="3383280"/>
+            <a:ext cx="3215640" cy="2011680"/>
           </a:xfrm>
           <a:prstGeom prst="rect">
             <a:avLst/>
@@ -4756,7 +4756,7 @@
         <p:spPr>
           <a:xfrm>
             <a:off x="548640" y="868680"/>
-            <a:ext cx="10972800" cy="914400"/>
+            <a:ext cx="10972800" cy="1188720"/>
           </a:xfrm>
           <a:prstGeom prst="rect">
             <a:avLst/>
@@ -4926,24 +4926,24 @@
         <p:spPr>
           <a:xfrm>
             <a:off x="731520" y="2304288"/>
-            <a:ext cx="3215640" cy="640080"/>
-          </a:xfrm>
-          <a:prstGeom prst="rect">
-            <a:avLst/>
-          </a:prstGeom>
-          <a:noFill/>
-        </p:spPr>
-        <p:txBody>
-          <a:bodyPr wrap="square" lIns="109728" rIns="109728">
-            <a:spAutoFit/>
-          </a:bodyPr>
-          <a:lstStyle/>
-          <a:p>
-            <a:pPr>
-              <a:spcAft>
-                <a:spcPts val="1200"/>
-              </a:spcAft>
-              <a:defRPr sz="2200" b="1">
+            <a:ext cx="3215640" cy="960120"/>
+          </a:xfrm>
+          <a:prstGeom prst="rect">
+            <a:avLst/>
+          </a:prstGeom>
+          <a:noFill/>
+        </p:spPr>
+        <p:txBody>
+          <a:bodyPr wrap="square" lIns="109728" rIns="109728">
+            <a:spAutoFit/>
+          </a:bodyPr>
+          <a:lstStyle/>
+          <a:p>
+            <a:pPr>
+              <a:spcAft>
+                <a:spcPts val="1200"/>
+              </a:spcAft>
+              <a:defRPr sz="2100" b="1">
                 <a:solidFill>
                   <a:srgbClr val="037E83"/>
                 </a:solidFill>
@@ -4964,8 +4964,8 @@
         </p:nvSpPr>
         <p:spPr>
           <a:xfrm>
-            <a:off x="731520" y="3063240"/>
-            <a:ext cx="3215640" cy="2194560"/>
+            <a:off x="731520" y="3383280"/>
+            <a:ext cx="3215640" cy="2011680"/>
           </a:xfrm>
           <a:prstGeom prst="rect">
             <a:avLst/>
@@ -5057,24 +5057,24 @@
         <p:spPr>
           <a:xfrm>
             <a:off x="4386072" y="2304288"/>
-            <a:ext cx="3215640" cy="640080"/>
-          </a:xfrm>
-          <a:prstGeom prst="rect">
-            <a:avLst/>
-          </a:prstGeom>
-          <a:noFill/>
-        </p:spPr>
-        <p:txBody>
-          <a:bodyPr wrap="square" lIns="109728" rIns="109728">
-            <a:spAutoFit/>
-          </a:bodyPr>
-          <a:lstStyle/>
-          <a:p>
-            <a:pPr>
-              <a:spcAft>
-                <a:spcPts val="1200"/>
-              </a:spcAft>
-              <a:defRPr sz="2200" b="1">
+            <a:ext cx="3215640" cy="960120"/>
+          </a:xfrm>
+          <a:prstGeom prst="rect">
+            <a:avLst/>
+          </a:prstGeom>
+          <a:noFill/>
+        </p:spPr>
+        <p:txBody>
+          <a:bodyPr wrap="square" lIns="109728" rIns="109728">
+            <a:spAutoFit/>
+          </a:bodyPr>
+          <a:lstStyle/>
+          <a:p>
+            <a:pPr>
+              <a:spcAft>
+                <a:spcPts val="1200"/>
+              </a:spcAft>
+              <a:defRPr sz="2100" b="1">
                 <a:solidFill>
                   <a:srgbClr val="037E83"/>
                 </a:solidFill>
@@ -5095,8 +5095,8 @@
         </p:nvSpPr>
         <p:spPr>
           <a:xfrm>
-            <a:off x="4386072" y="3063240"/>
-            <a:ext cx="3215640" cy="2194560"/>
+            <a:off x="4386072" y="3383280"/>
+            <a:ext cx="3215640" cy="2011680"/>
           </a:xfrm>
           <a:prstGeom prst="rect">
             <a:avLst/>
@@ -5188,24 +5188,24 @@
         <p:spPr>
           <a:xfrm>
             <a:off x="8040624" y="2304288"/>
-            <a:ext cx="3215640" cy="640080"/>
-          </a:xfrm>
-          <a:prstGeom prst="rect">
-            <a:avLst/>
-          </a:prstGeom>
-          <a:noFill/>
-        </p:spPr>
-        <p:txBody>
-          <a:bodyPr wrap="square" lIns="109728" rIns="109728">
-            <a:spAutoFit/>
-          </a:bodyPr>
-          <a:lstStyle/>
-          <a:p>
-            <a:pPr>
-              <a:spcAft>
-                <a:spcPts val="1200"/>
-              </a:spcAft>
-              <a:defRPr sz="2200" b="1">
+            <a:ext cx="3215640" cy="960120"/>
+          </a:xfrm>
+          <a:prstGeom prst="rect">
+            <a:avLst/>
+          </a:prstGeom>
+          <a:noFill/>
+        </p:spPr>
+        <p:txBody>
+          <a:bodyPr wrap="square" lIns="109728" rIns="109728">
+            <a:spAutoFit/>
+          </a:bodyPr>
+          <a:lstStyle/>
+          <a:p>
+            <a:pPr>
+              <a:spcAft>
+                <a:spcPts val="1200"/>
+              </a:spcAft>
+              <a:defRPr sz="2100" b="1">
                 <a:solidFill>
                   <a:srgbClr val="037E83"/>
                 </a:solidFill>
@@ -5226,8 +5226,8 @@
         </p:nvSpPr>
         <p:spPr>
           <a:xfrm>
-            <a:off x="8040624" y="3063240"/>
-            <a:ext cx="3215640" cy="2194560"/>
+            <a:off x="8040624" y="3383280"/>
+            <a:ext cx="3215640" cy="2011680"/>
           </a:xfrm>
           <a:prstGeom prst="rect">
             <a:avLst/>
@@ -5370,7 +5370,7 @@
         <p:spPr>
           <a:xfrm>
             <a:off x="548640" y="868680"/>
-            <a:ext cx="10972800" cy="914400"/>
+            <a:ext cx="10972800" cy="1188720"/>
           </a:xfrm>
           <a:prstGeom prst="rect">
             <a:avLst/>
@@ -5540,24 +5540,24 @@
         <p:spPr>
           <a:xfrm>
             <a:off x="731520" y="2304288"/>
-            <a:ext cx="3215640" cy="640080"/>
-          </a:xfrm>
-          <a:prstGeom prst="rect">
-            <a:avLst/>
-          </a:prstGeom>
-          <a:noFill/>
-        </p:spPr>
-        <p:txBody>
-          <a:bodyPr wrap="square" lIns="109728" rIns="109728">
-            <a:spAutoFit/>
-          </a:bodyPr>
-          <a:lstStyle/>
-          <a:p>
-            <a:pPr>
-              <a:spcAft>
-                <a:spcPts val="1200"/>
-              </a:spcAft>
-              <a:defRPr sz="2200" b="1">
+            <a:ext cx="3215640" cy="960120"/>
+          </a:xfrm>
+          <a:prstGeom prst="rect">
+            <a:avLst/>
+          </a:prstGeom>
+          <a:noFill/>
+        </p:spPr>
+        <p:txBody>
+          <a:bodyPr wrap="square" lIns="109728" rIns="109728">
+            <a:spAutoFit/>
+          </a:bodyPr>
+          <a:lstStyle/>
+          <a:p>
+            <a:pPr>
+              <a:spcAft>
+                <a:spcPts val="1200"/>
+              </a:spcAft>
+              <a:defRPr sz="2100" b="1">
                 <a:solidFill>
                   <a:srgbClr val="037E83"/>
                 </a:solidFill>
@@ -5578,8 +5578,8 @@
         </p:nvSpPr>
         <p:spPr>
           <a:xfrm>
-            <a:off x="731520" y="3063240"/>
-            <a:ext cx="3215640" cy="2194560"/>
+            <a:off x="731520" y="3383280"/>
+            <a:ext cx="3215640" cy="2011680"/>
           </a:xfrm>
           <a:prstGeom prst="rect">
             <a:avLst/>
@@ -5671,24 +5671,24 @@
         <p:spPr>
           <a:xfrm>
             <a:off x="4386072" y="2304288"/>
-            <a:ext cx="3215640" cy="640080"/>
-          </a:xfrm>
-          <a:prstGeom prst="rect">
-            <a:avLst/>
-          </a:prstGeom>
-          <a:noFill/>
-        </p:spPr>
-        <p:txBody>
-          <a:bodyPr wrap="square" lIns="109728" rIns="109728">
-            <a:spAutoFit/>
-          </a:bodyPr>
-          <a:lstStyle/>
-          <a:p>
-            <a:pPr>
-              <a:spcAft>
-                <a:spcPts val="1200"/>
-              </a:spcAft>
-              <a:defRPr sz="2200" b="1">
+            <a:ext cx="3215640" cy="960120"/>
+          </a:xfrm>
+          <a:prstGeom prst="rect">
+            <a:avLst/>
+          </a:prstGeom>
+          <a:noFill/>
+        </p:spPr>
+        <p:txBody>
+          <a:bodyPr wrap="square" lIns="109728" rIns="109728">
+            <a:spAutoFit/>
+          </a:bodyPr>
+          <a:lstStyle/>
+          <a:p>
+            <a:pPr>
+              <a:spcAft>
+                <a:spcPts val="1200"/>
+              </a:spcAft>
+              <a:defRPr sz="2100" b="1">
                 <a:solidFill>
                   <a:srgbClr val="037E83"/>
                 </a:solidFill>
@@ -5709,8 +5709,8 @@
         </p:nvSpPr>
         <p:spPr>
           <a:xfrm>
-            <a:off x="4386072" y="3063240"/>
-            <a:ext cx="3215640" cy="2194560"/>
+            <a:off x="4386072" y="3383280"/>
+            <a:ext cx="3215640" cy="2011680"/>
           </a:xfrm>
           <a:prstGeom prst="rect">
             <a:avLst/>
@@ -5802,24 +5802,24 @@
         <p:spPr>
           <a:xfrm>
             <a:off x="8040624" y="2304288"/>
-            <a:ext cx="3215640" cy="640080"/>
-          </a:xfrm>
-          <a:prstGeom prst="rect">
-            <a:avLst/>
-          </a:prstGeom>
-          <a:noFill/>
-        </p:spPr>
-        <p:txBody>
-          <a:bodyPr wrap="square" lIns="109728" rIns="109728">
-            <a:spAutoFit/>
-          </a:bodyPr>
-          <a:lstStyle/>
-          <a:p>
-            <a:pPr>
-              <a:spcAft>
-                <a:spcPts val="1200"/>
-              </a:spcAft>
-              <a:defRPr sz="2200" b="1">
+            <a:ext cx="3215640" cy="960120"/>
+          </a:xfrm>
+          <a:prstGeom prst="rect">
+            <a:avLst/>
+          </a:prstGeom>
+          <a:noFill/>
+        </p:spPr>
+        <p:txBody>
+          <a:bodyPr wrap="square" lIns="109728" rIns="109728">
+            <a:spAutoFit/>
+          </a:bodyPr>
+          <a:lstStyle/>
+          <a:p>
+            <a:pPr>
+              <a:spcAft>
+                <a:spcPts val="1200"/>
+              </a:spcAft>
+              <a:defRPr sz="2100" b="1">
                 <a:solidFill>
                   <a:srgbClr val="037E83"/>
                 </a:solidFill>
@@ -5840,8 +5840,8 @@
         </p:nvSpPr>
         <p:spPr>
           <a:xfrm>
-            <a:off x="8040624" y="3063240"/>
-            <a:ext cx="3215640" cy="2194560"/>
+            <a:off x="8040624" y="3383280"/>
+            <a:ext cx="3215640" cy="2011680"/>
           </a:xfrm>
           <a:prstGeom prst="rect">
             <a:avLst/>
@@ -5945,7 +5945,7 @@
         <p:spPr>
           <a:xfrm>
             <a:off x="548640" y="868680"/>
-            <a:ext cx="10972800" cy="914400"/>
+            <a:ext cx="10972800" cy="1188720"/>
           </a:xfrm>
           <a:prstGeom prst="rect">
             <a:avLst/>
@@ -6913,7 +6913,7 @@
         <p:spPr>
           <a:xfrm>
             <a:off x="548640" y="868680"/>
-            <a:ext cx="10972800" cy="914400"/>
+            <a:ext cx="10972800" cy="1188720"/>
           </a:xfrm>
           <a:prstGeom prst="rect">
             <a:avLst/>
@@ -7083,24 +7083,24 @@
         <p:spPr>
           <a:xfrm>
             <a:off x="731520" y="2304288"/>
-            <a:ext cx="3215640" cy="640080"/>
-          </a:xfrm>
-          <a:prstGeom prst="rect">
-            <a:avLst/>
-          </a:prstGeom>
-          <a:noFill/>
-        </p:spPr>
-        <p:txBody>
-          <a:bodyPr wrap="square" lIns="109728" rIns="109728">
-            <a:spAutoFit/>
-          </a:bodyPr>
-          <a:lstStyle/>
-          <a:p>
-            <a:pPr>
-              <a:spcAft>
-                <a:spcPts val="1200"/>
-              </a:spcAft>
-              <a:defRPr sz="2200" b="1">
+            <a:ext cx="3215640" cy="960120"/>
+          </a:xfrm>
+          <a:prstGeom prst="rect">
+            <a:avLst/>
+          </a:prstGeom>
+          <a:noFill/>
+        </p:spPr>
+        <p:txBody>
+          <a:bodyPr wrap="square" lIns="109728" rIns="109728">
+            <a:spAutoFit/>
+          </a:bodyPr>
+          <a:lstStyle/>
+          <a:p>
+            <a:pPr>
+              <a:spcAft>
+                <a:spcPts val="1200"/>
+              </a:spcAft>
+              <a:defRPr sz="2100" b="1">
                 <a:solidFill>
                   <a:srgbClr val="037E83"/>
                 </a:solidFill>
@@ -7121,8 +7121,8 @@
         </p:nvSpPr>
         <p:spPr>
           <a:xfrm>
-            <a:off x="731520" y="3063240"/>
-            <a:ext cx="3215640" cy="2194560"/>
+            <a:off x="731520" y="3383280"/>
+            <a:ext cx="3215640" cy="2011680"/>
           </a:xfrm>
           <a:prstGeom prst="rect">
             <a:avLst/>
@@ -7214,24 +7214,24 @@
         <p:spPr>
           <a:xfrm>
             <a:off x="4386072" y="2304288"/>
-            <a:ext cx="3215640" cy="640080"/>
-          </a:xfrm>
-          <a:prstGeom prst="rect">
-            <a:avLst/>
-          </a:prstGeom>
-          <a:noFill/>
-        </p:spPr>
-        <p:txBody>
-          <a:bodyPr wrap="square" lIns="109728" rIns="109728">
-            <a:spAutoFit/>
-          </a:bodyPr>
-          <a:lstStyle/>
-          <a:p>
-            <a:pPr>
-              <a:spcAft>
-                <a:spcPts val="1200"/>
-              </a:spcAft>
-              <a:defRPr sz="2200" b="1">
+            <a:ext cx="3215640" cy="960120"/>
+          </a:xfrm>
+          <a:prstGeom prst="rect">
+            <a:avLst/>
+          </a:prstGeom>
+          <a:noFill/>
+        </p:spPr>
+        <p:txBody>
+          <a:bodyPr wrap="square" lIns="109728" rIns="109728">
+            <a:spAutoFit/>
+          </a:bodyPr>
+          <a:lstStyle/>
+          <a:p>
+            <a:pPr>
+              <a:spcAft>
+                <a:spcPts val="1200"/>
+              </a:spcAft>
+              <a:defRPr sz="2100" b="1">
                 <a:solidFill>
                   <a:srgbClr val="037E83"/>
                 </a:solidFill>
@@ -7252,8 +7252,8 @@
         </p:nvSpPr>
         <p:spPr>
           <a:xfrm>
-            <a:off x="4386072" y="3063240"/>
-            <a:ext cx="3215640" cy="2194560"/>
+            <a:off x="4386072" y="3383280"/>
+            <a:ext cx="3215640" cy="2011680"/>
           </a:xfrm>
           <a:prstGeom prst="rect">
             <a:avLst/>
@@ -7345,24 +7345,24 @@
         <p:spPr>
           <a:xfrm>
             <a:off x="8040624" y="2304288"/>
-            <a:ext cx="3215640" cy="640080"/>
-          </a:xfrm>
-          <a:prstGeom prst="rect">
-            <a:avLst/>
-          </a:prstGeom>
-          <a:noFill/>
-        </p:spPr>
-        <p:txBody>
-          <a:bodyPr wrap="square" lIns="109728" rIns="109728">
-            <a:spAutoFit/>
-          </a:bodyPr>
-          <a:lstStyle/>
-          <a:p>
-            <a:pPr>
-              <a:spcAft>
-                <a:spcPts val="1200"/>
-              </a:spcAft>
-              <a:defRPr sz="2200" b="1">
+            <a:ext cx="3215640" cy="960120"/>
+          </a:xfrm>
+          <a:prstGeom prst="rect">
+            <a:avLst/>
+          </a:prstGeom>
+          <a:noFill/>
+        </p:spPr>
+        <p:txBody>
+          <a:bodyPr wrap="square" lIns="109728" rIns="109728">
+            <a:spAutoFit/>
+          </a:bodyPr>
+          <a:lstStyle/>
+          <a:p>
+            <a:pPr>
+              <a:spcAft>
+                <a:spcPts val="1200"/>
+              </a:spcAft>
+              <a:defRPr sz="2100" b="1">
                 <a:solidFill>
                   <a:srgbClr val="037E83"/>
                 </a:solidFill>
@@ -7383,8 +7383,8 @@
         </p:nvSpPr>
         <p:spPr>
           <a:xfrm>
-            <a:off x="8040624" y="3063240"/>
-            <a:ext cx="3215640" cy="2194560"/>
+            <a:off x="8040624" y="3383280"/>
+            <a:ext cx="3215640" cy="2011680"/>
           </a:xfrm>
           <a:prstGeom prst="rect">
             <a:avLst/>
@@ -7527,7 +7527,7 @@
         <p:spPr>
           <a:xfrm>
             <a:off x="548640" y="868680"/>
-            <a:ext cx="10972800" cy="914400"/>
+            <a:ext cx="10972800" cy="1188720"/>
           </a:xfrm>
           <a:prstGeom prst="rect">
             <a:avLst/>
@@ -7697,24 +7697,24 @@
         <p:spPr>
           <a:xfrm>
             <a:off x="731520" y="2304288"/>
-            <a:ext cx="3215640" cy="640080"/>
-          </a:xfrm>
-          <a:prstGeom prst="rect">
-            <a:avLst/>
-          </a:prstGeom>
-          <a:noFill/>
-        </p:spPr>
-        <p:txBody>
-          <a:bodyPr wrap="square" lIns="109728" rIns="109728">
-            <a:spAutoFit/>
-          </a:bodyPr>
-          <a:lstStyle/>
-          <a:p>
-            <a:pPr>
-              <a:spcAft>
-                <a:spcPts val="1200"/>
-              </a:spcAft>
-              <a:defRPr sz="2200" b="1">
+            <a:ext cx="3215640" cy="960120"/>
+          </a:xfrm>
+          <a:prstGeom prst="rect">
+            <a:avLst/>
+          </a:prstGeom>
+          <a:noFill/>
+        </p:spPr>
+        <p:txBody>
+          <a:bodyPr wrap="square" lIns="109728" rIns="109728">
+            <a:spAutoFit/>
+          </a:bodyPr>
+          <a:lstStyle/>
+          <a:p>
+            <a:pPr>
+              <a:spcAft>
+                <a:spcPts val="1200"/>
+              </a:spcAft>
+              <a:defRPr sz="2100" b="1">
                 <a:solidFill>
                   <a:srgbClr val="037E83"/>
                 </a:solidFill>
@@ -7735,8 +7735,8 @@
         </p:nvSpPr>
         <p:spPr>
           <a:xfrm>
-            <a:off x="731520" y="3063240"/>
-            <a:ext cx="3215640" cy="2194560"/>
+            <a:off x="731520" y="3383280"/>
+            <a:ext cx="3215640" cy="2011680"/>
           </a:xfrm>
           <a:prstGeom prst="rect">
             <a:avLst/>
@@ -7828,24 +7828,24 @@
         <p:spPr>
           <a:xfrm>
             <a:off x="4386072" y="2304288"/>
-            <a:ext cx="3215640" cy="640080"/>
-          </a:xfrm>
-          <a:prstGeom prst="rect">
-            <a:avLst/>
-          </a:prstGeom>
-          <a:noFill/>
-        </p:spPr>
-        <p:txBody>
-          <a:bodyPr wrap="square" lIns="109728" rIns="109728">
-            <a:spAutoFit/>
-          </a:bodyPr>
-          <a:lstStyle/>
-          <a:p>
-            <a:pPr>
-              <a:spcAft>
-                <a:spcPts val="1200"/>
-              </a:spcAft>
-              <a:defRPr sz="2200" b="1">
+            <a:ext cx="3215640" cy="960120"/>
+          </a:xfrm>
+          <a:prstGeom prst="rect">
+            <a:avLst/>
+          </a:prstGeom>
+          <a:noFill/>
+        </p:spPr>
+        <p:txBody>
+          <a:bodyPr wrap="square" lIns="109728" rIns="109728">
+            <a:spAutoFit/>
+          </a:bodyPr>
+          <a:lstStyle/>
+          <a:p>
+            <a:pPr>
+              <a:spcAft>
+                <a:spcPts val="1200"/>
+              </a:spcAft>
+              <a:defRPr sz="2100" b="1">
                 <a:solidFill>
                   <a:srgbClr val="037E83"/>
                 </a:solidFill>
@@ -7866,8 +7866,8 @@
         </p:nvSpPr>
         <p:spPr>
           <a:xfrm>
-            <a:off x="4386072" y="3063240"/>
-            <a:ext cx="3215640" cy="2194560"/>
+            <a:off x="4386072" y="3383280"/>
+            <a:ext cx="3215640" cy="2011680"/>
           </a:xfrm>
           <a:prstGeom prst="rect">
             <a:avLst/>
@@ -7959,24 +7959,24 @@
         <p:spPr>
           <a:xfrm>
             <a:off x="8040624" y="2304288"/>
-            <a:ext cx="3215640" cy="640080"/>
-          </a:xfrm>
-          <a:prstGeom prst="rect">
-            <a:avLst/>
-          </a:prstGeom>
-          <a:noFill/>
-        </p:spPr>
-        <p:txBody>
-          <a:bodyPr wrap="square" lIns="109728" rIns="109728">
-            <a:spAutoFit/>
-          </a:bodyPr>
-          <a:lstStyle/>
-          <a:p>
-            <a:pPr>
-              <a:spcAft>
-                <a:spcPts val="1200"/>
-              </a:spcAft>
-              <a:defRPr sz="2200" b="1">
+            <a:ext cx="3215640" cy="960120"/>
+          </a:xfrm>
+          <a:prstGeom prst="rect">
+            <a:avLst/>
+          </a:prstGeom>
+          <a:noFill/>
+        </p:spPr>
+        <p:txBody>
+          <a:bodyPr wrap="square" lIns="109728" rIns="109728">
+            <a:spAutoFit/>
+          </a:bodyPr>
+          <a:lstStyle/>
+          <a:p>
+            <a:pPr>
+              <a:spcAft>
+                <a:spcPts val="1200"/>
+              </a:spcAft>
+              <a:defRPr sz="2100" b="1">
                 <a:solidFill>
                   <a:srgbClr val="037E83"/>
                 </a:solidFill>
@@ -7997,8 +7997,8 @@
         </p:nvSpPr>
         <p:spPr>
           <a:xfrm>
-            <a:off x="8040624" y="3063240"/>
-            <a:ext cx="3215640" cy="2194560"/>
+            <a:off x="8040624" y="3383280"/>
+            <a:ext cx="3215640" cy="2011680"/>
           </a:xfrm>
           <a:prstGeom prst="rect">
             <a:avLst/>
@@ -8141,7 +8141,7 @@
         <p:spPr>
           <a:xfrm>
             <a:off x="548640" y="868680"/>
-            <a:ext cx="10972800" cy="914400"/>
+            <a:ext cx="10972800" cy="1188720"/>
           </a:xfrm>
           <a:prstGeom prst="rect">
             <a:avLst/>
@@ -8311,24 +8311,24 @@
         <p:spPr>
           <a:xfrm>
             <a:off x="731520" y="2304288"/>
-            <a:ext cx="3215640" cy="640080"/>
-          </a:xfrm>
-          <a:prstGeom prst="rect">
-            <a:avLst/>
-          </a:prstGeom>
-          <a:noFill/>
-        </p:spPr>
-        <p:txBody>
-          <a:bodyPr wrap="square" lIns="109728" rIns="109728">
-            <a:spAutoFit/>
-          </a:bodyPr>
-          <a:lstStyle/>
-          <a:p>
-            <a:pPr>
-              <a:spcAft>
-                <a:spcPts val="1200"/>
-              </a:spcAft>
-              <a:defRPr sz="2200" b="1">
+            <a:ext cx="3215640" cy="960120"/>
+          </a:xfrm>
+          <a:prstGeom prst="rect">
+            <a:avLst/>
+          </a:prstGeom>
+          <a:noFill/>
+        </p:spPr>
+        <p:txBody>
+          <a:bodyPr wrap="square" lIns="109728" rIns="109728">
+            <a:spAutoFit/>
+          </a:bodyPr>
+          <a:lstStyle/>
+          <a:p>
+            <a:pPr>
+              <a:spcAft>
+                <a:spcPts val="1200"/>
+              </a:spcAft>
+              <a:defRPr sz="2100" b="1">
                 <a:solidFill>
                   <a:srgbClr val="037E83"/>
                 </a:solidFill>
@@ -8349,8 +8349,8 @@
         </p:nvSpPr>
         <p:spPr>
           <a:xfrm>
-            <a:off x="731520" y="3063240"/>
-            <a:ext cx="3215640" cy="2194560"/>
+            <a:off x="731520" y="3383280"/>
+            <a:ext cx="3215640" cy="2011680"/>
           </a:xfrm>
           <a:prstGeom prst="rect">
             <a:avLst/>
@@ -8442,24 +8442,24 @@
         <p:spPr>
           <a:xfrm>
             <a:off x="4386072" y="2304288"/>
-            <a:ext cx="3215640" cy="640080"/>
-          </a:xfrm>
-          <a:prstGeom prst="rect">
-            <a:avLst/>
-          </a:prstGeom>
-          <a:noFill/>
-        </p:spPr>
-        <p:txBody>
-          <a:bodyPr wrap="square" lIns="109728" rIns="109728">
-            <a:spAutoFit/>
-          </a:bodyPr>
-          <a:lstStyle/>
-          <a:p>
-            <a:pPr>
-              <a:spcAft>
-                <a:spcPts val="1200"/>
-              </a:spcAft>
-              <a:defRPr sz="2200" b="1">
+            <a:ext cx="3215640" cy="960120"/>
+          </a:xfrm>
+          <a:prstGeom prst="rect">
+            <a:avLst/>
+          </a:prstGeom>
+          <a:noFill/>
+        </p:spPr>
+        <p:txBody>
+          <a:bodyPr wrap="square" lIns="109728" rIns="109728">
+            <a:spAutoFit/>
+          </a:bodyPr>
+          <a:lstStyle/>
+          <a:p>
+            <a:pPr>
+              <a:spcAft>
+                <a:spcPts val="1200"/>
+              </a:spcAft>
+              <a:defRPr sz="2100" b="1">
                 <a:solidFill>
                   <a:srgbClr val="037E83"/>
                 </a:solidFill>
@@ -8480,8 +8480,8 @@
         </p:nvSpPr>
         <p:spPr>
           <a:xfrm>
-            <a:off x="4386072" y="3063240"/>
-            <a:ext cx="3215640" cy="2194560"/>
+            <a:off x="4386072" y="3383280"/>
+            <a:ext cx="3215640" cy="2011680"/>
           </a:xfrm>
           <a:prstGeom prst="rect">
             <a:avLst/>
@@ -8573,24 +8573,24 @@
         <p:spPr>
           <a:xfrm>
             <a:off x="8040624" y="2304288"/>
-            <a:ext cx="3215640" cy="640080"/>
-          </a:xfrm>
-          <a:prstGeom prst="rect">
-            <a:avLst/>
-          </a:prstGeom>
-          <a:noFill/>
-        </p:spPr>
-        <p:txBody>
-          <a:bodyPr wrap="square" lIns="109728" rIns="109728">
-            <a:spAutoFit/>
-          </a:bodyPr>
-          <a:lstStyle/>
-          <a:p>
-            <a:pPr>
-              <a:spcAft>
-                <a:spcPts val="1200"/>
-              </a:spcAft>
-              <a:defRPr sz="2200" b="1">
+            <a:ext cx="3215640" cy="960120"/>
+          </a:xfrm>
+          <a:prstGeom prst="rect">
+            <a:avLst/>
+          </a:prstGeom>
+          <a:noFill/>
+        </p:spPr>
+        <p:txBody>
+          <a:bodyPr wrap="square" lIns="109728" rIns="109728">
+            <a:spAutoFit/>
+          </a:bodyPr>
+          <a:lstStyle/>
+          <a:p>
+            <a:pPr>
+              <a:spcAft>
+                <a:spcPts val="1200"/>
+              </a:spcAft>
+              <a:defRPr sz="2100" b="1">
                 <a:solidFill>
                   <a:srgbClr val="037E83"/>
                 </a:solidFill>
@@ -8611,8 +8611,8 @@
         </p:nvSpPr>
         <p:spPr>
           <a:xfrm>
-            <a:off x="8040624" y="3063240"/>
-            <a:ext cx="3215640" cy="2194560"/>
+            <a:off x="8040624" y="3383280"/>
+            <a:ext cx="3215640" cy="2011680"/>
           </a:xfrm>
           <a:prstGeom prst="rect">
             <a:avLst/>
@@ -8716,7 +8716,7 @@
         <p:spPr>
           <a:xfrm>
             <a:off x="548640" y="868680"/>
-            <a:ext cx="10972800" cy="914400"/>
+            <a:ext cx="10972800" cy="1188720"/>
           </a:xfrm>
           <a:prstGeom prst="rect">
             <a:avLst/>
@@ -8886,24 +8886,24 @@
         <p:spPr>
           <a:xfrm>
             <a:off x="731520" y="2304288"/>
-            <a:ext cx="3215640" cy="640080"/>
-          </a:xfrm>
-          <a:prstGeom prst="rect">
-            <a:avLst/>
-          </a:prstGeom>
-          <a:noFill/>
-        </p:spPr>
-        <p:txBody>
-          <a:bodyPr wrap="square" lIns="109728" rIns="109728">
-            <a:spAutoFit/>
-          </a:bodyPr>
-          <a:lstStyle/>
-          <a:p>
-            <a:pPr>
-              <a:spcAft>
-                <a:spcPts val="1200"/>
-              </a:spcAft>
-              <a:defRPr sz="2200" b="1">
+            <a:ext cx="3215640" cy="960120"/>
+          </a:xfrm>
+          <a:prstGeom prst="rect">
+            <a:avLst/>
+          </a:prstGeom>
+          <a:noFill/>
+        </p:spPr>
+        <p:txBody>
+          <a:bodyPr wrap="square" lIns="109728" rIns="109728">
+            <a:spAutoFit/>
+          </a:bodyPr>
+          <a:lstStyle/>
+          <a:p>
+            <a:pPr>
+              <a:spcAft>
+                <a:spcPts val="1200"/>
+              </a:spcAft>
+              <a:defRPr sz="2100" b="1">
                 <a:solidFill>
                   <a:srgbClr val="037E83"/>
                 </a:solidFill>
@@ -8924,8 +8924,8 @@
         </p:nvSpPr>
         <p:spPr>
           <a:xfrm>
-            <a:off x="731520" y="3063240"/>
-            <a:ext cx="3215640" cy="2194560"/>
+            <a:off x="731520" y="3383280"/>
+            <a:ext cx="3215640" cy="2011680"/>
           </a:xfrm>
           <a:prstGeom prst="rect">
             <a:avLst/>
@@ -9017,24 +9017,24 @@
         <p:spPr>
           <a:xfrm>
             <a:off x="4386072" y="2304288"/>
-            <a:ext cx="3215640" cy="640080"/>
-          </a:xfrm>
-          <a:prstGeom prst="rect">
-            <a:avLst/>
-          </a:prstGeom>
-          <a:noFill/>
-        </p:spPr>
-        <p:txBody>
-          <a:bodyPr wrap="square" lIns="109728" rIns="109728">
-            <a:spAutoFit/>
-          </a:bodyPr>
-          <a:lstStyle/>
-          <a:p>
-            <a:pPr>
-              <a:spcAft>
-                <a:spcPts val="1200"/>
-              </a:spcAft>
-              <a:defRPr sz="2200" b="1">
+            <a:ext cx="3215640" cy="960120"/>
+          </a:xfrm>
+          <a:prstGeom prst="rect">
+            <a:avLst/>
+          </a:prstGeom>
+          <a:noFill/>
+        </p:spPr>
+        <p:txBody>
+          <a:bodyPr wrap="square" lIns="109728" rIns="109728">
+            <a:spAutoFit/>
+          </a:bodyPr>
+          <a:lstStyle/>
+          <a:p>
+            <a:pPr>
+              <a:spcAft>
+                <a:spcPts val="1200"/>
+              </a:spcAft>
+              <a:defRPr sz="2100" b="1">
                 <a:solidFill>
                   <a:srgbClr val="037E83"/>
                 </a:solidFill>
@@ -9055,8 +9055,8 @@
         </p:nvSpPr>
         <p:spPr>
           <a:xfrm>
-            <a:off x="4386072" y="3063240"/>
-            <a:ext cx="3215640" cy="2194560"/>
+            <a:off x="4386072" y="3383280"/>
+            <a:ext cx="3215640" cy="2011680"/>
           </a:xfrm>
           <a:prstGeom prst="rect">
             <a:avLst/>
@@ -9148,24 +9148,24 @@
         <p:spPr>
           <a:xfrm>
             <a:off x="8040624" y="2304288"/>
-            <a:ext cx="3215640" cy="640080"/>
-          </a:xfrm>
-          <a:prstGeom prst="rect">
-            <a:avLst/>
-          </a:prstGeom>
-          <a:noFill/>
-        </p:spPr>
-        <p:txBody>
-          <a:bodyPr wrap="square" lIns="109728" rIns="109728">
-            <a:spAutoFit/>
-          </a:bodyPr>
-          <a:lstStyle/>
-          <a:p>
-            <a:pPr>
-              <a:spcAft>
-                <a:spcPts val="1200"/>
-              </a:spcAft>
-              <a:defRPr sz="2200" b="1">
+            <a:ext cx="3215640" cy="960120"/>
+          </a:xfrm>
+          <a:prstGeom prst="rect">
+            <a:avLst/>
+          </a:prstGeom>
+          <a:noFill/>
+        </p:spPr>
+        <p:txBody>
+          <a:bodyPr wrap="square" lIns="109728" rIns="109728">
+            <a:spAutoFit/>
+          </a:bodyPr>
+          <a:lstStyle/>
+          <a:p>
+            <a:pPr>
+              <a:spcAft>
+                <a:spcPts val="1200"/>
+              </a:spcAft>
+              <a:defRPr sz="2100" b="1">
                 <a:solidFill>
                   <a:srgbClr val="037E83"/>
                 </a:solidFill>
@@ -9186,8 +9186,8 @@
         </p:nvSpPr>
         <p:spPr>
           <a:xfrm>
-            <a:off x="8040624" y="3063240"/>
-            <a:ext cx="3215640" cy="2194560"/>
+            <a:off x="8040624" y="3383280"/>
+            <a:ext cx="3215640" cy="2011680"/>
           </a:xfrm>
           <a:prstGeom prst="rect">
             <a:avLst/>
@@ -9330,7 +9330,7 @@
         <p:spPr>
           <a:xfrm>
             <a:off x="548640" y="868680"/>
-            <a:ext cx="10972800" cy="914400"/>
+            <a:ext cx="10972800" cy="1188720"/>
           </a:xfrm>
           <a:prstGeom prst="rect">
             <a:avLst/>
@@ -9500,24 +9500,24 @@
         <p:spPr>
           <a:xfrm>
             <a:off x="731520" y="2304288"/>
-            <a:ext cx="3215640" cy="640080"/>
-          </a:xfrm>
-          <a:prstGeom prst="rect">
-            <a:avLst/>
-          </a:prstGeom>
-          <a:noFill/>
-        </p:spPr>
-        <p:txBody>
-          <a:bodyPr wrap="square" lIns="109728" rIns="109728">
-            <a:spAutoFit/>
-          </a:bodyPr>
-          <a:lstStyle/>
-          <a:p>
-            <a:pPr>
-              <a:spcAft>
-                <a:spcPts val="1200"/>
-              </a:spcAft>
-              <a:defRPr sz="2200" b="1">
+            <a:ext cx="3215640" cy="960120"/>
+          </a:xfrm>
+          <a:prstGeom prst="rect">
+            <a:avLst/>
+          </a:prstGeom>
+          <a:noFill/>
+        </p:spPr>
+        <p:txBody>
+          <a:bodyPr wrap="square" lIns="109728" rIns="109728">
+            <a:spAutoFit/>
+          </a:bodyPr>
+          <a:lstStyle/>
+          <a:p>
+            <a:pPr>
+              <a:spcAft>
+                <a:spcPts val="1200"/>
+              </a:spcAft>
+              <a:defRPr sz="2100" b="1">
                 <a:solidFill>
                   <a:srgbClr val="037E83"/>
                 </a:solidFill>
@@ -9538,8 +9538,8 @@
         </p:nvSpPr>
         <p:spPr>
           <a:xfrm>
-            <a:off x="731520" y="3063240"/>
-            <a:ext cx="3215640" cy="2194560"/>
+            <a:off x="731520" y="3383280"/>
+            <a:ext cx="3215640" cy="2011680"/>
           </a:xfrm>
           <a:prstGeom prst="rect">
             <a:avLst/>
@@ -9631,24 +9631,24 @@
         <p:spPr>
           <a:xfrm>
             <a:off x="4386072" y="2304288"/>
-            <a:ext cx="3215640" cy="640080"/>
-          </a:xfrm>
-          <a:prstGeom prst="rect">
-            <a:avLst/>
-          </a:prstGeom>
-          <a:noFill/>
-        </p:spPr>
-        <p:txBody>
-          <a:bodyPr wrap="square" lIns="109728" rIns="109728">
-            <a:spAutoFit/>
-          </a:bodyPr>
-          <a:lstStyle/>
-          <a:p>
-            <a:pPr>
-              <a:spcAft>
-                <a:spcPts val="1200"/>
-              </a:spcAft>
-              <a:defRPr sz="2200" b="1">
+            <a:ext cx="3215640" cy="960120"/>
+          </a:xfrm>
+          <a:prstGeom prst="rect">
+            <a:avLst/>
+          </a:prstGeom>
+          <a:noFill/>
+        </p:spPr>
+        <p:txBody>
+          <a:bodyPr wrap="square" lIns="109728" rIns="109728">
+            <a:spAutoFit/>
+          </a:bodyPr>
+          <a:lstStyle/>
+          <a:p>
+            <a:pPr>
+              <a:spcAft>
+                <a:spcPts val="1200"/>
+              </a:spcAft>
+              <a:defRPr sz="2100" b="1">
                 <a:solidFill>
                   <a:srgbClr val="037E83"/>
                 </a:solidFill>
@@ -9669,8 +9669,8 @@
         </p:nvSpPr>
         <p:spPr>
           <a:xfrm>
-            <a:off x="4386072" y="3063240"/>
-            <a:ext cx="3215640" cy="2194560"/>
+            <a:off x="4386072" y="3383280"/>
+            <a:ext cx="3215640" cy="2011680"/>
           </a:xfrm>
           <a:prstGeom prst="rect">
             <a:avLst/>
@@ -9762,24 +9762,24 @@
         <p:spPr>
           <a:xfrm>
             <a:off x="8040624" y="2304288"/>
-            <a:ext cx="3215640" cy="640080"/>
-          </a:xfrm>
-          <a:prstGeom prst="rect">
-            <a:avLst/>
-          </a:prstGeom>
-          <a:noFill/>
-        </p:spPr>
-        <p:txBody>
-          <a:bodyPr wrap="square" lIns="109728" rIns="109728">
-            <a:spAutoFit/>
-          </a:bodyPr>
-          <a:lstStyle/>
-          <a:p>
-            <a:pPr>
-              <a:spcAft>
-                <a:spcPts val="1200"/>
-              </a:spcAft>
-              <a:defRPr sz="2200" b="1">
+            <a:ext cx="3215640" cy="960120"/>
+          </a:xfrm>
+          <a:prstGeom prst="rect">
+            <a:avLst/>
+          </a:prstGeom>
+          <a:noFill/>
+        </p:spPr>
+        <p:txBody>
+          <a:bodyPr wrap="square" lIns="109728" rIns="109728">
+            <a:spAutoFit/>
+          </a:bodyPr>
+          <a:lstStyle/>
+          <a:p>
+            <a:pPr>
+              <a:spcAft>
+                <a:spcPts val="1200"/>
+              </a:spcAft>
+              <a:defRPr sz="2100" b="1">
                 <a:solidFill>
                   <a:srgbClr val="037E83"/>
                 </a:solidFill>
@@ -9800,8 +9800,8 @@
         </p:nvSpPr>
         <p:spPr>
           <a:xfrm>
-            <a:off x="8040624" y="3063240"/>
-            <a:ext cx="3215640" cy="2194560"/>
+            <a:off x="8040624" y="3383280"/>
+            <a:ext cx="3215640" cy="2011680"/>
           </a:xfrm>
           <a:prstGeom prst="rect">
             <a:avLst/>
@@ -9944,7 +9944,7 @@
         <p:spPr>
           <a:xfrm>
             <a:off x="548640" y="868680"/>
-            <a:ext cx="10972800" cy="914400"/>
+            <a:ext cx="10972800" cy="1188720"/>
           </a:xfrm>
           <a:prstGeom prst="rect">
             <a:avLst/>
@@ -10114,24 +10114,24 @@
         <p:spPr>
           <a:xfrm>
             <a:off x="731520" y="2304288"/>
-            <a:ext cx="3215640" cy="640080"/>
-          </a:xfrm>
-          <a:prstGeom prst="rect">
-            <a:avLst/>
-          </a:prstGeom>
-          <a:noFill/>
-        </p:spPr>
-        <p:txBody>
-          <a:bodyPr wrap="square" lIns="109728" rIns="109728">
-            <a:spAutoFit/>
-          </a:bodyPr>
-          <a:lstStyle/>
-          <a:p>
-            <a:pPr>
-              <a:spcAft>
-                <a:spcPts val="1200"/>
-              </a:spcAft>
-              <a:defRPr sz="2200" b="1">
+            <a:ext cx="3215640" cy="960120"/>
+          </a:xfrm>
+          <a:prstGeom prst="rect">
+            <a:avLst/>
+          </a:prstGeom>
+          <a:noFill/>
+        </p:spPr>
+        <p:txBody>
+          <a:bodyPr wrap="square" lIns="109728" rIns="109728">
+            <a:spAutoFit/>
+          </a:bodyPr>
+          <a:lstStyle/>
+          <a:p>
+            <a:pPr>
+              <a:spcAft>
+                <a:spcPts val="1200"/>
+              </a:spcAft>
+              <a:defRPr sz="2100" b="1">
                 <a:solidFill>
                   <a:srgbClr val="037E83"/>
                 </a:solidFill>
@@ -10152,8 +10152,8 @@
         </p:nvSpPr>
         <p:spPr>
           <a:xfrm>
-            <a:off x="731520" y="3063240"/>
-            <a:ext cx="3215640" cy="2194560"/>
+            <a:off x="731520" y="3383280"/>
+            <a:ext cx="3215640" cy="2011680"/>
           </a:xfrm>
           <a:prstGeom prst="rect">
             <a:avLst/>
@@ -10245,24 +10245,24 @@
         <p:spPr>
           <a:xfrm>
             <a:off x="4386072" y="2304288"/>
-            <a:ext cx="3215640" cy="640080"/>
-          </a:xfrm>
-          <a:prstGeom prst="rect">
-            <a:avLst/>
-          </a:prstGeom>
-          <a:noFill/>
-        </p:spPr>
-        <p:txBody>
-          <a:bodyPr wrap="square" lIns="109728" rIns="109728">
-            <a:spAutoFit/>
-          </a:bodyPr>
-          <a:lstStyle/>
-          <a:p>
-            <a:pPr>
-              <a:spcAft>
-                <a:spcPts val="1200"/>
-              </a:spcAft>
-              <a:defRPr sz="2200" b="1">
+            <a:ext cx="3215640" cy="960120"/>
+          </a:xfrm>
+          <a:prstGeom prst="rect">
+            <a:avLst/>
+          </a:prstGeom>
+          <a:noFill/>
+        </p:spPr>
+        <p:txBody>
+          <a:bodyPr wrap="square" lIns="109728" rIns="109728">
+            <a:spAutoFit/>
+          </a:bodyPr>
+          <a:lstStyle/>
+          <a:p>
+            <a:pPr>
+              <a:spcAft>
+                <a:spcPts val="1200"/>
+              </a:spcAft>
+              <a:defRPr sz="2100" b="1">
                 <a:solidFill>
                   <a:srgbClr val="037E83"/>
                 </a:solidFill>
@@ -10283,8 +10283,8 @@
         </p:nvSpPr>
         <p:spPr>
           <a:xfrm>
-            <a:off x="4386072" y="3063240"/>
-            <a:ext cx="3215640" cy="2194560"/>
+            <a:off x="4386072" y="3383280"/>
+            <a:ext cx="3215640" cy="2011680"/>
           </a:xfrm>
           <a:prstGeom prst="rect">
             <a:avLst/>
@@ -10376,24 +10376,24 @@
         <p:spPr>
           <a:xfrm>
             <a:off x="8040624" y="2304288"/>
-            <a:ext cx="3215640" cy="640080"/>
-          </a:xfrm>
-          <a:prstGeom prst="rect">
-            <a:avLst/>
-          </a:prstGeom>
-          <a:noFill/>
-        </p:spPr>
-        <p:txBody>
-          <a:bodyPr wrap="square" lIns="109728" rIns="109728">
-            <a:spAutoFit/>
-          </a:bodyPr>
-          <a:lstStyle/>
-          <a:p>
-            <a:pPr>
-              <a:spcAft>
-                <a:spcPts val="1200"/>
-              </a:spcAft>
-              <a:defRPr sz="2200" b="1">
+            <a:ext cx="3215640" cy="960120"/>
+          </a:xfrm>
+          <a:prstGeom prst="rect">
+            <a:avLst/>
+          </a:prstGeom>
+          <a:noFill/>
+        </p:spPr>
+        <p:txBody>
+          <a:bodyPr wrap="square" lIns="109728" rIns="109728">
+            <a:spAutoFit/>
+          </a:bodyPr>
+          <a:lstStyle/>
+          <a:p>
+            <a:pPr>
+              <a:spcAft>
+                <a:spcPts val="1200"/>
+              </a:spcAft>
+              <a:defRPr sz="2100" b="1">
                 <a:solidFill>
                   <a:srgbClr val="037E83"/>
                 </a:solidFill>
@@ -10414,8 +10414,8 @@
         </p:nvSpPr>
         <p:spPr>
           <a:xfrm>
-            <a:off x="8040624" y="3063240"/>
-            <a:ext cx="3215640" cy="2194560"/>
+            <a:off x="8040624" y="3383280"/>
+            <a:ext cx="3215640" cy="2011680"/>
           </a:xfrm>
           <a:prstGeom prst="rect">
             <a:avLst/>

</xml_diff>

<commit_message>
Add name-based reference discovery, manual workbook drafts and clearer extraction review
</commit_message>
<xml_diff>
--- a/docs/delivery/Invoice_Studio_SLT.pptx
+++ b/docs/delivery/Invoice_Studio_SLT.pptx
@@ -17,6 +17,8 @@
     <p:sldId id="265" r:id="rId16"/>
     <p:sldId id="266" r:id="rId17"/>
     <p:sldId id="267" r:id="rId18"/>
+    <p:sldId id="268" r:id="rId19"/>
+    <p:sldId id="269" r:id="rId20"/>
   </p:sldIdLst>
   <p:sldSz cx="12191695" cy="6858000" type="screen4x3"/>
   <p:notesSz cx="6858000" cy="9144000"/>
@@ -3440,7 +3442,7 @@
               </a:defRPr>
             </a:pPr>
             <a:r>
-              <a:t>Local portal verified with synthetic invoices. Real-data acceptance and cloud access are separate gates.</a:t>
+              <a:t>Hosted baseline verified with synthetic invoices. Current source additions await integrated validation and deployment.</a:t>
             </a:r>
           </a:p>
         </p:txBody>
@@ -3544,7 +3546,7 @@
               </a:defRPr>
             </a:pPr>
             <a:r>
-              <a:t>A staged build plan with clear exits</a:t>
+              <a:t>Owner subscription paths keep a hard boundary</a:t>
             </a:r>
           </a:p>
         </p:txBody>
@@ -3714,23 +3716,7 @@
               </a:defRPr>
             </a:pPr>
             <a:r>
-              <a:t>Data contract</a:t>
-            </a:r>
-          </a:p>
-          <a:p>
-            <a:pPr>
-              <a:spcAft>
-                <a:spcPts val="1200"/>
-              </a:spcAft>
-              <a:defRPr sz="2100" b="1">
-                <a:solidFill>
-                  <a:srgbClr val="037E83"/>
-                </a:solidFill>
-                <a:latin typeface="Aptos"/>
-              </a:defRPr>
-            </a:pPr>
-            <a:r>
-              <a:t>1–2 weeks</a:t>
+              <a:t>Claude setup token</a:t>
             </a:r>
           </a:p>
         </p:txBody>
@@ -3769,7 +3755,7 @@
               </a:defRPr>
             </a:pPr>
             <a:r>
-              <a:t>Approve mappings and missing values. Accept the target workbook with the receiving team.</a:t>
+              <a:t>Encrypted on the server and provided only to a restricted hosted CLI invocation with tools disabled.</a:t>
             </a:r>
           </a:p>
         </p:txBody>
@@ -3861,23 +3847,7 @@
               </a:defRPr>
             </a:pPr>
             <a:r>
-              <a:t>Supplier evaluation</a:t>
-            </a:r>
-          </a:p>
-          <a:p>
-            <a:pPr>
-              <a:spcAft>
-                <a:spcPts val="1200"/>
-              </a:spcAft>
-              <a:defRPr sz="2100" b="1">
-                <a:solidFill>
-                  <a:srgbClr val="037E83"/>
-                </a:solidFill>
-                <a:latin typeface="Aptos"/>
-              </a:defRPr>
-            </a:pPr>
-            <a:r>
-              <a:t>2–3 weeks</a:t>
+              <a:t>ChatGPT move</a:t>
             </a:r>
           </a:p>
         </p:txBody>
@@ -3916,7 +3886,7 @@
               </a:defRPr>
             </a:pPr>
             <a:r>
-              <a:t>Evaluate at least 100 representative invoices and the difficult exception cases.</a:t>
+              <a:t>Local OAuth uses the application registration. Export deletes local credentials and clears the active account.</a:t>
             </a:r>
           </a:p>
         </p:txBody>
@@ -4008,23 +3978,7 @@
               </a:defRPr>
             </a:pPr>
             <a:r>
-              <a:t>Production pilot</a:t>
-            </a:r>
-          </a:p>
-          <a:p>
-            <a:pPr>
-              <a:spcAft>
-                <a:spcPts val="1200"/>
-              </a:spcAft>
-              <a:defRPr sz="2100" b="1">
-                <a:solidFill>
-                  <a:srgbClr val="037E83"/>
-                </a:solidFill>
-                <a:latin typeface="Aptos"/>
-              </a:defRPr>
-            </a:pPr>
-            <a:r>
-              <a:t>3–5 weeks</a:t>
+              <a:t>Hosted owner import</a:t>
             </a:r>
           </a:p>
         </p:txBody>
@@ -4063,7 +4017,7 @@
               </a:defRPr>
             </a:pPr>
             <a:r>
-              <a:t>Complete identity, operations, backup/recovery, monitoring and controlled UAT.</a:t>
+              <a:t>Authenticated import verifies and encrypts the one-time bundle. Protect it, import promptly, then delete it.</a:t>
             </a:r>
           </a:p>
         </p:txBody>
@@ -4102,7 +4056,7 @@
               </a:defRPr>
             </a:pPr>
             <a:r>
-              <a:t>Planning ranges assume available AP/data owners and a deliberately bounded initial invoice contract.</a:t>
+              <a:t>No automated result proves subscription eligibility, model access or live inference quality.</a:t>
             </a:r>
           </a:p>
         </p:txBody>
@@ -4206,7 +4160,7 @@
               </a:defRPr>
             </a:pPr>
             <a:r>
-              <a:t>Extend the platform after invoice proof</a:t>
+              <a:t>Show evidence before claiming automation</a:t>
             </a:r>
           </a:p>
         </p:txBody>
@@ -4376,7 +4330,7 @@
               </a:defRPr>
             </a:pPr>
             <a:r>
-              <a:t>New store or market</a:t>
+              <a:t>Release validation</a:t>
             </a:r>
           </a:p>
         </p:txBody>
@@ -4415,7 +4369,7 @@
               </a:defRPr>
             </a:pPr>
             <a:r>
-              <a:t>Search approved coverage; create supplier discovery and qualification cases only for gaps.</a:t>
+              <a:t>101 backend tests and real local PostgreSQL pass; Ruff clean; three-reader container warm passed. Browser, publish, catalog and hosted smoke pending.</a:t>
             </a:r>
           </a:p>
         </p:txBody>
@@ -4507,7 +4461,7 @@
               </a:defRPr>
             </a:pPr>
             <a:r>
-              <a:t>Supplier item intake</a:t>
+              <a:t>Pilot next</a:t>
             </a:r>
           </a:p>
         </p:txBody>
@@ -4546,7 +4500,7 @@
               </a:defRPr>
             </a:pPr>
             <a:r>
-              <a:t>Normalize item identity, codes, packaging and units. Route ambiguity to a data steward.</a:t>
+              <a:t>Representative supplier formats and languages. Independently adjudicated fields, lines and receipt balances.</a:t>
             </a:r>
           </a:p>
         </p:txBody>
@@ -4638,7 +4592,7 @@
               </a:defRPr>
             </a:pPr>
             <a:r>
-              <a:t>Digital channels</a:t>
+              <a:t>Measure value</a:t>
             </a:r>
           </a:p>
         </p:txBody>
@@ -4677,7 +4631,7 @@
               </a:defRPr>
             </a:pPr>
             <a:r>
-              <a:t>Maintain versioned content, images, translations and channel rules separately from purchasing identity.</a:t>
+              <a:t>Minutes saved per invoice, correction count, false-ready rate, fallback share, latency and provider cost.</a:t>
             </a:r>
           </a:p>
         </p:txBody>
@@ -4781,7 +4735,7 @@
               </a:defRPr>
             </a:pPr>
             <a:r>
-              <a:t>The next business decisions</a:t>
+              <a:t>A staged build plan with clear exits</a:t>
             </a:r>
           </a:p>
         </p:txBody>
@@ -4951,7 +4905,23 @@
               </a:defRPr>
             </a:pPr>
             <a:r>
-              <a:t>Name the owners</a:t>
+              <a:t>Data contract</a:t>
+            </a:r>
+          </a:p>
+          <a:p>
+            <a:pPr>
+              <a:spcAft>
+                <a:spcPts val="1200"/>
+              </a:spcAft>
+              <a:defRPr sz="2100" b="1">
+                <a:solidFill>
+                  <a:srgbClr val="037E83"/>
+                </a:solidFill>
+                <a:latin typeface="Aptos"/>
+              </a:defRPr>
+            </a:pPr>
+            <a:r>
+              <a:t>1–2 weeks</a:t>
             </a:r>
           </a:p>
         </p:txBody>
@@ -4990,7 +4960,7 @@
               </a:defRPr>
             </a:pPr>
             <a:r>
-              <a:t>AP process owner, reference steward, receiving owner and finance/tax approver.</a:t>
+              <a:t>Approve mappings and missing values. Accept the target workbook with the receiving team.</a:t>
             </a:r>
           </a:p>
         </p:txBody>
@@ -5082,7 +5052,23 @@
               </a:defRPr>
             </a:pPr>
             <a:r>
-              <a:t>Accept the evidence</a:t>
+              <a:t>Supplier evaluation</a:t>
+            </a:r>
+          </a:p>
+          <a:p>
+            <a:pPr>
+              <a:spcAft>
+                <a:spcPts val="1200"/>
+              </a:spcAft>
+              <a:defRPr sz="2100" b="1">
+                <a:solidFill>
+                  <a:srgbClr val="037E83"/>
+                </a:solidFill>
+                <a:latin typeface="Aptos"/>
+              </a:defRPr>
+            </a:pPr>
+            <a:r>
+              <a:t>2–3 weeks</a:t>
             </a:r>
           </a:p>
         </p:txBody>
@@ -5121,7 +5107,7 @@
               </a:defRPr>
             </a:pPr>
             <a:r>
-              <a:t>Confirm receipt status meaning, invoice baseline, route scope and the initial supplier test set.</a:t>
+              <a:t>Evaluate at least 100 representative invoices and the difficult exception cases.</a:t>
             </a:r>
           </a:p>
         </p:txBody>
@@ -5213,7 +5199,23 @@
               </a:defRPr>
             </a:pPr>
             <a:r>
-              <a:t>Authorize the rollout</a:t>
+              <a:t>Production pilot</a:t>
+            </a:r>
+          </a:p>
+          <a:p>
+            <a:pPr>
+              <a:spcAft>
+                <a:spcPts val="1200"/>
+              </a:spcAft>
+              <a:defRPr sz="2100" b="1">
+                <a:solidFill>
+                  <a:srgbClr val="037E83"/>
+                </a:solidFill>
+                <a:latin typeface="Aptos"/>
+              </a:defRPr>
+            </a:pPr>
+            <a:r>
+              <a:t>3–5 weeks</a:t>
             </a:r>
           </a:p>
         </p:txBody>
@@ -5252,7 +5254,7 @@
               </a:defRPr>
             </a:pPr>
             <a:r>
-              <a:t>Set approved users, provider choices and budget; sign off downstream workbook compatibility.</a:t>
+              <a:t>Add role separation, durable workers, backup restoration, monitoring and controlled UAT.</a:t>
             </a:r>
           </a:p>
         </p:txBody>
@@ -5291,7 +5293,1196 @@
               </a:defRPr>
             </a:pPr>
             <a:r>
-              <a:t>Twelve acceptance-driven implementation stories accompany the design and operator guide.</a:t>
+              <a:t>Planning ranges assume available AP/data owners and a deliberately bounded initial invoice contract.</a:t>
+            </a:r>
+          </a:p>
+        </p:txBody>
+      </p:sp>
+    </p:spTree>
+  </p:cSld>
+  <p:clrMapOvr>
+    <a:masterClrMapping/>
+  </p:clrMapOvr>
+</p:sld>
+</file>
+
+<file path=ppt/slides/slide13.xml><?xml version="1.0" encoding="utf-8"?>
+<p:sld xmlns:a="http://schemas.openxmlformats.org/drawingml/2006/main" xmlns:p="http://schemas.openxmlformats.org/presentationml/2006/main" xmlns:r="http://schemas.openxmlformats.org/officeDocument/2006/relationships">
+  <p:cSld>
+    <p:bg>
+      <p:bgPr>
+        <a:solidFill>
+          <a:srgbClr val="F3F7F7"/>
+        </a:solidFill>
+        <a:effectLst/>
+      </p:bgPr>
+    </p:bg>
+    <p:spTree>
+      <p:nvGrpSpPr>
+        <p:cNvPr id="1" name=""/>
+        <p:cNvGrpSpPr/>
+        <p:nvPr/>
+      </p:nvGrpSpPr>
+      <p:grpSpPr/>
+      <p:sp>
+        <p:nvSpPr>
+          <p:cNvPr id="2" name="TextBox 1"/>
+          <p:cNvSpPr txBox="1"/>
+          <p:nvPr/>
+        </p:nvSpPr>
+        <p:spPr>
+          <a:xfrm>
+            <a:off x="548640" y="274320"/>
+            <a:ext cx="10972800" cy="274320"/>
+          </a:xfrm>
+          <a:prstGeom prst="rect">
+            <a:avLst/>
+          </a:prstGeom>
+          <a:noFill/>
+        </p:spPr>
+        <p:txBody>
+          <a:bodyPr wrap="square" lIns="109728" rIns="109728">
+            <a:spAutoFit/>
+          </a:bodyPr>
+          <a:lstStyle/>
+          <a:p>
+            <a:pPr>
+              <a:spcAft>
+                <a:spcPts val="1200"/>
+              </a:spcAft>
+              <a:defRPr sz="1100" b="1">
+                <a:solidFill>
+                  <a:srgbClr val="037E83"/>
+                </a:solidFill>
+                <a:latin typeface="Aptos"/>
+              </a:defRPr>
+            </a:pPr>
+            <a:r>
+              <a:t>INVOICE STUDIO / DECISION PACK</a:t>
+            </a:r>
+          </a:p>
+        </p:txBody>
+      </p:sp>
+      <p:sp>
+        <p:nvSpPr>
+          <p:cNvPr id="3" name="TextBox 2"/>
+          <p:cNvSpPr txBox="1"/>
+          <p:nvPr/>
+        </p:nvSpPr>
+        <p:spPr>
+          <a:xfrm>
+            <a:off x="548640" y="868680"/>
+            <a:ext cx="10972800" cy="1188720"/>
+          </a:xfrm>
+          <a:prstGeom prst="rect">
+            <a:avLst/>
+          </a:prstGeom>
+          <a:noFill/>
+        </p:spPr>
+        <p:txBody>
+          <a:bodyPr wrap="square" lIns="109728" rIns="109728">
+            <a:spAutoFit/>
+          </a:bodyPr>
+          <a:lstStyle/>
+          <a:p>
+            <a:pPr>
+              <a:spcAft>
+                <a:spcPts val="1200"/>
+              </a:spcAft>
+              <a:defRPr sz="3200" b="1">
+                <a:solidFill>
+                  <a:srgbClr val="112C3D"/>
+                </a:solidFill>
+                <a:latin typeface="Aptos"/>
+              </a:defRPr>
+            </a:pPr>
+            <a:r>
+              <a:t>Extend the platform after invoice proof</a:t>
+            </a:r>
+          </a:p>
+        </p:txBody>
+      </p:sp>
+      <p:sp>
+        <p:nvSpPr>
+          <p:cNvPr id="4" name="TextBox 3"/>
+          <p:cNvSpPr txBox="1"/>
+          <p:nvPr/>
+        </p:nvSpPr>
+        <p:spPr>
+          <a:xfrm>
+            <a:off x="548640" y="6419088"/>
+            <a:ext cx="10058400" cy="274320"/>
+          </a:xfrm>
+          <a:prstGeom prst="rect">
+            <a:avLst/>
+          </a:prstGeom>
+          <a:noFill/>
+        </p:spPr>
+        <p:txBody>
+          <a:bodyPr wrap="square" lIns="109728" rIns="109728">
+            <a:spAutoFit/>
+          </a:bodyPr>
+          <a:lstStyle/>
+          <a:p>
+            <a:pPr>
+              <a:spcAft>
+                <a:spcPts val="1200"/>
+              </a:spcAft>
+              <a:defRPr sz="900" b="0">
+                <a:solidFill>
+                  <a:srgbClr val="53717B"/>
+                </a:solidFill>
+                <a:latin typeface="Aptos"/>
+              </a:defRPr>
+            </a:pPr>
+            <a:r>
+              <a:t>4 OCT 2026  •  BUILD EVIDENCE AND PROPOSED NEXT STAGES</a:t>
+            </a:r>
+          </a:p>
+        </p:txBody>
+      </p:sp>
+      <p:sp>
+        <p:nvSpPr>
+          <p:cNvPr id="5" name="TextBox 4"/>
+          <p:cNvSpPr txBox="1"/>
+          <p:nvPr/>
+        </p:nvSpPr>
+        <p:spPr>
+          <a:xfrm>
+            <a:off x="10972800" y="6355080"/>
+            <a:ext cx="548640" cy="320040"/>
+          </a:xfrm>
+          <a:prstGeom prst="rect">
+            <a:avLst/>
+          </a:prstGeom>
+          <a:noFill/>
+        </p:spPr>
+        <p:txBody>
+          <a:bodyPr wrap="square" lIns="109728" rIns="109728">
+            <a:spAutoFit/>
+          </a:bodyPr>
+          <a:lstStyle/>
+          <a:p>
+            <a:pPr>
+              <a:spcAft>
+                <a:spcPts val="1200"/>
+              </a:spcAft>
+              <a:defRPr sz="1200" b="1">
+                <a:solidFill>
+                  <a:srgbClr val="037E83"/>
+                </a:solidFill>
+                <a:latin typeface="Aptos"/>
+              </a:defRPr>
+            </a:pPr>
+            <a:r>
+              <a:t>13</a:t>
+            </a:r>
+          </a:p>
+        </p:txBody>
+      </p:sp>
+      <p:sp>
+        <p:nvSpPr>
+          <p:cNvPr id="6" name="Rounded Rectangle 5"/>
+          <p:cNvSpPr/>
+          <p:nvPr/>
+        </p:nvSpPr>
+        <p:spPr>
+          <a:xfrm>
+            <a:off x="594360" y="2103120"/>
+            <a:ext cx="3489960" cy="3474720"/>
+          </a:xfrm>
+          <a:prstGeom prst="roundRect">
+            <a:avLst/>
+          </a:prstGeom>
+          <a:solidFill>
+            <a:srgbClr val="FFFFFF"/>
+          </a:solidFill>
+          <a:ln>
+            <a:noFill/>
+          </a:ln>
+        </p:spPr>
+        <p:style>
+          <a:lnRef idx="1">
+            <a:schemeClr val="accent1"/>
+          </a:lnRef>
+          <a:fillRef idx="3">
+            <a:schemeClr val="accent1"/>
+          </a:fillRef>
+          <a:effectRef idx="2">
+            <a:schemeClr val="accent1"/>
+          </a:effectRef>
+          <a:fontRef idx="minor">
+            <a:schemeClr val="lt1"/>
+          </a:fontRef>
+        </p:style>
+        <p:txBody>
+          <a:bodyPr rtlCol="0" anchor="ctr" wrap="square" lIns="109728" rIns="109728"/>
+          <a:lstStyle/>
+          <a:p>
+            <a:pPr algn="ctr">
+              <a:spcAft>
+                <a:spcPts val="1200"/>
+              </a:spcAft>
+              <a:defRPr sz="2200" b="0">
+                <a:solidFill>
+                  <a:srgbClr val="163548"/>
+                </a:solidFill>
+                <a:latin typeface="Aptos"/>
+              </a:defRPr>
+            </a:pPr>
+          </a:p>
+        </p:txBody>
+      </p:sp>
+      <p:sp>
+        <p:nvSpPr>
+          <p:cNvPr id="7" name="TextBox 6"/>
+          <p:cNvSpPr txBox="1"/>
+          <p:nvPr/>
+        </p:nvSpPr>
+        <p:spPr>
+          <a:xfrm>
+            <a:off x="731520" y="2304288"/>
+            <a:ext cx="3215640" cy="960120"/>
+          </a:xfrm>
+          <a:prstGeom prst="rect">
+            <a:avLst/>
+          </a:prstGeom>
+          <a:noFill/>
+        </p:spPr>
+        <p:txBody>
+          <a:bodyPr wrap="square" lIns="109728" rIns="109728">
+            <a:spAutoFit/>
+          </a:bodyPr>
+          <a:lstStyle/>
+          <a:p>
+            <a:pPr>
+              <a:spcAft>
+                <a:spcPts val="1200"/>
+              </a:spcAft>
+              <a:defRPr sz="2100" b="1">
+                <a:solidFill>
+                  <a:srgbClr val="037E83"/>
+                </a:solidFill>
+                <a:latin typeface="Aptos"/>
+              </a:defRPr>
+            </a:pPr>
+            <a:r>
+              <a:t>New store or market</a:t>
+            </a:r>
+          </a:p>
+        </p:txBody>
+      </p:sp>
+      <p:sp>
+        <p:nvSpPr>
+          <p:cNvPr id="8" name="TextBox 7"/>
+          <p:cNvSpPr txBox="1"/>
+          <p:nvPr/>
+        </p:nvSpPr>
+        <p:spPr>
+          <a:xfrm>
+            <a:off x="731520" y="3383280"/>
+            <a:ext cx="3215640" cy="2011680"/>
+          </a:xfrm>
+          <a:prstGeom prst="rect">
+            <a:avLst/>
+          </a:prstGeom>
+          <a:noFill/>
+        </p:spPr>
+        <p:txBody>
+          <a:bodyPr wrap="square" lIns="109728" rIns="109728">
+            <a:spAutoFit/>
+          </a:bodyPr>
+          <a:lstStyle/>
+          <a:p>
+            <a:pPr>
+              <a:spcAft>
+                <a:spcPts val="1200"/>
+              </a:spcAft>
+              <a:defRPr sz="1900" b="0">
+                <a:solidFill>
+                  <a:srgbClr val="163548"/>
+                </a:solidFill>
+                <a:latin typeface="Aptos"/>
+              </a:defRPr>
+            </a:pPr>
+            <a:r>
+              <a:t>Search approved coverage; create supplier discovery and qualification cases only for gaps.</a:t>
+            </a:r>
+          </a:p>
+        </p:txBody>
+      </p:sp>
+      <p:sp>
+        <p:nvSpPr>
+          <p:cNvPr id="9" name="Rounded Rectangle 8"/>
+          <p:cNvSpPr/>
+          <p:nvPr/>
+        </p:nvSpPr>
+        <p:spPr>
+          <a:xfrm>
+            <a:off x="4248912" y="2103120"/>
+            <a:ext cx="3489960" cy="3474720"/>
+          </a:xfrm>
+          <a:prstGeom prst="roundRect">
+            <a:avLst/>
+          </a:prstGeom>
+          <a:solidFill>
+            <a:srgbClr val="FFFFFF"/>
+          </a:solidFill>
+          <a:ln>
+            <a:noFill/>
+          </a:ln>
+        </p:spPr>
+        <p:style>
+          <a:lnRef idx="1">
+            <a:schemeClr val="accent1"/>
+          </a:lnRef>
+          <a:fillRef idx="3">
+            <a:schemeClr val="accent1"/>
+          </a:fillRef>
+          <a:effectRef idx="2">
+            <a:schemeClr val="accent1"/>
+          </a:effectRef>
+          <a:fontRef idx="minor">
+            <a:schemeClr val="lt1"/>
+          </a:fontRef>
+        </p:style>
+        <p:txBody>
+          <a:bodyPr rtlCol="0" anchor="ctr" wrap="square" lIns="109728" rIns="109728"/>
+          <a:lstStyle/>
+          <a:p>
+            <a:pPr algn="ctr">
+              <a:spcAft>
+                <a:spcPts val="1200"/>
+              </a:spcAft>
+              <a:defRPr sz="2200" b="0">
+                <a:solidFill>
+                  <a:srgbClr val="163548"/>
+                </a:solidFill>
+                <a:latin typeface="Aptos"/>
+              </a:defRPr>
+            </a:pPr>
+          </a:p>
+        </p:txBody>
+      </p:sp>
+      <p:sp>
+        <p:nvSpPr>
+          <p:cNvPr id="10" name="TextBox 9"/>
+          <p:cNvSpPr txBox="1"/>
+          <p:nvPr/>
+        </p:nvSpPr>
+        <p:spPr>
+          <a:xfrm>
+            <a:off x="4386072" y="2304288"/>
+            <a:ext cx="3215640" cy="960120"/>
+          </a:xfrm>
+          <a:prstGeom prst="rect">
+            <a:avLst/>
+          </a:prstGeom>
+          <a:noFill/>
+        </p:spPr>
+        <p:txBody>
+          <a:bodyPr wrap="square" lIns="109728" rIns="109728">
+            <a:spAutoFit/>
+          </a:bodyPr>
+          <a:lstStyle/>
+          <a:p>
+            <a:pPr>
+              <a:spcAft>
+                <a:spcPts val="1200"/>
+              </a:spcAft>
+              <a:defRPr sz="2100" b="1">
+                <a:solidFill>
+                  <a:srgbClr val="037E83"/>
+                </a:solidFill>
+                <a:latin typeface="Aptos"/>
+              </a:defRPr>
+            </a:pPr>
+            <a:r>
+              <a:t>Supplier item intake</a:t>
+            </a:r>
+          </a:p>
+        </p:txBody>
+      </p:sp>
+      <p:sp>
+        <p:nvSpPr>
+          <p:cNvPr id="11" name="TextBox 10"/>
+          <p:cNvSpPr txBox="1"/>
+          <p:nvPr/>
+        </p:nvSpPr>
+        <p:spPr>
+          <a:xfrm>
+            <a:off x="4386072" y="3383280"/>
+            <a:ext cx="3215640" cy="2011680"/>
+          </a:xfrm>
+          <a:prstGeom prst="rect">
+            <a:avLst/>
+          </a:prstGeom>
+          <a:noFill/>
+        </p:spPr>
+        <p:txBody>
+          <a:bodyPr wrap="square" lIns="109728" rIns="109728">
+            <a:spAutoFit/>
+          </a:bodyPr>
+          <a:lstStyle/>
+          <a:p>
+            <a:pPr>
+              <a:spcAft>
+                <a:spcPts val="1200"/>
+              </a:spcAft>
+              <a:defRPr sz="1900" b="0">
+                <a:solidFill>
+                  <a:srgbClr val="163548"/>
+                </a:solidFill>
+                <a:latin typeface="Aptos"/>
+              </a:defRPr>
+            </a:pPr>
+            <a:r>
+              <a:t>Normalize item identity, codes, packaging and units. Route ambiguity to a data steward.</a:t>
+            </a:r>
+          </a:p>
+        </p:txBody>
+      </p:sp>
+      <p:sp>
+        <p:nvSpPr>
+          <p:cNvPr id="12" name="Rounded Rectangle 11"/>
+          <p:cNvSpPr/>
+          <p:nvPr/>
+        </p:nvSpPr>
+        <p:spPr>
+          <a:xfrm>
+            <a:off x="7903463" y="2103120"/>
+            <a:ext cx="3489960" cy="3474720"/>
+          </a:xfrm>
+          <a:prstGeom prst="roundRect">
+            <a:avLst/>
+          </a:prstGeom>
+          <a:solidFill>
+            <a:srgbClr val="FFFFFF"/>
+          </a:solidFill>
+          <a:ln>
+            <a:noFill/>
+          </a:ln>
+        </p:spPr>
+        <p:style>
+          <a:lnRef idx="1">
+            <a:schemeClr val="accent1"/>
+          </a:lnRef>
+          <a:fillRef idx="3">
+            <a:schemeClr val="accent1"/>
+          </a:fillRef>
+          <a:effectRef idx="2">
+            <a:schemeClr val="accent1"/>
+          </a:effectRef>
+          <a:fontRef idx="minor">
+            <a:schemeClr val="lt1"/>
+          </a:fontRef>
+        </p:style>
+        <p:txBody>
+          <a:bodyPr rtlCol="0" anchor="ctr" wrap="square" lIns="109728" rIns="109728"/>
+          <a:lstStyle/>
+          <a:p>
+            <a:pPr algn="ctr">
+              <a:spcAft>
+                <a:spcPts val="1200"/>
+              </a:spcAft>
+              <a:defRPr sz="2200" b="0">
+                <a:solidFill>
+                  <a:srgbClr val="163548"/>
+                </a:solidFill>
+                <a:latin typeface="Aptos"/>
+              </a:defRPr>
+            </a:pPr>
+          </a:p>
+        </p:txBody>
+      </p:sp>
+      <p:sp>
+        <p:nvSpPr>
+          <p:cNvPr id="13" name="TextBox 12"/>
+          <p:cNvSpPr txBox="1"/>
+          <p:nvPr/>
+        </p:nvSpPr>
+        <p:spPr>
+          <a:xfrm>
+            <a:off x="8040624" y="2304288"/>
+            <a:ext cx="3215640" cy="960120"/>
+          </a:xfrm>
+          <a:prstGeom prst="rect">
+            <a:avLst/>
+          </a:prstGeom>
+          <a:noFill/>
+        </p:spPr>
+        <p:txBody>
+          <a:bodyPr wrap="square" lIns="109728" rIns="109728">
+            <a:spAutoFit/>
+          </a:bodyPr>
+          <a:lstStyle/>
+          <a:p>
+            <a:pPr>
+              <a:spcAft>
+                <a:spcPts val="1200"/>
+              </a:spcAft>
+              <a:defRPr sz="2100" b="1">
+                <a:solidFill>
+                  <a:srgbClr val="037E83"/>
+                </a:solidFill>
+                <a:latin typeface="Aptos"/>
+              </a:defRPr>
+            </a:pPr>
+            <a:r>
+              <a:t>Digital channels</a:t>
+            </a:r>
+          </a:p>
+        </p:txBody>
+      </p:sp>
+      <p:sp>
+        <p:nvSpPr>
+          <p:cNvPr id="14" name="TextBox 13"/>
+          <p:cNvSpPr txBox="1"/>
+          <p:nvPr/>
+        </p:nvSpPr>
+        <p:spPr>
+          <a:xfrm>
+            <a:off x="8040624" y="3383280"/>
+            <a:ext cx="3215640" cy="2011680"/>
+          </a:xfrm>
+          <a:prstGeom prst="rect">
+            <a:avLst/>
+          </a:prstGeom>
+          <a:noFill/>
+        </p:spPr>
+        <p:txBody>
+          <a:bodyPr wrap="square" lIns="109728" rIns="109728">
+            <a:spAutoFit/>
+          </a:bodyPr>
+          <a:lstStyle/>
+          <a:p>
+            <a:pPr>
+              <a:spcAft>
+                <a:spcPts val="1200"/>
+              </a:spcAft>
+              <a:defRPr sz="1900" b="0">
+                <a:solidFill>
+                  <a:srgbClr val="163548"/>
+                </a:solidFill>
+                <a:latin typeface="Aptos"/>
+              </a:defRPr>
+            </a:pPr>
+            <a:r>
+              <a:t>Maintain versioned content, images, translations and channel rules separately from purchasing identity.</a:t>
+            </a:r>
+          </a:p>
+        </p:txBody>
+      </p:sp>
+    </p:spTree>
+  </p:cSld>
+  <p:clrMapOvr>
+    <a:masterClrMapping/>
+  </p:clrMapOvr>
+</p:sld>
+</file>
+
+<file path=ppt/slides/slide14.xml><?xml version="1.0" encoding="utf-8"?>
+<p:sld xmlns:a="http://schemas.openxmlformats.org/drawingml/2006/main" xmlns:p="http://schemas.openxmlformats.org/presentationml/2006/main" xmlns:r="http://schemas.openxmlformats.org/officeDocument/2006/relationships">
+  <p:cSld>
+    <p:bg>
+      <p:bgPr>
+        <a:solidFill>
+          <a:srgbClr val="F3F7F7"/>
+        </a:solidFill>
+        <a:effectLst/>
+      </p:bgPr>
+    </p:bg>
+    <p:spTree>
+      <p:nvGrpSpPr>
+        <p:cNvPr id="1" name=""/>
+        <p:cNvGrpSpPr/>
+        <p:nvPr/>
+      </p:nvGrpSpPr>
+      <p:grpSpPr/>
+      <p:sp>
+        <p:nvSpPr>
+          <p:cNvPr id="2" name="TextBox 1"/>
+          <p:cNvSpPr txBox="1"/>
+          <p:nvPr/>
+        </p:nvSpPr>
+        <p:spPr>
+          <a:xfrm>
+            <a:off x="548640" y="274320"/>
+            <a:ext cx="10972800" cy="274320"/>
+          </a:xfrm>
+          <a:prstGeom prst="rect">
+            <a:avLst/>
+          </a:prstGeom>
+          <a:noFill/>
+        </p:spPr>
+        <p:txBody>
+          <a:bodyPr wrap="square" lIns="109728" rIns="109728">
+            <a:spAutoFit/>
+          </a:bodyPr>
+          <a:lstStyle/>
+          <a:p>
+            <a:pPr>
+              <a:spcAft>
+                <a:spcPts val="1200"/>
+              </a:spcAft>
+              <a:defRPr sz="1100" b="1">
+                <a:solidFill>
+                  <a:srgbClr val="037E83"/>
+                </a:solidFill>
+                <a:latin typeface="Aptos"/>
+              </a:defRPr>
+            </a:pPr>
+            <a:r>
+              <a:t>INVOICE STUDIO / DECISION PACK</a:t>
+            </a:r>
+          </a:p>
+        </p:txBody>
+      </p:sp>
+      <p:sp>
+        <p:nvSpPr>
+          <p:cNvPr id="3" name="TextBox 2"/>
+          <p:cNvSpPr txBox="1"/>
+          <p:nvPr/>
+        </p:nvSpPr>
+        <p:spPr>
+          <a:xfrm>
+            <a:off x="548640" y="868680"/>
+            <a:ext cx="10972800" cy="1188720"/>
+          </a:xfrm>
+          <a:prstGeom prst="rect">
+            <a:avLst/>
+          </a:prstGeom>
+          <a:noFill/>
+        </p:spPr>
+        <p:txBody>
+          <a:bodyPr wrap="square" lIns="109728" rIns="109728">
+            <a:spAutoFit/>
+          </a:bodyPr>
+          <a:lstStyle/>
+          <a:p>
+            <a:pPr>
+              <a:spcAft>
+                <a:spcPts val="1200"/>
+              </a:spcAft>
+              <a:defRPr sz="3200" b="1">
+                <a:solidFill>
+                  <a:srgbClr val="112C3D"/>
+                </a:solidFill>
+                <a:latin typeface="Aptos"/>
+              </a:defRPr>
+            </a:pPr>
+            <a:r>
+              <a:t>The next business decisions</a:t>
+            </a:r>
+          </a:p>
+        </p:txBody>
+      </p:sp>
+      <p:sp>
+        <p:nvSpPr>
+          <p:cNvPr id="4" name="TextBox 3"/>
+          <p:cNvSpPr txBox="1"/>
+          <p:nvPr/>
+        </p:nvSpPr>
+        <p:spPr>
+          <a:xfrm>
+            <a:off x="548640" y="6419088"/>
+            <a:ext cx="10058400" cy="274320"/>
+          </a:xfrm>
+          <a:prstGeom prst="rect">
+            <a:avLst/>
+          </a:prstGeom>
+          <a:noFill/>
+        </p:spPr>
+        <p:txBody>
+          <a:bodyPr wrap="square" lIns="109728" rIns="109728">
+            <a:spAutoFit/>
+          </a:bodyPr>
+          <a:lstStyle/>
+          <a:p>
+            <a:pPr>
+              <a:spcAft>
+                <a:spcPts val="1200"/>
+              </a:spcAft>
+              <a:defRPr sz="900" b="0">
+                <a:solidFill>
+                  <a:srgbClr val="53717B"/>
+                </a:solidFill>
+                <a:latin typeface="Aptos"/>
+              </a:defRPr>
+            </a:pPr>
+            <a:r>
+              <a:t>4 OCT 2026  •  BUILD EVIDENCE AND PROPOSED NEXT STAGES</a:t>
+            </a:r>
+          </a:p>
+        </p:txBody>
+      </p:sp>
+      <p:sp>
+        <p:nvSpPr>
+          <p:cNvPr id="5" name="TextBox 4"/>
+          <p:cNvSpPr txBox="1"/>
+          <p:nvPr/>
+        </p:nvSpPr>
+        <p:spPr>
+          <a:xfrm>
+            <a:off x="10972800" y="6355080"/>
+            <a:ext cx="548640" cy="320040"/>
+          </a:xfrm>
+          <a:prstGeom prst="rect">
+            <a:avLst/>
+          </a:prstGeom>
+          <a:noFill/>
+        </p:spPr>
+        <p:txBody>
+          <a:bodyPr wrap="square" lIns="109728" rIns="109728">
+            <a:spAutoFit/>
+          </a:bodyPr>
+          <a:lstStyle/>
+          <a:p>
+            <a:pPr>
+              <a:spcAft>
+                <a:spcPts val="1200"/>
+              </a:spcAft>
+              <a:defRPr sz="1200" b="1">
+                <a:solidFill>
+                  <a:srgbClr val="037E83"/>
+                </a:solidFill>
+                <a:latin typeface="Aptos"/>
+              </a:defRPr>
+            </a:pPr>
+            <a:r>
+              <a:t>14</a:t>
+            </a:r>
+          </a:p>
+        </p:txBody>
+      </p:sp>
+      <p:sp>
+        <p:nvSpPr>
+          <p:cNvPr id="6" name="Rounded Rectangle 5"/>
+          <p:cNvSpPr/>
+          <p:nvPr/>
+        </p:nvSpPr>
+        <p:spPr>
+          <a:xfrm>
+            <a:off x="594360" y="2103120"/>
+            <a:ext cx="3489960" cy="3474720"/>
+          </a:xfrm>
+          <a:prstGeom prst="roundRect">
+            <a:avLst/>
+          </a:prstGeom>
+          <a:solidFill>
+            <a:srgbClr val="FFFFFF"/>
+          </a:solidFill>
+          <a:ln>
+            <a:noFill/>
+          </a:ln>
+        </p:spPr>
+        <p:style>
+          <a:lnRef idx="1">
+            <a:schemeClr val="accent1"/>
+          </a:lnRef>
+          <a:fillRef idx="3">
+            <a:schemeClr val="accent1"/>
+          </a:fillRef>
+          <a:effectRef idx="2">
+            <a:schemeClr val="accent1"/>
+          </a:effectRef>
+          <a:fontRef idx="minor">
+            <a:schemeClr val="lt1"/>
+          </a:fontRef>
+        </p:style>
+        <p:txBody>
+          <a:bodyPr rtlCol="0" anchor="ctr" wrap="square" lIns="109728" rIns="109728"/>
+          <a:lstStyle/>
+          <a:p>
+            <a:pPr algn="ctr">
+              <a:spcAft>
+                <a:spcPts val="1200"/>
+              </a:spcAft>
+              <a:defRPr sz="2200" b="0">
+                <a:solidFill>
+                  <a:srgbClr val="163548"/>
+                </a:solidFill>
+                <a:latin typeface="Aptos"/>
+              </a:defRPr>
+            </a:pPr>
+          </a:p>
+        </p:txBody>
+      </p:sp>
+      <p:sp>
+        <p:nvSpPr>
+          <p:cNvPr id="7" name="TextBox 6"/>
+          <p:cNvSpPr txBox="1"/>
+          <p:nvPr/>
+        </p:nvSpPr>
+        <p:spPr>
+          <a:xfrm>
+            <a:off x="731520" y="2304288"/>
+            <a:ext cx="3215640" cy="960120"/>
+          </a:xfrm>
+          <a:prstGeom prst="rect">
+            <a:avLst/>
+          </a:prstGeom>
+          <a:noFill/>
+        </p:spPr>
+        <p:txBody>
+          <a:bodyPr wrap="square" lIns="109728" rIns="109728">
+            <a:spAutoFit/>
+          </a:bodyPr>
+          <a:lstStyle/>
+          <a:p>
+            <a:pPr>
+              <a:spcAft>
+                <a:spcPts val="1200"/>
+              </a:spcAft>
+              <a:defRPr sz="2100" b="1">
+                <a:solidFill>
+                  <a:srgbClr val="037E83"/>
+                </a:solidFill>
+                <a:latin typeface="Aptos"/>
+              </a:defRPr>
+            </a:pPr>
+            <a:r>
+              <a:t>Name the owners</a:t>
+            </a:r>
+          </a:p>
+        </p:txBody>
+      </p:sp>
+      <p:sp>
+        <p:nvSpPr>
+          <p:cNvPr id="8" name="TextBox 7"/>
+          <p:cNvSpPr txBox="1"/>
+          <p:nvPr/>
+        </p:nvSpPr>
+        <p:spPr>
+          <a:xfrm>
+            <a:off x="731520" y="3383280"/>
+            <a:ext cx="3215640" cy="2011680"/>
+          </a:xfrm>
+          <a:prstGeom prst="rect">
+            <a:avLst/>
+          </a:prstGeom>
+          <a:noFill/>
+        </p:spPr>
+        <p:txBody>
+          <a:bodyPr wrap="square" lIns="109728" rIns="109728">
+            <a:spAutoFit/>
+          </a:bodyPr>
+          <a:lstStyle/>
+          <a:p>
+            <a:pPr>
+              <a:spcAft>
+                <a:spcPts val="1200"/>
+              </a:spcAft>
+              <a:defRPr sz="1900" b="0">
+                <a:solidFill>
+                  <a:srgbClr val="163548"/>
+                </a:solidFill>
+                <a:latin typeface="Aptos"/>
+              </a:defRPr>
+            </a:pPr>
+            <a:r>
+              <a:t>AP process owner, reference steward, receiving owner and finance/tax approver.</a:t>
+            </a:r>
+          </a:p>
+        </p:txBody>
+      </p:sp>
+      <p:sp>
+        <p:nvSpPr>
+          <p:cNvPr id="9" name="Rounded Rectangle 8"/>
+          <p:cNvSpPr/>
+          <p:nvPr/>
+        </p:nvSpPr>
+        <p:spPr>
+          <a:xfrm>
+            <a:off x="4248912" y="2103120"/>
+            <a:ext cx="3489960" cy="3474720"/>
+          </a:xfrm>
+          <a:prstGeom prst="roundRect">
+            <a:avLst/>
+          </a:prstGeom>
+          <a:solidFill>
+            <a:srgbClr val="FFFFFF"/>
+          </a:solidFill>
+          <a:ln>
+            <a:noFill/>
+          </a:ln>
+        </p:spPr>
+        <p:style>
+          <a:lnRef idx="1">
+            <a:schemeClr val="accent1"/>
+          </a:lnRef>
+          <a:fillRef idx="3">
+            <a:schemeClr val="accent1"/>
+          </a:fillRef>
+          <a:effectRef idx="2">
+            <a:schemeClr val="accent1"/>
+          </a:effectRef>
+          <a:fontRef idx="minor">
+            <a:schemeClr val="lt1"/>
+          </a:fontRef>
+        </p:style>
+        <p:txBody>
+          <a:bodyPr rtlCol="0" anchor="ctr" wrap="square" lIns="109728" rIns="109728"/>
+          <a:lstStyle/>
+          <a:p>
+            <a:pPr algn="ctr">
+              <a:spcAft>
+                <a:spcPts val="1200"/>
+              </a:spcAft>
+              <a:defRPr sz="2200" b="0">
+                <a:solidFill>
+                  <a:srgbClr val="163548"/>
+                </a:solidFill>
+                <a:latin typeface="Aptos"/>
+              </a:defRPr>
+            </a:pPr>
+          </a:p>
+        </p:txBody>
+      </p:sp>
+      <p:sp>
+        <p:nvSpPr>
+          <p:cNvPr id="10" name="TextBox 9"/>
+          <p:cNvSpPr txBox="1"/>
+          <p:nvPr/>
+        </p:nvSpPr>
+        <p:spPr>
+          <a:xfrm>
+            <a:off x="4386072" y="2304288"/>
+            <a:ext cx="3215640" cy="960120"/>
+          </a:xfrm>
+          <a:prstGeom prst="rect">
+            <a:avLst/>
+          </a:prstGeom>
+          <a:noFill/>
+        </p:spPr>
+        <p:txBody>
+          <a:bodyPr wrap="square" lIns="109728" rIns="109728">
+            <a:spAutoFit/>
+          </a:bodyPr>
+          <a:lstStyle/>
+          <a:p>
+            <a:pPr>
+              <a:spcAft>
+                <a:spcPts val="1200"/>
+              </a:spcAft>
+              <a:defRPr sz="2100" b="1">
+                <a:solidFill>
+                  <a:srgbClr val="037E83"/>
+                </a:solidFill>
+                <a:latin typeface="Aptos"/>
+              </a:defRPr>
+            </a:pPr>
+            <a:r>
+              <a:t>Accept the evidence</a:t>
+            </a:r>
+          </a:p>
+        </p:txBody>
+      </p:sp>
+      <p:sp>
+        <p:nvSpPr>
+          <p:cNvPr id="11" name="TextBox 10"/>
+          <p:cNvSpPr txBox="1"/>
+          <p:nvPr/>
+        </p:nvSpPr>
+        <p:spPr>
+          <a:xfrm>
+            <a:off x="4386072" y="3383280"/>
+            <a:ext cx="3215640" cy="2011680"/>
+          </a:xfrm>
+          <a:prstGeom prst="rect">
+            <a:avLst/>
+          </a:prstGeom>
+          <a:noFill/>
+        </p:spPr>
+        <p:txBody>
+          <a:bodyPr wrap="square" lIns="109728" rIns="109728">
+            <a:spAutoFit/>
+          </a:bodyPr>
+          <a:lstStyle/>
+          <a:p>
+            <a:pPr>
+              <a:spcAft>
+                <a:spcPts val="1200"/>
+              </a:spcAft>
+              <a:defRPr sz="1900" b="0">
+                <a:solidFill>
+                  <a:srgbClr val="163548"/>
+                </a:solidFill>
+                <a:latin typeface="Aptos"/>
+              </a:defRPr>
+            </a:pPr>
+            <a:r>
+              <a:t>Confirm receipt status meaning, invoice baseline, route scope and the initial supplier test set.</a:t>
+            </a:r>
+          </a:p>
+        </p:txBody>
+      </p:sp>
+      <p:sp>
+        <p:nvSpPr>
+          <p:cNvPr id="12" name="Rounded Rectangle 11"/>
+          <p:cNvSpPr/>
+          <p:nvPr/>
+        </p:nvSpPr>
+        <p:spPr>
+          <a:xfrm>
+            <a:off x="7903463" y="2103120"/>
+            <a:ext cx="3489960" cy="3474720"/>
+          </a:xfrm>
+          <a:prstGeom prst="roundRect">
+            <a:avLst/>
+          </a:prstGeom>
+          <a:solidFill>
+            <a:srgbClr val="FFFFFF"/>
+          </a:solidFill>
+          <a:ln>
+            <a:noFill/>
+          </a:ln>
+        </p:spPr>
+        <p:style>
+          <a:lnRef idx="1">
+            <a:schemeClr val="accent1"/>
+          </a:lnRef>
+          <a:fillRef idx="3">
+            <a:schemeClr val="accent1"/>
+          </a:fillRef>
+          <a:effectRef idx="2">
+            <a:schemeClr val="accent1"/>
+          </a:effectRef>
+          <a:fontRef idx="minor">
+            <a:schemeClr val="lt1"/>
+          </a:fontRef>
+        </p:style>
+        <p:txBody>
+          <a:bodyPr rtlCol="0" anchor="ctr" wrap="square" lIns="109728" rIns="109728"/>
+          <a:lstStyle/>
+          <a:p>
+            <a:pPr algn="ctr">
+              <a:spcAft>
+                <a:spcPts val="1200"/>
+              </a:spcAft>
+              <a:defRPr sz="2200" b="0">
+                <a:solidFill>
+                  <a:srgbClr val="163548"/>
+                </a:solidFill>
+                <a:latin typeface="Aptos"/>
+              </a:defRPr>
+            </a:pPr>
+          </a:p>
+        </p:txBody>
+      </p:sp>
+      <p:sp>
+        <p:nvSpPr>
+          <p:cNvPr id="13" name="TextBox 12"/>
+          <p:cNvSpPr txBox="1"/>
+          <p:nvPr/>
+        </p:nvSpPr>
+        <p:spPr>
+          <a:xfrm>
+            <a:off x="8040624" y="2304288"/>
+            <a:ext cx="3215640" cy="960120"/>
+          </a:xfrm>
+          <a:prstGeom prst="rect">
+            <a:avLst/>
+          </a:prstGeom>
+          <a:noFill/>
+        </p:spPr>
+        <p:txBody>
+          <a:bodyPr wrap="square" lIns="109728" rIns="109728">
+            <a:spAutoFit/>
+          </a:bodyPr>
+          <a:lstStyle/>
+          <a:p>
+            <a:pPr>
+              <a:spcAft>
+                <a:spcPts val="1200"/>
+              </a:spcAft>
+              <a:defRPr sz="2100" b="1">
+                <a:solidFill>
+                  <a:srgbClr val="037E83"/>
+                </a:solidFill>
+                <a:latin typeface="Aptos"/>
+              </a:defRPr>
+            </a:pPr>
+            <a:r>
+              <a:t>Authorize the rollout</a:t>
+            </a:r>
+          </a:p>
+        </p:txBody>
+      </p:sp>
+      <p:sp>
+        <p:nvSpPr>
+          <p:cNvPr id="14" name="TextBox 13"/>
+          <p:cNvSpPr txBox="1"/>
+          <p:nvPr/>
+        </p:nvSpPr>
+        <p:spPr>
+          <a:xfrm>
+            <a:off x="8040624" y="3383280"/>
+            <a:ext cx="3215640" cy="2011680"/>
+          </a:xfrm>
+          <a:prstGeom prst="rect">
+            <a:avLst/>
+          </a:prstGeom>
+          <a:noFill/>
+        </p:spPr>
+        <p:txBody>
+          <a:bodyPr wrap="square" lIns="109728" rIns="109728">
+            <a:spAutoFit/>
+          </a:bodyPr>
+          <a:lstStyle/>
+          <a:p>
+            <a:pPr>
+              <a:spcAft>
+                <a:spcPts val="1200"/>
+              </a:spcAft>
+              <a:defRPr sz="1900" b="0">
+                <a:solidFill>
+                  <a:srgbClr val="163548"/>
+                </a:solidFill>
+                <a:latin typeface="Aptos"/>
+              </a:defRPr>
+            </a:pPr>
+            <a:r>
+              <a:t>Set approved users, provider choices and budget; sign off downstream workbook compatibility.</a:t>
+            </a:r>
+          </a:p>
+        </p:txBody>
+      </p:sp>
+      <p:sp>
+        <p:nvSpPr>
+          <p:cNvPr id="15" name="TextBox 14"/>
+          <p:cNvSpPr txBox="1"/>
+          <p:nvPr/>
+        </p:nvSpPr>
+        <p:spPr>
+          <a:xfrm>
+            <a:off x="640080" y="5806440"/>
+            <a:ext cx="10789920" cy="411480"/>
+          </a:xfrm>
+          <a:prstGeom prst="rect">
+            <a:avLst/>
+          </a:prstGeom>
+          <a:noFill/>
+        </p:spPr>
+        <p:txBody>
+          <a:bodyPr wrap="square" lIns="109728" rIns="109728">
+            <a:spAutoFit/>
+          </a:bodyPr>
+          <a:lstStyle/>
+          <a:p>
+            <a:pPr>
+              <a:spcAft>
+                <a:spcPts val="1200"/>
+              </a:spcAft>
+              <a:defRPr sz="1400" b="0">
+                <a:solidFill>
+                  <a:srgbClr val="53717B"/>
+                </a:solidFill>
+                <a:latin typeface="Aptos"/>
+              </a:defRPr>
+            </a:pPr>
+            <a:r>
+              <a:t>Fifteen acceptance-driven implementation stories accompany the design and operator guide.</a:t>
             </a:r>
           </a:p>
         </p:txBody>
@@ -6441,7 +7632,7 @@
               </a:defRPr>
             </a:pPr>
             <a:r>
-              <a:t>Local engines; selected AI for gaps.</a:t>
+              <a:t>Template, native-PDF fast path, OCR or permitted AI.</a:t>
             </a:r>
           </a:p>
         </p:txBody>
@@ -6572,7 +7763,7 @@
               </a:defRPr>
             </a:pPr>
             <a:r>
-              <a:t>Supplier, PO, item, receipt and tax.</a:t>
+              <a:t>Approved references; lookup remains evidence only.</a:t>
             </a:r>
           </a:p>
         </p:txBody>
@@ -6703,7 +7894,7 @@
               </a:defRPr>
             </a:pPr>
             <a:r>
-              <a:t>Evidence and exceptions, then recheck.</a:t>
+              <a:t>Visible stage, evidence and exceptions.</a:t>
             </a:r>
           </a:p>
         </p:txBody>
@@ -6834,7 +8025,7 @@
               </a:defRPr>
             </a:pPr>
             <a:r>
-              <a:t>One workbook with joined transactions.</a:t>
+              <a:t>Approved workbook or labelled manual draft.</a:t>
             </a:r>
           </a:p>
         </p:txBody>
@@ -8062,7 +9253,7 @@
               </a:defRPr>
             </a:pPr>
             <a:r>
-              <a:t>Invoice 1 joins as transaction 1 on every sheet. Invoice 2 joins as transaction 2.</a:t>
+              <a:t>Approved export revalidates and reserves receipts. Manual draft uses the same shape but is visibly DRAFT_UNVALIDATED and reserves nothing.</a:t>
             </a:r>
           </a:p>
         </p:txBody>
@@ -8166,7 +9357,7 @@
               </a:defRPr>
             </a:pPr>
             <a:r>
-              <a:t>Cross-market supply needs an explicit route</a:t>
+              <a:t>Two controlled routes to the workbook</a:t>
             </a:r>
           </a:p>
         </p:txBody>
@@ -8336,7 +9527,7 @@
               </a:defRPr>
             </a:pPr>
             <a:r>
-              <a:t>Supplier legal entity</a:t>
+              <a:t>Approved export</a:t>
             </a:r>
           </a:p>
         </p:txBody>
@@ -8375,7 +9566,7 @@
               </a:defRPr>
             </a:pPr>
             <a:r>
-              <a:t>A supplier name is not enough. Operational sites have their own identities and approved names.</a:t>
+              <a:t>Ready and reviewed invoices are revalidated. Receipt allocations and export receipt commit atomically.</a:t>
             </a:r>
           </a:p>
         </p:txBody>
@@ -8467,7 +9658,7 @@
               </a:defRPr>
             </a:pPr>
             <a:r>
-              <a:t>Buying company</a:t>
+              <a:t>Manual draft</a:t>
             </a:r>
           </a:p>
         </p:txBody>
@@ -8506,7 +9697,7 @@
               </a:defRPr>
             </a:pPr>
             <a:r>
-              <a:t>The same seller may serve different owned companies. PO scope must identify the correct buyer.</a:t>
+              <a:t>Every target field is editable during OCR. Explicit acknowledgement, one joined transaction and no formulas.</a:t>
             </a:r>
           </a:p>
         </p:txBody>
@@ -8598,7 +9789,7 @@
               </a:defRPr>
             </a:pPr>
             <a:r>
-              <a:t>Route and currency</a:t>
+              <a:t>Visible boundary</a:t>
             </a:r>
           </a:p>
         </p:txBody>
@@ -8637,7 +9828,46 @@
               </a:defRPr>
             </a:pPr>
             <a:r>
-              <a:t>UAE → Kuwait with AED billing remains a distinct route. Currency equality does not prove approval.</a:t>
+              <a:t>Filename, workbook properties and comments say DRAFT_UNVALIDATED, references not validated and no receipt reserved.</a:t>
+            </a:r>
+          </a:p>
+        </p:txBody>
+      </p:sp>
+      <p:sp>
+        <p:nvSpPr>
+          <p:cNvPr id="15" name="TextBox 14"/>
+          <p:cNvSpPr txBox="1"/>
+          <p:nvPr/>
+        </p:nvSpPr>
+        <p:spPr>
+          <a:xfrm>
+            <a:off x="640080" y="5806440"/>
+            <a:ext cx="10789920" cy="411480"/>
+          </a:xfrm>
+          <a:prstGeom prst="rect">
+            <a:avLst/>
+          </a:prstGeom>
+          <a:noFill/>
+        </p:spPr>
+        <p:txBody>
+          <a:bodyPr wrap="square" lIns="109728" rIns="109728">
+            <a:spAutoFit/>
+          </a:bodyPr>
+          <a:lstStyle/>
+          <a:p>
+            <a:pPr>
+              <a:spcAft>
+                <a:spcPts val="1200"/>
+              </a:spcAft>
+              <a:defRPr sz="1400" b="0">
+                <a:solidFill>
+                  <a:srgbClr val="53717B"/>
+                </a:solidFill>
+                <a:latin typeface="Aptos"/>
+              </a:defRPr>
+            </a:pPr>
+            <a:r>
+              <a:t>The draft does not change job status, revision, extracted invoice, reference approval or the approved-export ledger.</a:t>
             </a:r>
           </a:p>
         </p:txBody>
@@ -8741,7 +9971,7 @@
               </a:defRPr>
             </a:pPr>
             <a:r>
-              <a:t>Reference files are evidence, not assumptions</a:t>
+              <a:t>Cross-market supply needs an explicit route</a:t>
             </a:r>
           </a:p>
         </p:txBody>
@@ -8911,7 +10141,7 @@
               </a:defRPr>
             </a:pPr>
             <a:r>
-              <a:t>Profile everything</a:t>
+              <a:t>Supplier legal entity</a:t>
             </a:r>
           </a:p>
         </p:txBody>
@@ -8950,7 +10180,7 @@
               </a:defRPr>
             </a:pPr>
             <a:r>
-              <a:t>Preserve original bytes and hashes. Read all populated cells. Report missing values and duplicate grain.</a:t>
+              <a:t>A supplier name is not enough. Operational sites have their own identities and approved names.</a:t>
             </a:r>
           </a:p>
         </p:txBody>
@@ -9042,7 +10272,7 @@
               </a:defRPr>
             </a:pPr>
             <a:r>
-              <a:t>Map with provenance</a:t>
+              <a:t>Buying company</a:t>
             </a:r>
           </a:p>
         </p:txBody>
@@ -9081,7 +10311,7 @@
               </a:defRPr>
             </a:pPr>
             <a:r>
-              <a:t>Keep source sheet, column and row. Separate unique joins from ambiguous matches.</a:t>
+              <a:t>The same seller may serve different owned companies. PO scope must identify the correct buyer.</a:t>
             </a:r>
           </a:p>
         </p:txBody>
@@ -9173,7 +10403,7 @@
               </a:defRPr>
             </a:pPr>
             <a:r>
-              <a:t>Close the gaps</a:t>
+              <a:t>Route and currency</a:t>
             </a:r>
           </a:p>
         </p:txBody>
@@ -9212,46 +10442,7 @@
               </a:defRPr>
             </a:pPr>
             <a:r>
-              <a:t>Buyer, legal entity, receipt acceptance, prior invoicing and route/tax approval need a named owner.</a:t>
-            </a:r>
-          </a:p>
-        </p:txBody>
-      </p:sp>
-      <p:sp>
-        <p:nvSpPr>
-          <p:cNvPr id="15" name="TextBox 14"/>
-          <p:cNvSpPr txBox="1"/>
-          <p:nvPr/>
-        </p:nvSpPr>
-        <p:spPr>
-          <a:xfrm>
-            <a:off x="640080" y="5806440"/>
-            <a:ext cx="10789920" cy="411480"/>
-          </a:xfrm>
-          <a:prstGeom prst="rect">
-            <a:avLst/>
-          </a:prstGeom>
-          <a:noFill/>
-        </p:spPr>
-        <p:txBody>
-          <a:bodyPr wrap="square" lIns="109728" rIns="109728">
-            <a:spAutoFit/>
-          </a:bodyPr>
-          <a:lstStyle/>
-          <a:p>
-            <a:pPr>
-              <a:spcAft>
-                <a:spcPts val="1200"/>
-              </a:spcAft>
-              <a:defRPr sz="1400" b="0">
-                <a:solidFill>
-                  <a:srgbClr val="53717B"/>
-                </a:solidFill>
-                <a:latin typeface="Aptos"/>
-              </a:defRPr>
-            </a:pPr>
-            <a:r>
-              <a:t>Completed target examples validate the Excel shape; they do not establish master-data approval.</a:t>
+              <a:t>UAE → Kuwait with AED billing remains a distinct route. Currency equality does not prove approval.</a:t>
             </a:r>
           </a:p>
         </p:txBody>
@@ -9355,7 +10546,7 @@
               </a:defRPr>
             </a:pPr>
             <a:r>
-              <a:t>Cloud delivery is a controlled pilot</a:t>
+              <a:t>Reference files are evidence, not assumptions</a:t>
             </a:r>
           </a:p>
         </p:txBody>
@@ -9525,7 +10716,7 @@
               </a:defRPr>
             </a:pPr>
             <a:r>
-              <a:t>Firebase frontend</a:t>
+              <a:t>Search actual scale</a:t>
             </a:r>
           </a:p>
         </p:txBody>
@@ -9564,7 +10755,7 @@
               </a:defRPr>
             </a:pPr>
             <a:r>
-              <a:t>Responsive portal, approved account sign-in and authenticated document downloads.</a:t>
+              <a:t>Lookup covers 114,940 item rows and 297,199 PO rows by exact identifier or product-name token.</a:t>
             </a:r>
           </a:p>
         </p:txBody>
@@ -9656,7 +10847,7 @@
               </a:defRPr>
             </a:pPr>
             <a:r>
-              <a:t>GCP application</a:t>
+              <a:t>Show conflicts</a:t>
             </a:r>
           </a:p>
         </p:txBody>
@@ -9695,7 +10886,7 @@
               </a:defRPr>
             </a:pPr>
             <a:r>
-              <a:t>Cloud Run readers and API. Cloud SQL records/ledger. Private Cloud Storage evidence.</a:t>
+              <a:t>Keep source sheet/row and duplicate context. Require explicit operator confirmation before copying evidence.</a:t>
             </a:r>
           </a:p>
         </p:txBody>
@@ -9787,7 +10978,7 @@
               </a:defRPr>
             </a:pPr>
             <a:r>
-              <a:t>Release gates</a:t>
+              <a:t>Approve separately</a:t>
             </a:r>
           </a:p>
         </p:txBody>
@@ -9826,7 +11017,7 @@
               </a:defRPr>
             </a:pPr>
             <a:r>
-              <a:t>Verified access restrictions, synthetic end-to-end export and restart persistence before handoff.</a:t>
+              <a:t>Lookup never approves matching. Buyer, receipt, prior invoicing, route and tax meaning still need owners.</a:t>
             </a:r>
           </a:p>
         </p:txBody>
@@ -9865,7 +11056,7 @@
               </a:defRPr>
             </a:pPr>
             <a:r>
-              <a:t>Deployment is in progress. A shared enterprise release still needs role separation and durable distributed workers.</a:t>
+              <a:t>Completed target examples and lookup hits are evidence; neither establishes canonical master-data approval.</a:t>
             </a:r>
           </a:p>
         </p:txBody>
@@ -9969,7 +11160,7 @@
               </a:defRPr>
             </a:pPr>
             <a:r>
-              <a:t>Show evidence before claiming automation</a:t>
+              <a:t>Cloud delivery is a controlled pilot</a:t>
             </a:r>
           </a:p>
         </p:txBody>
@@ -10139,7 +11330,7 @@
               </a:defRPr>
             </a:pPr>
             <a:r>
-              <a:t>Verified now</a:t>
+              <a:t>Firebase frontend</a:t>
             </a:r>
           </a:p>
         </p:txBody>
@@ -10178,7 +11369,7 @@
               </a:defRPr>
             </a:pPr>
             <a:r>
-              <a:t>Backend and browser checks. Real local reader runs on synthetic digital/scanned examples. Exact batch workbook.</a:t>
+              <a:t>Responsive portal, approved account sign-in and authenticated document downloads.</a:t>
             </a:r>
           </a:p>
         </p:txBody>
@@ -10270,7 +11461,7 @@
               </a:defRPr>
             </a:pPr>
             <a:r>
-              <a:t>Pilot next</a:t>
+              <a:t>GCP application</a:t>
             </a:r>
           </a:p>
         </p:txBody>
@@ -10309,7 +11500,7 @@
               </a:defRPr>
             </a:pPr>
             <a:r>
-              <a:t>Representative supplier formats and languages. Independently adjudicated fields, lines and receipt balances.</a:t>
+              <a:t>Cloud Run readers and API. Cloud SQL records/ledger. Private Cloud Storage evidence.</a:t>
             </a:r>
           </a:p>
         </p:txBody>
@@ -10401,7 +11592,7 @@
               </a:defRPr>
             </a:pPr>
             <a:r>
-              <a:t>Measure value</a:t>
+              <a:t>Release gates</a:t>
             </a:r>
           </a:p>
         </p:txBody>
@@ -10440,7 +11631,46 @@
               </a:defRPr>
             </a:pPr>
             <a:r>
-              <a:t>Minutes saved per invoice, correction count, false-ready rate, fallback share, latency and provider cost.</a:t>
+              <a:t>Re-run auth, draft immutability, lookup, connections, extraction/export and persistence before handoff.</a:t>
+            </a:r>
+          </a:p>
+        </p:txBody>
+      </p:sp>
+      <p:sp>
+        <p:nvSpPr>
+          <p:cNvPr id="15" name="TextBox 14"/>
+          <p:cNvSpPr txBox="1"/>
+          <p:nvPr/>
+        </p:nvSpPr>
+        <p:spPr>
+          <a:xfrm>
+            <a:off x="640080" y="5806440"/>
+            <a:ext cx="10789920" cy="411480"/>
+          </a:xfrm>
+          <a:prstGeom prst="rect">
+            <a:avLst/>
+          </a:prstGeom>
+          <a:noFill/>
+        </p:spPr>
+        <p:txBody>
+          <a:bodyPr wrap="square" lIns="109728" rIns="109728">
+            <a:spAutoFit/>
+          </a:bodyPr>
+          <a:lstStyle/>
+          <a:p>
+            <a:pPr>
+              <a:spcAft>
+                <a:spcPts val="1200"/>
+              </a:spcAft>
+              <a:defRPr sz="1400" b="0">
+                <a:solidFill>
+                  <a:srgbClr val="53717B"/>
+                </a:solidFill>
+                <a:latin typeface="Aptos"/>
+              </a:defRPr>
+            </a:pPr>
+            <a:r>
+              <a:t>The deployed URL is the earlier baseline. Current source additions are not yet claimed as deployed.</a:t>
             </a:r>
           </a:p>
         </p:txBody>

</xml_diff>

<commit_message>
Deliver structured OCR, bulk review workbooks, and responsive cloud inbox
</commit_message>
<xml_diff>
--- a/docs/delivery/Invoice_Studio_SLT.pptx
+++ b/docs/delivery/Invoice_Studio_SLT.pptx
@@ -19,6 +19,9 @@
     <p:sldId id="267" r:id="rId18"/>
     <p:sldId id="268" r:id="rId19"/>
     <p:sldId id="269" r:id="rId20"/>
+    <p:sldId id="270" r:id="rId21"/>
+    <p:sldId id="271" r:id="rId22"/>
+    <p:sldId id="272" r:id="rId23"/>
   </p:sldIdLst>
   <p:sldSz cx="12191695" cy="6858000" type="screen4x3"/>
   <p:notesSz cx="6858000" cy="9144000"/>
@@ -3237,7 +3240,7 @@
               </a:defRPr>
             </a:pPr>
             <a:r>
-              <a:t>4 OCT 2026  •  BUILD EVIDENCE AND PROPOSED NEXT STAGES</a:t>
+              <a:t>5 OCT 2026  •  MEASURED EVIDENCE AND PROPOSED NEXT STAGES</a:t>
             </a:r>
           </a:p>
         </p:txBody>
@@ -3416,25 +3419,25 @@
         </p:nvSpPr>
         <p:spPr>
           <a:xfrm>
-            <a:off x="640080" y="5120640"/>
-            <a:ext cx="10515600" cy="731520"/>
-          </a:xfrm>
-          <a:prstGeom prst="rect">
-            <a:avLst/>
-          </a:prstGeom>
-          <a:noFill/>
-        </p:spPr>
-        <p:txBody>
-          <a:bodyPr wrap="square" lIns="109728" rIns="109728">
-            <a:spAutoFit/>
-          </a:bodyPr>
-          <a:lstStyle/>
-          <a:p>
-            <a:pPr>
-              <a:spcAft>
-                <a:spcPts val="1200"/>
-              </a:spcAft>
-              <a:defRPr sz="1800" b="0">
+            <a:off x="640080" y="4983480"/>
+            <a:ext cx="10515600" cy="960120"/>
+          </a:xfrm>
+          <a:prstGeom prst="rect">
+            <a:avLst/>
+          </a:prstGeom>
+          <a:noFill/>
+        </p:spPr>
+        <p:txBody>
+          <a:bodyPr wrap="square" lIns="109728" rIns="109728">
+            <a:spAutoFit/>
+          </a:bodyPr>
+          <a:lstStyle/>
+          <a:p>
+            <a:pPr>
+              <a:spcAft>
+                <a:spcPts val="1200"/>
+              </a:spcAft>
+              <a:defRPr sz="1700" b="0">
                 <a:solidFill>
                   <a:srgbClr val="53717B"/>
                 </a:solidFill>
@@ -3442,7 +3445,7 @@
               </a:defRPr>
             </a:pPr>
             <a:r>
-              <a:t>Hosted baseline verified with synthetic invoices. Current source additions await integrated validation and deployment.</a:t>
+              <a:t>Access hotfix 00005-zdk is verified. 148 backend tests, Chromium and three Docker reader warmups pass. Full feature deployment and hosted catalog recovery remain pending.</a:t>
             </a:r>
           </a:p>
         </p:txBody>
@@ -3585,7 +3588,7 @@
               </a:defRPr>
             </a:pPr>
             <a:r>
-              <a:t>4 OCT 2026  •  BUILD EVIDENCE AND PROPOSED NEXT STAGES</a:t>
+              <a:t>5 OCT 2026  •  MEASURED EVIDENCE AND PROPOSED NEXT STAGES</a:t>
             </a:r>
           </a:p>
         </p:txBody>
@@ -4160,7 +4163,7 @@
               </a:defRPr>
             </a:pPr>
             <a:r>
-              <a:t>Show evidence before claiming automation</a:t>
+              <a:t>Release checks are green; deployment remains bounded</a:t>
             </a:r>
           </a:p>
         </p:txBody>
@@ -4199,7 +4202,7 @@
               </a:defRPr>
             </a:pPr>
             <a:r>
-              <a:t>4 OCT 2026  •  BUILD EVIDENCE AND PROPOSED NEXT STAGES</a:t>
+              <a:t>5 OCT 2026  •  MEASURED EVIDENCE AND PROPOSED NEXT STAGES</a:t>
             </a:r>
           </a:p>
         </p:txBody>
@@ -4330,7 +4333,7 @@
               </a:defRPr>
             </a:pPr>
             <a:r>
-              <a:t>Release validation</a:t>
+              <a:t>Repository gate</a:t>
             </a:r>
           </a:p>
         </p:txBody>
@@ -4369,7 +4372,7 @@
               </a:defRPr>
             </a:pPr>
             <a:r>
-              <a:t>101 backend tests and real local PostgreSQL pass; Ruff clean; three-reader container warm passed. Browser, publish, catalog and hosted smoke pending.</a:t>
+              <a:t>148 backend tests pass with PostgreSQL included and no skips. Ruff and the latest full Chromium workflow pass.</a:t>
             </a:r>
           </a:p>
         </p:txBody>
@@ -4461,7 +4464,7 @@
               </a:defRPr>
             </a:pPr>
             <a:r>
-              <a:t>Pilot next</a:t>
+              <a:t>Reader image</a:t>
             </a:r>
           </a:p>
         </p:txBody>
@@ -4500,7 +4503,7 @@
               </a:defRPr>
             </a:pPr>
             <a:r>
-              <a:t>Representative supplier formats and languages. Independently adjudicated fields, lines and receipt balances.</a:t>
+              <a:t>All three Docker reader warmups passed in 63 seconds and recovered both synthetic lines.</a:t>
             </a:r>
           </a:p>
         </p:txBody>
@@ -4592,7 +4595,7 @@
               </a:defRPr>
             </a:pPr>
             <a:r>
-              <a:t>Measure value</a:t>
+              <a:t>Hosted boundary</a:t>
             </a:r>
           </a:p>
         </p:txBody>
@@ -4631,7 +4634,7 @@
               </a:defRPr>
             </a:pPr>
             <a:r>
-              <a:t>Minutes saved per invoice, correction count, false-ready rate, fallback share, latency and provider cost.</a:t>
+              <a:t>00005-zdk restored access. The complete feature release is not live; hosted lookup reports zero rows.</a:t>
             </a:r>
           </a:p>
         </p:txBody>
@@ -4735,7 +4738,7 @@
               </a:defRPr>
             </a:pPr>
             <a:r>
-              <a:t>A staged build plan with clear exits</a:t>
+              <a:t>Measured AI-off reader evidence</a:t>
             </a:r>
           </a:p>
         </p:txBody>
@@ -4774,7 +4777,7 @@
               </a:defRPr>
             </a:pPr>
             <a:r>
-              <a:t>4 OCT 2026  •  BUILD EVIDENCE AND PROPOSED NEXT STAGES</a:t>
+              <a:t>5 OCT 2026  •  MEASURED EVIDENCE AND PROPOSED NEXT STAGES</a:t>
             </a:r>
           </a:p>
         </p:txBody>
@@ -4905,23 +4908,7 @@
               </a:defRPr>
             </a:pPr>
             <a:r>
-              <a:t>Data contract</a:t>
-            </a:r>
-          </a:p>
-          <a:p>
-            <a:pPr>
-              <a:spcAft>
-                <a:spcPts val="1200"/>
-              </a:spcAft>
-              <a:defRPr sz="2100" b="1">
-                <a:solidFill>
-                  <a:srgbClr val="037E83"/>
-                </a:solidFill>
-                <a:latin typeface="Aptos"/>
-              </a:defRPr>
-            </a:pPr>
-            <a:r>
-              <a:t>1–2 weeks</a:t>
+              <a:t>Native tables</a:t>
             </a:r>
           </a:p>
         </p:txBody>
@@ -4960,7 +4947,7 @@
               </a:defRPr>
             </a:pPr>
             <a:r>
-              <a:t>Approve mappings and missing values. Accept the target workbook with the receiving team.</a:t>
+              <a:t>15/15 PDFs, 570/570 rows and 3,990/3,990 tested line facts exact in one layout family; 24.6 s first total, 12.9 s warm.</a:t>
             </a:r>
           </a:p>
         </p:txBody>
@@ -5052,23 +5039,7 @@
               </a:defRPr>
             </a:pPr>
             <a:r>
-              <a:t>Supplier evaluation</a:t>
-            </a:r>
-          </a:p>
-          <a:p>
-            <a:pPr>
-              <a:spcAft>
-                <a:spcPts val="1200"/>
-              </a:spcAft>
-              <a:defRPr sz="2100" b="1">
-                <a:solidFill>
-                  <a:srgbClr val="037E83"/>
-                </a:solidFill>
-                <a:latin typeface="Aptos"/>
-              </a:defRPr>
-            </a:pPr>
-            <a:r>
-              <a:t>2–3 weeks</a:t>
+              <a:t>PaddleOCR</a:t>
             </a:r>
           </a:p>
         </p:txBody>
@@ -5107,7 +5078,7 @@
               </a:defRPr>
             </a:pPr>
             <a:r>
-              <a:t>Evaluate at least 100 representative invoices and the difficult exception cases.</a:t>
+              <a:t>6/6 scan lines and 60/60 tested facts exact. Treating six descriptions as wrong gives a 60/66 = 90.91% floor.</a:t>
             </a:r>
           </a:p>
         </p:txBody>
@@ -5199,23 +5170,7 @@
               </a:defRPr>
             </a:pPr>
             <a:r>
-              <a:t>Production pilot</a:t>
-            </a:r>
-          </a:p>
-          <a:p>
-            <a:pPr>
-              <a:spcAft>
-                <a:spcPts val="1200"/>
-              </a:spcAft>
-              <a:defRPr sz="2100" b="1">
-                <a:solidFill>
-                  <a:srgbClr val="037E83"/>
-                </a:solidFill>
-                <a:latin typeface="Aptos"/>
-              </a:defRPr>
-            </a:pPr>
-            <a:r>
-              <a:t>3–5 weeks</a:t>
+              <a:t>Docling</a:t>
             </a:r>
           </a:p>
         </p:txBody>
@@ -5254,7 +5209,7 @@
               </a:defRPr>
             </a:pPr>
             <a:r>
-              <a:t>Add role separation, durable workers, backup restoration, monitoring and controlled UAT.</a:t>
+              <a:t>5/5, 1/1 and 17/17 native lines. Ten pages exceeded 528 s; three scans took 103–170 s and returned no reliable lines.</a:t>
             </a:r>
           </a:p>
         </p:txBody>
@@ -5293,7 +5248,7 @@
               </a:defRPr>
             </a:pPr>
             <a:r>
-              <a:t>Planning ranges assume available AP/data owners and a deliberately bounded initial invoice contract.</a:t>
+              <a:t>These bounded cohorts do not prove the expected 95% across suppliers, scans, languages and lengths.</a:t>
             </a:r>
           </a:p>
         </p:txBody>
@@ -5397,7 +5352,7 @@
               </a:defRPr>
             </a:pPr>
             <a:r>
-              <a:t>Extend the platform after invoice proof</a:t>
+              <a:t>Managed Vertex: useful evidence, narrow cohort</a:t>
             </a:r>
           </a:p>
         </p:txBody>
@@ -5436,7 +5391,7 @@
               </a:defRPr>
             </a:pPr>
             <a:r>
-              <a:t>4 OCT 2026  •  BUILD EVIDENCE AND PROPOSED NEXT STAGES</a:t>
+              <a:t>5 OCT 2026  •  MEASURED EVIDENCE AND PROPOSED NEXT STAGES</a:t>
             </a:r>
           </a:p>
         </p:txBody>
@@ -5567,7 +5522,7 @@
               </a:defRPr>
             </a:pPr>
             <a:r>
-              <a:t>New store or market</a:t>
+              <a:t>Measured result</a:t>
             </a:r>
           </a:p>
         </p:txBody>
@@ -5606,7 +5561,7 @@
               </a:defRPr>
             </a:pPr>
             <a:r>
-              <a:t>Search approved coverage; create supplier discovery and qualification cases only for gaps.</a:t>
+              <a:t>All source-tested fields were exact across 15 documents and 570 lines from one layout family.</a:t>
             </a:r>
           </a:p>
         </p:txBody>
@@ -5698,7 +5653,7 @@
               </a:defRPr>
             </a:pPr>
             <a:r>
-              <a:t>Supplier item intake</a:t>
+              <a:t>Measured usage</a:t>
             </a:r>
           </a:p>
         </p:txBody>
@@ -5737,7 +5692,7 @@
               </a:defRPr>
             </a:pPr>
             <a:r>
-              <a:t>Normalize item identity, codes, packaging and units. Route ambiguity to a data steward.</a:t>
+              <a:t>36,450 input and 91,892 output tokens including reasoning across 15 successful calls.</a:t>
             </a:r>
           </a:p>
         </p:txBody>
@@ -5829,7 +5784,7 @@
               </a:defRPr>
             </a:pPr>
             <a:r>
-              <a:t>Digital channels</a:t>
+              <a:t>Calculated cost</a:t>
             </a:r>
           </a:p>
         </p:txBody>
@@ -5868,7 +5823,46 @@
               </a:defRPr>
             </a:pPr>
             <a:r>
-              <a:t>Maintain versioned content, images, translations and channel rules separately from purchasing identity.</a:t>
+              <a:t>USD 0.3719325 at the published time-bounded rate; USD 24.7955 per 1,000 at the same mix.</a:t>
+            </a:r>
+          </a:p>
+        </p:txBody>
+      </p:sp>
+      <p:sp>
+        <p:nvSpPr>
+          <p:cNvPr id="15" name="TextBox 14"/>
+          <p:cNvSpPr txBox="1"/>
+          <p:nvPr/>
+        </p:nvSpPr>
+        <p:spPr>
+          <a:xfrm>
+            <a:off x="640080" y="5806440"/>
+            <a:ext cx="10789920" cy="411480"/>
+          </a:xfrm>
+          <a:prstGeom prst="rect">
+            <a:avLst/>
+          </a:prstGeom>
+          <a:noFill/>
+        </p:spPr>
+        <p:txBody>
+          <a:bodyPr wrap="square" lIns="109728" rIns="109728">
+            <a:spAutoFit/>
+          </a:bodyPr>
+          <a:lstStyle/>
+          <a:p>
+            <a:pPr>
+              <a:spcAft>
+                <a:spcPts val="1200"/>
+              </a:spcAft>
+              <a:defRPr sz="1400" b="0">
+                <a:solidFill>
+                  <a:srgbClr val="53717B"/>
+                </a:solidFill>
+                <a:latin typeface="Aptos"/>
+              </a:defRPr>
+            </a:pPr>
+            <a:r>
+              <a:t>Not an actual bill. Excludes retries, hosting, database, storage and network. Broad accuracy remains unproven.</a:t>
             </a:r>
           </a:p>
         </p:txBody>
@@ -5972,7 +5966,7 @@
               </a:defRPr>
             </a:pPr>
             <a:r>
-              <a:t>The next business decisions</a:t>
+              <a:t>Define 90% before measuring it</a:t>
             </a:r>
           </a:p>
         </p:txBody>
@@ -6011,7 +6005,7 @@
               </a:defRPr>
             </a:pPr>
             <a:r>
-              <a:t>4 OCT 2026  •  BUILD EVIDENCE AND PROPOSED NEXT STAGES</a:t>
+              <a:t>5 OCT 2026  •  MEASURED EVIDENCE AND PROPOSED NEXT STAGES</a:t>
             </a:r>
           </a:p>
         </p:txBody>
@@ -6051,6 +6045,1857 @@
             </a:pPr>
             <a:r>
               <a:t>14</a:t>
+            </a:r>
+          </a:p>
+        </p:txBody>
+      </p:sp>
+      <p:sp>
+        <p:nvSpPr>
+          <p:cNvPr id="6" name="Rounded Rectangle 5"/>
+          <p:cNvSpPr/>
+          <p:nvPr/>
+        </p:nvSpPr>
+        <p:spPr>
+          <a:xfrm>
+            <a:off x="594360" y="2103120"/>
+            <a:ext cx="3489960" cy="3474720"/>
+          </a:xfrm>
+          <a:prstGeom prst="roundRect">
+            <a:avLst/>
+          </a:prstGeom>
+          <a:solidFill>
+            <a:srgbClr val="FFFFFF"/>
+          </a:solidFill>
+          <a:ln>
+            <a:noFill/>
+          </a:ln>
+        </p:spPr>
+        <p:style>
+          <a:lnRef idx="1">
+            <a:schemeClr val="accent1"/>
+          </a:lnRef>
+          <a:fillRef idx="3">
+            <a:schemeClr val="accent1"/>
+          </a:fillRef>
+          <a:effectRef idx="2">
+            <a:schemeClr val="accent1"/>
+          </a:effectRef>
+          <a:fontRef idx="minor">
+            <a:schemeClr val="lt1"/>
+          </a:fontRef>
+        </p:style>
+        <p:txBody>
+          <a:bodyPr rtlCol="0" anchor="ctr" wrap="square" lIns="109728" rIns="109728"/>
+          <a:lstStyle/>
+          <a:p>
+            <a:pPr algn="ctr">
+              <a:spcAft>
+                <a:spcPts val="1200"/>
+              </a:spcAft>
+              <a:defRPr sz="2200" b="0">
+                <a:solidFill>
+                  <a:srgbClr val="163548"/>
+                </a:solidFill>
+                <a:latin typeface="Aptos"/>
+              </a:defRPr>
+            </a:pPr>
+          </a:p>
+        </p:txBody>
+      </p:sp>
+      <p:sp>
+        <p:nvSpPr>
+          <p:cNvPr id="7" name="TextBox 6"/>
+          <p:cNvSpPr txBox="1"/>
+          <p:nvPr/>
+        </p:nvSpPr>
+        <p:spPr>
+          <a:xfrm>
+            <a:off x="731520" y="2304288"/>
+            <a:ext cx="3215640" cy="960120"/>
+          </a:xfrm>
+          <a:prstGeom prst="rect">
+            <a:avLst/>
+          </a:prstGeom>
+          <a:noFill/>
+        </p:spPr>
+        <p:txBody>
+          <a:bodyPr wrap="square" lIns="109728" rIns="109728">
+            <a:spAutoFit/>
+          </a:bodyPr>
+          <a:lstStyle/>
+          <a:p>
+            <a:pPr>
+              <a:spcAft>
+                <a:spcPts val="1200"/>
+              </a:spcAft>
+              <a:defRPr sz="2100" b="1">
+                <a:solidFill>
+                  <a:srgbClr val="037E83"/>
+                </a:solidFill>
+                <a:latin typeface="Aptos"/>
+              </a:defRPr>
+            </a:pPr>
+            <a:r>
+              <a:t>Header exact</a:t>
+            </a:r>
+          </a:p>
+        </p:txBody>
+      </p:sp>
+      <p:sp>
+        <p:nvSpPr>
+          <p:cNvPr id="8" name="TextBox 7"/>
+          <p:cNvSpPr txBox="1"/>
+          <p:nvPr/>
+        </p:nvSpPr>
+        <p:spPr>
+          <a:xfrm>
+            <a:off x="731520" y="3383280"/>
+            <a:ext cx="3215640" cy="2011680"/>
+          </a:xfrm>
+          <a:prstGeom prst="rect">
+            <a:avLst/>
+          </a:prstGeom>
+          <a:noFill/>
+        </p:spPr>
+        <p:txBody>
+          <a:bodyPr wrap="square" lIns="109728" rIns="109728">
+            <a:spAutoFit/>
+          </a:bodyPr>
+          <a:lstStyle/>
+          <a:p>
+            <a:pPr>
+              <a:spcAft>
+                <a:spcPts val="1200"/>
+              </a:spcAft>
+              <a:defRPr sz="1900" b="0">
+                <a:solidFill>
+                  <a:srgbClr val="163548"/>
+                </a:solidFill>
+                <a:latin typeface="Aptos"/>
+              </a:defRPr>
+            </a:pPr>
+            <a:r>
+              <a:t>Target ≥90% over every frozen gold header cell, including expected nulls. Failures and timeouts score zero.</a:t>
+            </a:r>
+          </a:p>
+        </p:txBody>
+      </p:sp>
+      <p:sp>
+        <p:nvSpPr>
+          <p:cNvPr id="9" name="Rounded Rectangle 8"/>
+          <p:cNvSpPr/>
+          <p:nvPr/>
+        </p:nvSpPr>
+        <p:spPr>
+          <a:xfrm>
+            <a:off x="4248912" y="2103120"/>
+            <a:ext cx="3489960" cy="3474720"/>
+          </a:xfrm>
+          <a:prstGeom prst="roundRect">
+            <a:avLst/>
+          </a:prstGeom>
+          <a:solidFill>
+            <a:srgbClr val="FFFFFF"/>
+          </a:solidFill>
+          <a:ln>
+            <a:noFill/>
+          </a:ln>
+        </p:spPr>
+        <p:style>
+          <a:lnRef idx="1">
+            <a:schemeClr val="accent1"/>
+          </a:lnRef>
+          <a:fillRef idx="3">
+            <a:schemeClr val="accent1"/>
+          </a:fillRef>
+          <a:effectRef idx="2">
+            <a:schemeClr val="accent1"/>
+          </a:effectRef>
+          <a:fontRef idx="minor">
+            <a:schemeClr val="lt1"/>
+          </a:fontRef>
+        </p:style>
+        <p:txBody>
+          <a:bodyPr rtlCol="0" anchor="ctr" wrap="square" lIns="109728" rIns="109728"/>
+          <a:lstStyle/>
+          <a:p>
+            <a:pPr algn="ctr">
+              <a:spcAft>
+                <a:spcPts val="1200"/>
+              </a:spcAft>
+              <a:defRPr sz="2200" b="0">
+                <a:solidFill>
+                  <a:srgbClr val="163548"/>
+                </a:solidFill>
+                <a:latin typeface="Aptos"/>
+              </a:defRPr>
+            </a:pPr>
+          </a:p>
+        </p:txBody>
+      </p:sp>
+      <p:sp>
+        <p:nvSpPr>
+          <p:cNvPr id="10" name="TextBox 9"/>
+          <p:cNvSpPr txBox="1"/>
+          <p:nvPr/>
+        </p:nvSpPr>
+        <p:spPr>
+          <a:xfrm>
+            <a:off x="4386072" y="2304288"/>
+            <a:ext cx="3215640" cy="960120"/>
+          </a:xfrm>
+          <a:prstGeom prst="rect">
+            <a:avLst/>
+          </a:prstGeom>
+          <a:noFill/>
+        </p:spPr>
+        <p:txBody>
+          <a:bodyPr wrap="square" lIns="109728" rIns="109728">
+            <a:spAutoFit/>
+          </a:bodyPr>
+          <a:lstStyle/>
+          <a:p>
+            <a:pPr>
+              <a:spcAft>
+                <a:spcPts val="1200"/>
+              </a:spcAft>
+              <a:defRPr sz="2100" b="1">
+                <a:solidFill>
+                  <a:srgbClr val="037E83"/>
+                </a:solidFill>
+                <a:latin typeface="Aptos"/>
+              </a:defRPr>
+            </a:pPr>
+            <a:r>
+              <a:t>Line exact</a:t>
+            </a:r>
+          </a:p>
+        </p:txBody>
+      </p:sp>
+      <p:sp>
+        <p:nvSpPr>
+          <p:cNvPr id="11" name="TextBox 10"/>
+          <p:cNvSpPr txBox="1"/>
+          <p:nvPr/>
+        </p:nvSpPr>
+        <p:spPr>
+          <a:xfrm>
+            <a:off x="4386072" y="3383280"/>
+            <a:ext cx="3215640" cy="2011680"/>
+          </a:xfrm>
+          <a:prstGeom prst="rect">
+            <a:avLst/>
+          </a:prstGeom>
+          <a:noFill/>
+        </p:spPr>
+        <p:txBody>
+          <a:bodyPr wrap="square" lIns="109728" rIns="109728">
+            <a:spAutoFit/>
+          </a:bodyPr>
+          <a:lstStyle/>
+          <a:p>
+            <a:pPr>
+              <a:spcAft>
+                <a:spcPts val="1200"/>
+              </a:spcAft>
+              <a:defRPr sz="1900" b="0">
+                <a:solidFill>
+                  <a:srgbClr val="163548"/>
+                </a:solidFill>
+                <a:latin typeface="Aptos"/>
+              </a:defRPr>
+            </a:pPr>
+            <a:r>
+              <a:t>Target ≥90% exact cells after adjudicated line alignment; also report missing, extra and misaligned lines.</a:t>
+            </a:r>
+          </a:p>
+        </p:txBody>
+      </p:sp>
+      <p:sp>
+        <p:nvSpPr>
+          <p:cNvPr id="12" name="Rounded Rectangle 11"/>
+          <p:cNvSpPr/>
+          <p:nvPr/>
+        </p:nvSpPr>
+        <p:spPr>
+          <a:xfrm>
+            <a:off x="7903463" y="2103120"/>
+            <a:ext cx="3489960" cy="3474720"/>
+          </a:xfrm>
+          <a:prstGeom prst="roundRect">
+            <a:avLst/>
+          </a:prstGeom>
+          <a:solidFill>
+            <a:srgbClr val="FFFFFF"/>
+          </a:solidFill>
+          <a:ln>
+            <a:noFill/>
+          </a:ln>
+        </p:spPr>
+        <p:style>
+          <a:lnRef idx="1">
+            <a:schemeClr val="accent1"/>
+          </a:lnRef>
+          <a:fillRef idx="3">
+            <a:schemeClr val="accent1"/>
+          </a:fillRef>
+          <a:effectRef idx="2">
+            <a:schemeClr val="accent1"/>
+          </a:effectRef>
+          <a:fontRef idx="minor">
+            <a:schemeClr val="lt1"/>
+          </a:fontRef>
+        </p:style>
+        <p:txBody>
+          <a:bodyPr rtlCol="0" anchor="ctr" wrap="square" lIns="109728" rIns="109728"/>
+          <a:lstStyle/>
+          <a:p>
+            <a:pPr algn="ctr">
+              <a:spcAft>
+                <a:spcPts val="1200"/>
+              </a:spcAft>
+              <a:defRPr sz="2200" b="0">
+                <a:solidFill>
+                  <a:srgbClr val="163548"/>
+                </a:solidFill>
+                <a:latin typeface="Aptos"/>
+              </a:defRPr>
+            </a:pPr>
+          </a:p>
+        </p:txBody>
+      </p:sp>
+      <p:sp>
+        <p:nvSpPr>
+          <p:cNvPr id="13" name="TextBox 12"/>
+          <p:cNvSpPr txBox="1"/>
+          <p:nvPr/>
+        </p:nvSpPr>
+        <p:spPr>
+          <a:xfrm>
+            <a:off x="8040624" y="2304288"/>
+            <a:ext cx="3215640" cy="960120"/>
+          </a:xfrm>
+          <a:prstGeom prst="rect">
+            <a:avLst/>
+          </a:prstGeom>
+          <a:noFill/>
+        </p:spPr>
+        <p:txBody>
+          <a:bodyPr wrap="square" lIns="109728" rIns="109728">
+            <a:spAutoFit/>
+          </a:bodyPr>
+          <a:lstStyle/>
+          <a:p>
+            <a:pPr>
+              <a:spcAft>
+                <a:spcPts val="1200"/>
+              </a:spcAft>
+              <a:defRPr sz="2100" b="1">
+                <a:solidFill>
+                  <a:srgbClr val="037E83"/>
+                </a:solidFill>
+                <a:latin typeface="Aptos"/>
+              </a:defRPr>
+            </a:pPr>
+            <a:r>
+              <a:t>Zero correction</a:t>
+            </a:r>
+          </a:p>
+        </p:txBody>
+      </p:sp>
+      <p:sp>
+        <p:nvSpPr>
+          <p:cNvPr id="14" name="TextBox 13"/>
+          <p:cNvSpPr txBox="1"/>
+          <p:nvPr/>
+        </p:nvSpPr>
+        <p:spPr>
+          <a:xfrm>
+            <a:off x="8040624" y="3383280"/>
+            <a:ext cx="3215640" cy="2011680"/>
+          </a:xfrm>
+          <a:prstGeom prst="rect">
+            <a:avLst/>
+          </a:prstGeom>
+          <a:noFill/>
+        </p:spPr>
+        <p:txBody>
+          <a:bodyPr wrap="square" lIns="109728" rIns="109728">
+            <a:spAutoFit/>
+          </a:bodyPr>
+          <a:lstStyle/>
+          <a:p>
+            <a:pPr>
+              <a:spcAft>
+                <a:spcPts val="1200"/>
+              </a:spcAft>
+              <a:defRPr sz="1900" b="0">
+                <a:solidFill>
+                  <a:srgbClr val="163548"/>
+                </a:solidFill>
+                <a:latin typeface="Aptos"/>
+              </a:defRPr>
+            </a:pPr>
+            <a:r>
+              <a:t>Target ≥90% of all attempted invoices needing no extraction edit, plus zero false-ready approvals.</a:t>
+            </a:r>
+          </a:p>
+        </p:txBody>
+      </p:sp>
+      <p:sp>
+        <p:nvSpPr>
+          <p:cNvPr id="15" name="TextBox 14"/>
+          <p:cNvSpPr txBox="1"/>
+          <p:nvPr/>
+        </p:nvSpPr>
+        <p:spPr>
+          <a:xfrm>
+            <a:off x="640080" y="5806440"/>
+            <a:ext cx="10789920" cy="411480"/>
+          </a:xfrm>
+          <a:prstGeom prst="rect">
+            <a:avLst/>
+          </a:prstGeom>
+          <a:noFill/>
+        </p:spPr>
+        <p:txBody>
+          <a:bodyPr wrap="square" lIns="109728" rIns="109728">
+            <a:spAutoFit/>
+          </a:bodyPr>
+          <a:lstStyle/>
+          <a:p>
+            <a:pPr>
+              <a:spcAft>
+                <a:spcPts val="1200"/>
+              </a:spcAft>
+              <a:defRPr sz="1400" b="0">
+                <a:solidFill>
+                  <a:srgbClr val="53717B"/>
+                </a:solidFill>
+                <a:latin typeface="Aptos"/>
+              </a:defRPr>
+            </a:pPr>
+            <a:r>
+              <a:t>Stratify by supplier, native/scan, language, quality and length. Completeness, schema and arithmetic are diagnostics, not accuracy.</a:t>
+            </a:r>
+          </a:p>
+        </p:txBody>
+      </p:sp>
+    </p:spTree>
+  </p:cSld>
+  <p:clrMapOvr>
+    <a:masterClrMapping/>
+  </p:clrMapOvr>
+</p:sld>
+</file>
+
+<file path=ppt/slides/slide15.xml><?xml version="1.0" encoding="utf-8"?>
+<p:sld xmlns:a="http://schemas.openxmlformats.org/drawingml/2006/main" xmlns:p="http://schemas.openxmlformats.org/presentationml/2006/main" xmlns:r="http://schemas.openxmlformats.org/officeDocument/2006/relationships">
+  <p:cSld>
+    <p:bg>
+      <p:bgPr>
+        <a:solidFill>
+          <a:srgbClr val="F3F7F7"/>
+        </a:solidFill>
+        <a:effectLst/>
+      </p:bgPr>
+    </p:bg>
+    <p:spTree>
+      <p:nvGrpSpPr>
+        <p:cNvPr id="1" name=""/>
+        <p:cNvGrpSpPr/>
+        <p:nvPr/>
+      </p:nvGrpSpPr>
+      <p:grpSpPr/>
+      <p:sp>
+        <p:nvSpPr>
+          <p:cNvPr id="2" name="TextBox 1"/>
+          <p:cNvSpPr txBox="1"/>
+          <p:nvPr/>
+        </p:nvSpPr>
+        <p:spPr>
+          <a:xfrm>
+            <a:off x="548640" y="274320"/>
+            <a:ext cx="10972800" cy="274320"/>
+          </a:xfrm>
+          <a:prstGeom prst="rect">
+            <a:avLst/>
+          </a:prstGeom>
+          <a:noFill/>
+        </p:spPr>
+        <p:txBody>
+          <a:bodyPr wrap="square" lIns="109728" rIns="109728">
+            <a:spAutoFit/>
+          </a:bodyPr>
+          <a:lstStyle/>
+          <a:p>
+            <a:pPr>
+              <a:spcAft>
+                <a:spcPts val="1200"/>
+              </a:spcAft>
+              <a:defRPr sz="1100" b="1">
+                <a:solidFill>
+                  <a:srgbClr val="037E83"/>
+                </a:solidFill>
+                <a:latin typeface="Aptos"/>
+              </a:defRPr>
+            </a:pPr>
+            <a:r>
+              <a:t>INVOICE STUDIO / DECISION PACK</a:t>
+            </a:r>
+          </a:p>
+        </p:txBody>
+      </p:sp>
+      <p:sp>
+        <p:nvSpPr>
+          <p:cNvPr id="3" name="TextBox 2"/>
+          <p:cNvSpPr txBox="1"/>
+          <p:nvPr/>
+        </p:nvSpPr>
+        <p:spPr>
+          <a:xfrm>
+            <a:off x="548640" y="868680"/>
+            <a:ext cx="10972800" cy="1188720"/>
+          </a:xfrm>
+          <a:prstGeom prst="rect">
+            <a:avLst/>
+          </a:prstGeom>
+          <a:noFill/>
+        </p:spPr>
+        <p:txBody>
+          <a:bodyPr wrap="square" lIns="109728" rIns="109728">
+            <a:spAutoFit/>
+          </a:bodyPr>
+          <a:lstStyle/>
+          <a:p>
+            <a:pPr>
+              <a:spcAft>
+                <a:spcPts val="1200"/>
+              </a:spcAft>
+              <a:defRPr sz="3200" b="1">
+                <a:solidFill>
+                  <a:srgbClr val="112C3D"/>
+                </a:solidFill>
+                <a:latin typeface="Aptos"/>
+              </a:defRPr>
+            </a:pPr>
+            <a:r>
+              <a:t>A staged build plan with clear exits</a:t>
+            </a:r>
+          </a:p>
+        </p:txBody>
+      </p:sp>
+      <p:sp>
+        <p:nvSpPr>
+          <p:cNvPr id="4" name="TextBox 3"/>
+          <p:cNvSpPr txBox="1"/>
+          <p:nvPr/>
+        </p:nvSpPr>
+        <p:spPr>
+          <a:xfrm>
+            <a:off x="548640" y="6419088"/>
+            <a:ext cx="10058400" cy="274320"/>
+          </a:xfrm>
+          <a:prstGeom prst="rect">
+            <a:avLst/>
+          </a:prstGeom>
+          <a:noFill/>
+        </p:spPr>
+        <p:txBody>
+          <a:bodyPr wrap="square" lIns="109728" rIns="109728">
+            <a:spAutoFit/>
+          </a:bodyPr>
+          <a:lstStyle/>
+          <a:p>
+            <a:pPr>
+              <a:spcAft>
+                <a:spcPts val="1200"/>
+              </a:spcAft>
+              <a:defRPr sz="900" b="0">
+                <a:solidFill>
+                  <a:srgbClr val="53717B"/>
+                </a:solidFill>
+                <a:latin typeface="Aptos"/>
+              </a:defRPr>
+            </a:pPr>
+            <a:r>
+              <a:t>5 OCT 2026  •  MEASURED EVIDENCE AND PROPOSED NEXT STAGES</a:t>
+            </a:r>
+          </a:p>
+        </p:txBody>
+      </p:sp>
+      <p:sp>
+        <p:nvSpPr>
+          <p:cNvPr id="5" name="TextBox 4"/>
+          <p:cNvSpPr txBox="1"/>
+          <p:nvPr/>
+        </p:nvSpPr>
+        <p:spPr>
+          <a:xfrm>
+            <a:off x="10972800" y="6355080"/>
+            <a:ext cx="548640" cy="320040"/>
+          </a:xfrm>
+          <a:prstGeom prst="rect">
+            <a:avLst/>
+          </a:prstGeom>
+          <a:noFill/>
+        </p:spPr>
+        <p:txBody>
+          <a:bodyPr wrap="square" lIns="109728" rIns="109728">
+            <a:spAutoFit/>
+          </a:bodyPr>
+          <a:lstStyle/>
+          <a:p>
+            <a:pPr>
+              <a:spcAft>
+                <a:spcPts val="1200"/>
+              </a:spcAft>
+              <a:defRPr sz="1200" b="1">
+                <a:solidFill>
+                  <a:srgbClr val="037E83"/>
+                </a:solidFill>
+                <a:latin typeface="Aptos"/>
+              </a:defRPr>
+            </a:pPr>
+            <a:r>
+              <a:t>15</a:t>
+            </a:r>
+          </a:p>
+        </p:txBody>
+      </p:sp>
+      <p:sp>
+        <p:nvSpPr>
+          <p:cNvPr id="6" name="Rounded Rectangle 5"/>
+          <p:cNvSpPr/>
+          <p:nvPr/>
+        </p:nvSpPr>
+        <p:spPr>
+          <a:xfrm>
+            <a:off x="594360" y="2103120"/>
+            <a:ext cx="3489960" cy="3474720"/>
+          </a:xfrm>
+          <a:prstGeom prst="roundRect">
+            <a:avLst/>
+          </a:prstGeom>
+          <a:solidFill>
+            <a:srgbClr val="FFFFFF"/>
+          </a:solidFill>
+          <a:ln>
+            <a:noFill/>
+          </a:ln>
+        </p:spPr>
+        <p:style>
+          <a:lnRef idx="1">
+            <a:schemeClr val="accent1"/>
+          </a:lnRef>
+          <a:fillRef idx="3">
+            <a:schemeClr val="accent1"/>
+          </a:fillRef>
+          <a:effectRef idx="2">
+            <a:schemeClr val="accent1"/>
+          </a:effectRef>
+          <a:fontRef idx="minor">
+            <a:schemeClr val="lt1"/>
+          </a:fontRef>
+        </p:style>
+        <p:txBody>
+          <a:bodyPr rtlCol="0" anchor="ctr" wrap="square" lIns="109728" rIns="109728"/>
+          <a:lstStyle/>
+          <a:p>
+            <a:pPr algn="ctr">
+              <a:spcAft>
+                <a:spcPts val="1200"/>
+              </a:spcAft>
+              <a:defRPr sz="2200" b="0">
+                <a:solidFill>
+                  <a:srgbClr val="163548"/>
+                </a:solidFill>
+                <a:latin typeface="Aptos"/>
+              </a:defRPr>
+            </a:pPr>
+          </a:p>
+        </p:txBody>
+      </p:sp>
+      <p:sp>
+        <p:nvSpPr>
+          <p:cNvPr id="7" name="TextBox 6"/>
+          <p:cNvSpPr txBox="1"/>
+          <p:nvPr/>
+        </p:nvSpPr>
+        <p:spPr>
+          <a:xfrm>
+            <a:off x="731520" y="2304288"/>
+            <a:ext cx="3215640" cy="960120"/>
+          </a:xfrm>
+          <a:prstGeom prst="rect">
+            <a:avLst/>
+          </a:prstGeom>
+          <a:noFill/>
+        </p:spPr>
+        <p:txBody>
+          <a:bodyPr wrap="square" lIns="109728" rIns="109728">
+            <a:spAutoFit/>
+          </a:bodyPr>
+          <a:lstStyle/>
+          <a:p>
+            <a:pPr>
+              <a:spcAft>
+                <a:spcPts val="1200"/>
+              </a:spcAft>
+              <a:defRPr sz="2100" b="1">
+                <a:solidFill>
+                  <a:srgbClr val="037E83"/>
+                </a:solidFill>
+                <a:latin typeface="Aptos"/>
+              </a:defRPr>
+            </a:pPr>
+            <a:r>
+              <a:t>Data contract</a:t>
+            </a:r>
+          </a:p>
+          <a:p>
+            <a:pPr>
+              <a:spcAft>
+                <a:spcPts val="1200"/>
+              </a:spcAft>
+              <a:defRPr sz="2100" b="1">
+                <a:solidFill>
+                  <a:srgbClr val="037E83"/>
+                </a:solidFill>
+                <a:latin typeface="Aptos"/>
+              </a:defRPr>
+            </a:pPr>
+            <a:r>
+              <a:t>1–2 weeks</a:t>
+            </a:r>
+          </a:p>
+        </p:txBody>
+      </p:sp>
+      <p:sp>
+        <p:nvSpPr>
+          <p:cNvPr id="8" name="TextBox 7"/>
+          <p:cNvSpPr txBox="1"/>
+          <p:nvPr/>
+        </p:nvSpPr>
+        <p:spPr>
+          <a:xfrm>
+            <a:off x="731520" y="3383280"/>
+            <a:ext cx="3215640" cy="2011680"/>
+          </a:xfrm>
+          <a:prstGeom prst="rect">
+            <a:avLst/>
+          </a:prstGeom>
+          <a:noFill/>
+        </p:spPr>
+        <p:txBody>
+          <a:bodyPr wrap="square" lIns="109728" rIns="109728">
+            <a:spAutoFit/>
+          </a:bodyPr>
+          <a:lstStyle/>
+          <a:p>
+            <a:pPr>
+              <a:spcAft>
+                <a:spcPts val="1200"/>
+              </a:spcAft>
+              <a:defRPr sz="1900" b="0">
+                <a:solidFill>
+                  <a:srgbClr val="163548"/>
+                </a:solidFill>
+                <a:latin typeface="Aptos"/>
+              </a:defRPr>
+            </a:pPr>
+            <a:r>
+              <a:t>Approve mappings and missing values. Accept the target workbook with the receiving team.</a:t>
+            </a:r>
+          </a:p>
+        </p:txBody>
+      </p:sp>
+      <p:sp>
+        <p:nvSpPr>
+          <p:cNvPr id="9" name="Rounded Rectangle 8"/>
+          <p:cNvSpPr/>
+          <p:nvPr/>
+        </p:nvSpPr>
+        <p:spPr>
+          <a:xfrm>
+            <a:off x="4248912" y="2103120"/>
+            <a:ext cx="3489960" cy="3474720"/>
+          </a:xfrm>
+          <a:prstGeom prst="roundRect">
+            <a:avLst/>
+          </a:prstGeom>
+          <a:solidFill>
+            <a:srgbClr val="FFFFFF"/>
+          </a:solidFill>
+          <a:ln>
+            <a:noFill/>
+          </a:ln>
+        </p:spPr>
+        <p:style>
+          <a:lnRef idx="1">
+            <a:schemeClr val="accent1"/>
+          </a:lnRef>
+          <a:fillRef idx="3">
+            <a:schemeClr val="accent1"/>
+          </a:fillRef>
+          <a:effectRef idx="2">
+            <a:schemeClr val="accent1"/>
+          </a:effectRef>
+          <a:fontRef idx="minor">
+            <a:schemeClr val="lt1"/>
+          </a:fontRef>
+        </p:style>
+        <p:txBody>
+          <a:bodyPr rtlCol="0" anchor="ctr" wrap="square" lIns="109728" rIns="109728"/>
+          <a:lstStyle/>
+          <a:p>
+            <a:pPr algn="ctr">
+              <a:spcAft>
+                <a:spcPts val="1200"/>
+              </a:spcAft>
+              <a:defRPr sz="2200" b="0">
+                <a:solidFill>
+                  <a:srgbClr val="163548"/>
+                </a:solidFill>
+                <a:latin typeface="Aptos"/>
+              </a:defRPr>
+            </a:pPr>
+          </a:p>
+        </p:txBody>
+      </p:sp>
+      <p:sp>
+        <p:nvSpPr>
+          <p:cNvPr id="10" name="TextBox 9"/>
+          <p:cNvSpPr txBox="1"/>
+          <p:nvPr/>
+        </p:nvSpPr>
+        <p:spPr>
+          <a:xfrm>
+            <a:off x="4386072" y="2304288"/>
+            <a:ext cx="3215640" cy="960120"/>
+          </a:xfrm>
+          <a:prstGeom prst="rect">
+            <a:avLst/>
+          </a:prstGeom>
+          <a:noFill/>
+        </p:spPr>
+        <p:txBody>
+          <a:bodyPr wrap="square" lIns="109728" rIns="109728">
+            <a:spAutoFit/>
+          </a:bodyPr>
+          <a:lstStyle/>
+          <a:p>
+            <a:pPr>
+              <a:spcAft>
+                <a:spcPts val="1200"/>
+              </a:spcAft>
+              <a:defRPr sz="2100" b="1">
+                <a:solidFill>
+                  <a:srgbClr val="037E83"/>
+                </a:solidFill>
+                <a:latin typeface="Aptos"/>
+              </a:defRPr>
+            </a:pPr>
+            <a:r>
+              <a:t>Supplier evaluation</a:t>
+            </a:r>
+          </a:p>
+          <a:p>
+            <a:pPr>
+              <a:spcAft>
+                <a:spcPts val="1200"/>
+              </a:spcAft>
+              <a:defRPr sz="2100" b="1">
+                <a:solidFill>
+                  <a:srgbClr val="037E83"/>
+                </a:solidFill>
+                <a:latin typeface="Aptos"/>
+              </a:defRPr>
+            </a:pPr>
+            <a:r>
+              <a:t>2–3 weeks</a:t>
+            </a:r>
+          </a:p>
+        </p:txBody>
+      </p:sp>
+      <p:sp>
+        <p:nvSpPr>
+          <p:cNvPr id="11" name="TextBox 10"/>
+          <p:cNvSpPr txBox="1"/>
+          <p:nvPr/>
+        </p:nvSpPr>
+        <p:spPr>
+          <a:xfrm>
+            <a:off x="4386072" y="3383280"/>
+            <a:ext cx="3215640" cy="2011680"/>
+          </a:xfrm>
+          <a:prstGeom prst="rect">
+            <a:avLst/>
+          </a:prstGeom>
+          <a:noFill/>
+        </p:spPr>
+        <p:txBody>
+          <a:bodyPr wrap="square" lIns="109728" rIns="109728">
+            <a:spAutoFit/>
+          </a:bodyPr>
+          <a:lstStyle/>
+          <a:p>
+            <a:pPr>
+              <a:spcAft>
+                <a:spcPts val="1200"/>
+              </a:spcAft>
+              <a:defRPr sz="1900" b="0">
+                <a:solidFill>
+                  <a:srgbClr val="163548"/>
+                </a:solidFill>
+                <a:latin typeface="Aptos"/>
+              </a:defRPr>
+            </a:pPr>
+            <a:r>
+              <a:t>Evaluate at least 100 representative invoices and the difficult exception cases.</a:t>
+            </a:r>
+          </a:p>
+        </p:txBody>
+      </p:sp>
+      <p:sp>
+        <p:nvSpPr>
+          <p:cNvPr id="12" name="Rounded Rectangle 11"/>
+          <p:cNvSpPr/>
+          <p:nvPr/>
+        </p:nvSpPr>
+        <p:spPr>
+          <a:xfrm>
+            <a:off x="7903463" y="2103120"/>
+            <a:ext cx="3489960" cy="3474720"/>
+          </a:xfrm>
+          <a:prstGeom prst="roundRect">
+            <a:avLst/>
+          </a:prstGeom>
+          <a:solidFill>
+            <a:srgbClr val="FFFFFF"/>
+          </a:solidFill>
+          <a:ln>
+            <a:noFill/>
+          </a:ln>
+        </p:spPr>
+        <p:style>
+          <a:lnRef idx="1">
+            <a:schemeClr val="accent1"/>
+          </a:lnRef>
+          <a:fillRef idx="3">
+            <a:schemeClr val="accent1"/>
+          </a:fillRef>
+          <a:effectRef idx="2">
+            <a:schemeClr val="accent1"/>
+          </a:effectRef>
+          <a:fontRef idx="minor">
+            <a:schemeClr val="lt1"/>
+          </a:fontRef>
+        </p:style>
+        <p:txBody>
+          <a:bodyPr rtlCol="0" anchor="ctr" wrap="square" lIns="109728" rIns="109728"/>
+          <a:lstStyle/>
+          <a:p>
+            <a:pPr algn="ctr">
+              <a:spcAft>
+                <a:spcPts val="1200"/>
+              </a:spcAft>
+              <a:defRPr sz="2200" b="0">
+                <a:solidFill>
+                  <a:srgbClr val="163548"/>
+                </a:solidFill>
+                <a:latin typeface="Aptos"/>
+              </a:defRPr>
+            </a:pPr>
+          </a:p>
+        </p:txBody>
+      </p:sp>
+      <p:sp>
+        <p:nvSpPr>
+          <p:cNvPr id="13" name="TextBox 12"/>
+          <p:cNvSpPr txBox="1"/>
+          <p:nvPr/>
+        </p:nvSpPr>
+        <p:spPr>
+          <a:xfrm>
+            <a:off x="8040624" y="2304288"/>
+            <a:ext cx="3215640" cy="960120"/>
+          </a:xfrm>
+          <a:prstGeom prst="rect">
+            <a:avLst/>
+          </a:prstGeom>
+          <a:noFill/>
+        </p:spPr>
+        <p:txBody>
+          <a:bodyPr wrap="square" lIns="109728" rIns="109728">
+            <a:spAutoFit/>
+          </a:bodyPr>
+          <a:lstStyle/>
+          <a:p>
+            <a:pPr>
+              <a:spcAft>
+                <a:spcPts val="1200"/>
+              </a:spcAft>
+              <a:defRPr sz="2100" b="1">
+                <a:solidFill>
+                  <a:srgbClr val="037E83"/>
+                </a:solidFill>
+                <a:latin typeface="Aptos"/>
+              </a:defRPr>
+            </a:pPr>
+            <a:r>
+              <a:t>Production pilot</a:t>
+            </a:r>
+          </a:p>
+          <a:p>
+            <a:pPr>
+              <a:spcAft>
+                <a:spcPts val="1200"/>
+              </a:spcAft>
+              <a:defRPr sz="2100" b="1">
+                <a:solidFill>
+                  <a:srgbClr val="037E83"/>
+                </a:solidFill>
+                <a:latin typeface="Aptos"/>
+              </a:defRPr>
+            </a:pPr>
+            <a:r>
+              <a:t>3–5 weeks</a:t>
+            </a:r>
+          </a:p>
+        </p:txBody>
+      </p:sp>
+      <p:sp>
+        <p:nvSpPr>
+          <p:cNvPr id="14" name="TextBox 13"/>
+          <p:cNvSpPr txBox="1"/>
+          <p:nvPr/>
+        </p:nvSpPr>
+        <p:spPr>
+          <a:xfrm>
+            <a:off x="8040624" y="3383280"/>
+            <a:ext cx="3215640" cy="2011680"/>
+          </a:xfrm>
+          <a:prstGeom prst="rect">
+            <a:avLst/>
+          </a:prstGeom>
+          <a:noFill/>
+        </p:spPr>
+        <p:txBody>
+          <a:bodyPr wrap="square" lIns="109728" rIns="109728">
+            <a:spAutoFit/>
+          </a:bodyPr>
+          <a:lstStyle/>
+          <a:p>
+            <a:pPr>
+              <a:spcAft>
+                <a:spcPts val="1200"/>
+              </a:spcAft>
+              <a:defRPr sz="1900" b="0">
+                <a:solidFill>
+                  <a:srgbClr val="163548"/>
+                </a:solidFill>
+                <a:latin typeface="Aptos"/>
+              </a:defRPr>
+            </a:pPr>
+            <a:r>
+              <a:t>Add role separation, durable workers, backup restoration, monitoring and controlled UAT.</a:t>
+            </a:r>
+          </a:p>
+        </p:txBody>
+      </p:sp>
+      <p:sp>
+        <p:nvSpPr>
+          <p:cNvPr id="15" name="TextBox 14"/>
+          <p:cNvSpPr txBox="1"/>
+          <p:nvPr/>
+        </p:nvSpPr>
+        <p:spPr>
+          <a:xfrm>
+            <a:off x="640080" y="5806440"/>
+            <a:ext cx="10789920" cy="411480"/>
+          </a:xfrm>
+          <a:prstGeom prst="rect">
+            <a:avLst/>
+          </a:prstGeom>
+          <a:noFill/>
+        </p:spPr>
+        <p:txBody>
+          <a:bodyPr wrap="square" lIns="109728" rIns="109728">
+            <a:spAutoFit/>
+          </a:bodyPr>
+          <a:lstStyle/>
+          <a:p>
+            <a:pPr>
+              <a:spcAft>
+                <a:spcPts val="1200"/>
+              </a:spcAft>
+              <a:defRPr sz="1400" b="0">
+                <a:solidFill>
+                  <a:srgbClr val="53717B"/>
+                </a:solidFill>
+                <a:latin typeface="Aptos"/>
+              </a:defRPr>
+            </a:pPr>
+            <a:r>
+              <a:t>Planning ranges assume available AP/data owners and a deliberately bounded initial invoice contract.</a:t>
+            </a:r>
+          </a:p>
+        </p:txBody>
+      </p:sp>
+    </p:spTree>
+  </p:cSld>
+  <p:clrMapOvr>
+    <a:masterClrMapping/>
+  </p:clrMapOvr>
+</p:sld>
+</file>
+
+<file path=ppt/slides/slide16.xml><?xml version="1.0" encoding="utf-8"?>
+<p:sld xmlns:a="http://schemas.openxmlformats.org/drawingml/2006/main" xmlns:p="http://schemas.openxmlformats.org/presentationml/2006/main" xmlns:r="http://schemas.openxmlformats.org/officeDocument/2006/relationships">
+  <p:cSld>
+    <p:bg>
+      <p:bgPr>
+        <a:solidFill>
+          <a:srgbClr val="F3F7F7"/>
+        </a:solidFill>
+        <a:effectLst/>
+      </p:bgPr>
+    </p:bg>
+    <p:spTree>
+      <p:nvGrpSpPr>
+        <p:cNvPr id="1" name=""/>
+        <p:cNvGrpSpPr/>
+        <p:nvPr/>
+      </p:nvGrpSpPr>
+      <p:grpSpPr/>
+      <p:sp>
+        <p:nvSpPr>
+          <p:cNvPr id="2" name="TextBox 1"/>
+          <p:cNvSpPr txBox="1"/>
+          <p:nvPr/>
+        </p:nvSpPr>
+        <p:spPr>
+          <a:xfrm>
+            <a:off x="548640" y="274320"/>
+            <a:ext cx="10972800" cy="274320"/>
+          </a:xfrm>
+          <a:prstGeom prst="rect">
+            <a:avLst/>
+          </a:prstGeom>
+          <a:noFill/>
+        </p:spPr>
+        <p:txBody>
+          <a:bodyPr wrap="square" lIns="109728" rIns="109728">
+            <a:spAutoFit/>
+          </a:bodyPr>
+          <a:lstStyle/>
+          <a:p>
+            <a:pPr>
+              <a:spcAft>
+                <a:spcPts val="1200"/>
+              </a:spcAft>
+              <a:defRPr sz="1100" b="1">
+                <a:solidFill>
+                  <a:srgbClr val="037E83"/>
+                </a:solidFill>
+                <a:latin typeface="Aptos"/>
+              </a:defRPr>
+            </a:pPr>
+            <a:r>
+              <a:t>INVOICE STUDIO / DECISION PACK</a:t>
+            </a:r>
+          </a:p>
+        </p:txBody>
+      </p:sp>
+      <p:sp>
+        <p:nvSpPr>
+          <p:cNvPr id="3" name="TextBox 2"/>
+          <p:cNvSpPr txBox="1"/>
+          <p:nvPr/>
+        </p:nvSpPr>
+        <p:spPr>
+          <a:xfrm>
+            <a:off x="548640" y="868680"/>
+            <a:ext cx="10972800" cy="1188720"/>
+          </a:xfrm>
+          <a:prstGeom prst="rect">
+            <a:avLst/>
+          </a:prstGeom>
+          <a:noFill/>
+        </p:spPr>
+        <p:txBody>
+          <a:bodyPr wrap="square" lIns="109728" rIns="109728">
+            <a:spAutoFit/>
+          </a:bodyPr>
+          <a:lstStyle/>
+          <a:p>
+            <a:pPr>
+              <a:spcAft>
+                <a:spcPts val="1200"/>
+              </a:spcAft>
+              <a:defRPr sz="3200" b="1">
+                <a:solidFill>
+                  <a:srgbClr val="112C3D"/>
+                </a:solidFill>
+                <a:latin typeface="Aptos"/>
+              </a:defRPr>
+            </a:pPr>
+            <a:r>
+              <a:t>Extend the platform after invoice proof</a:t>
+            </a:r>
+          </a:p>
+        </p:txBody>
+      </p:sp>
+      <p:sp>
+        <p:nvSpPr>
+          <p:cNvPr id="4" name="TextBox 3"/>
+          <p:cNvSpPr txBox="1"/>
+          <p:nvPr/>
+        </p:nvSpPr>
+        <p:spPr>
+          <a:xfrm>
+            <a:off x="548640" y="6419088"/>
+            <a:ext cx="10058400" cy="274320"/>
+          </a:xfrm>
+          <a:prstGeom prst="rect">
+            <a:avLst/>
+          </a:prstGeom>
+          <a:noFill/>
+        </p:spPr>
+        <p:txBody>
+          <a:bodyPr wrap="square" lIns="109728" rIns="109728">
+            <a:spAutoFit/>
+          </a:bodyPr>
+          <a:lstStyle/>
+          <a:p>
+            <a:pPr>
+              <a:spcAft>
+                <a:spcPts val="1200"/>
+              </a:spcAft>
+              <a:defRPr sz="900" b="0">
+                <a:solidFill>
+                  <a:srgbClr val="53717B"/>
+                </a:solidFill>
+                <a:latin typeface="Aptos"/>
+              </a:defRPr>
+            </a:pPr>
+            <a:r>
+              <a:t>5 OCT 2026  •  MEASURED EVIDENCE AND PROPOSED NEXT STAGES</a:t>
+            </a:r>
+          </a:p>
+        </p:txBody>
+      </p:sp>
+      <p:sp>
+        <p:nvSpPr>
+          <p:cNvPr id="5" name="TextBox 4"/>
+          <p:cNvSpPr txBox="1"/>
+          <p:nvPr/>
+        </p:nvSpPr>
+        <p:spPr>
+          <a:xfrm>
+            <a:off x="10972800" y="6355080"/>
+            <a:ext cx="548640" cy="320040"/>
+          </a:xfrm>
+          <a:prstGeom prst="rect">
+            <a:avLst/>
+          </a:prstGeom>
+          <a:noFill/>
+        </p:spPr>
+        <p:txBody>
+          <a:bodyPr wrap="square" lIns="109728" rIns="109728">
+            <a:spAutoFit/>
+          </a:bodyPr>
+          <a:lstStyle/>
+          <a:p>
+            <a:pPr>
+              <a:spcAft>
+                <a:spcPts val="1200"/>
+              </a:spcAft>
+              <a:defRPr sz="1200" b="1">
+                <a:solidFill>
+                  <a:srgbClr val="037E83"/>
+                </a:solidFill>
+                <a:latin typeface="Aptos"/>
+              </a:defRPr>
+            </a:pPr>
+            <a:r>
+              <a:t>16</a:t>
+            </a:r>
+          </a:p>
+        </p:txBody>
+      </p:sp>
+      <p:sp>
+        <p:nvSpPr>
+          <p:cNvPr id="6" name="Rounded Rectangle 5"/>
+          <p:cNvSpPr/>
+          <p:nvPr/>
+        </p:nvSpPr>
+        <p:spPr>
+          <a:xfrm>
+            <a:off x="594360" y="2103120"/>
+            <a:ext cx="3489960" cy="3474720"/>
+          </a:xfrm>
+          <a:prstGeom prst="roundRect">
+            <a:avLst/>
+          </a:prstGeom>
+          <a:solidFill>
+            <a:srgbClr val="FFFFFF"/>
+          </a:solidFill>
+          <a:ln>
+            <a:noFill/>
+          </a:ln>
+        </p:spPr>
+        <p:style>
+          <a:lnRef idx="1">
+            <a:schemeClr val="accent1"/>
+          </a:lnRef>
+          <a:fillRef idx="3">
+            <a:schemeClr val="accent1"/>
+          </a:fillRef>
+          <a:effectRef idx="2">
+            <a:schemeClr val="accent1"/>
+          </a:effectRef>
+          <a:fontRef idx="minor">
+            <a:schemeClr val="lt1"/>
+          </a:fontRef>
+        </p:style>
+        <p:txBody>
+          <a:bodyPr rtlCol="0" anchor="ctr" wrap="square" lIns="109728" rIns="109728"/>
+          <a:lstStyle/>
+          <a:p>
+            <a:pPr algn="ctr">
+              <a:spcAft>
+                <a:spcPts val="1200"/>
+              </a:spcAft>
+              <a:defRPr sz="2200" b="0">
+                <a:solidFill>
+                  <a:srgbClr val="163548"/>
+                </a:solidFill>
+                <a:latin typeface="Aptos"/>
+              </a:defRPr>
+            </a:pPr>
+          </a:p>
+        </p:txBody>
+      </p:sp>
+      <p:sp>
+        <p:nvSpPr>
+          <p:cNvPr id="7" name="TextBox 6"/>
+          <p:cNvSpPr txBox="1"/>
+          <p:nvPr/>
+        </p:nvSpPr>
+        <p:spPr>
+          <a:xfrm>
+            <a:off x="731520" y="2304288"/>
+            <a:ext cx="3215640" cy="960120"/>
+          </a:xfrm>
+          <a:prstGeom prst="rect">
+            <a:avLst/>
+          </a:prstGeom>
+          <a:noFill/>
+        </p:spPr>
+        <p:txBody>
+          <a:bodyPr wrap="square" lIns="109728" rIns="109728">
+            <a:spAutoFit/>
+          </a:bodyPr>
+          <a:lstStyle/>
+          <a:p>
+            <a:pPr>
+              <a:spcAft>
+                <a:spcPts val="1200"/>
+              </a:spcAft>
+              <a:defRPr sz="2100" b="1">
+                <a:solidFill>
+                  <a:srgbClr val="037E83"/>
+                </a:solidFill>
+                <a:latin typeface="Aptos"/>
+              </a:defRPr>
+            </a:pPr>
+            <a:r>
+              <a:t>New store or market</a:t>
+            </a:r>
+          </a:p>
+        </p:txBody>
+      </p:sp>
+      <p:sp>
+        <p:nvSpPr>
+          <p:cNvPr id="8" name="TextBox 7"/>
+          <p:cNvSpPr txBox="1"/>
+          <p:nvPr/>
+        </p:nvSpPr>
+        <p:spPr>
+          <a:xfrm>
+            <a:off x="731520" y="3383280"/>
+            <a:ext cx="3215640" cy="2011680"/>
+          </a:xfrm>
+          <a:prstGeom prst="rect">
+            <a:avLst/>
+          </a:prstGeom>
+          <a:noFill/>
+        </p:spPr>
+        <p:txBody>
+          <a:bodyPr wrap="square" lIns="109728" rIns="109728">
+            <a:spAutoFit/>
+          </a:bodyPr>
+          <a:lstStyle/>
+          <a:p>
+            <a:pPr>
+              <a:spcAft>
+                <a:spcPts val="1200"/>
+              </a:spcAft>
+              <a:defRPr sz="1900" b="0">
+                <a:solidFill>
+                  <a:srgbClr val="163548"/>
+                </a:solidFill>
+                <a:latin typeface="Aptos"/>
+              </a:defRPr>
+            </a:pPr>
+            <a:r>
+              <a:t>Search approved coverage; create supplier discovery and qualification cases only for gaps.</a:t>
+            </a:r>
+          </a:p>
+        </p:txBody>
+      </p:sp>
+      <p:sp>
+        <p:nvSpPr>
+          <p:cNvPr id="9" name="Rounded Rectangle 8"/>
+          <p:cNvSpPr/>
+          <p:nvPr/>
+        </p:nvSpPr>
+        <p:spPr>
+          <a:xfrm>
+            <a:off x="4248912" y="2103120"/>
+            <a:ext cx="3489960" cy="3474720"/>
+          </a:xfrm>
+          <a:prstGeom prst="roundRect">
+            <a:avLst/>
+          </a:prstGeom>
+          <a:solidFill>
+            <a:srgbClr val="FFFFFF"/>
+          </a:solidFill>
+          <a:ln>
+            <a:noFill/>
+          </a:ln>
+        </p:spPr>
+        <p:style>
+          <a:lnRef idx="1">
+            <a:schemeClr val="accent1"/>
+          </a:lnRef>
+          <a:fillRef idx="3">
+            <a:schemeClr val="accent1"/>
+          </a:fillRef>
+          <a:effectRef idx="2">
+            <a:schemeClr val="accent1"/>
+          </a:effectRef>
+          <a:fontRef idx="minor">
+            <a:schemeClr val="lt1"/>
+          </a:fontRef>
+        </p:style>
+        <p:txBody>
+          <a:bodyPr rtlCol="0" anchor="ctr" wrap="square" lIns="109728" rIns="109728"/>
+          <a:lstStyle/>
+          <a:p>
+            <a:pPr algn="ctr">
+              <a:spcAft>
+                <a:spcPts val="1200"/>
+              </a:spcAft>
+              <a:defRPr sz="2200" b="0">
+                <a:solidFill>
+                  <a:srgbClr val="163548"/>
+                </a:solidFill>
+                <a:latin typeface="Aptos"/>
+              </a:defRPr>
+            </a:pPr>
+          </a:p>
+        </p:txBody>
+      </p:sp>
+      <p:sp>
+        <p:nvSpPr>
+          <p:cNvPr id="10" name="TextBox 9"/>
+          <p:cNvSpPr txBox="1"/>
+          <p:nvPr/>
+        </p:nvSpPr>
+        <p:spPr>
+          <a:xfrm>
+            <a:off x="4386072" y="2304288"/>
+            <a:ext cx="3215640" cy="960120"/>
+          </a:xfrm>
+          <a:prstGeom prst="rect">
+            <a:avLst/>
+          </a:prstGeom>
+          <a:noFill/>
+        </p:spPr>
+        <p:txBody>
+          <a:bodyPr wrap="square" lIns="109728" rIns="109728">
+            <a:spAutoFit/>
+          </a:bodyPr>
+          <a:lstStyle/>
+          <a:p>
+            <a:pPr>
+              <a:spcAft>
+                <a:spcPts val="1200"/>
+              </a:spcAft>
+              <a:defRPr sz="2100" b="1">
+                <a:solidFill>
+                  <a:srgbClr val="037E83"/>
+                </a:solidFill>
+                <a:latin typeface="Aptos"/>
+              </a:defRPr>
+            </a:pPr>
+            <a:r>
+              <a:t>Supplier item intake</a:t>
+            </a:r>
+          </a:p>
+        </p:txBody>
+      </p:sp>
+      <p:sp>
+        <p:nvSpPr>
+          <p:cNvPr id="11" name="TextBox 10"/>
+          <p:cNvSpPr txBox="1"/>
+          <p:nvPr/>
+        </p:nvSpPr>
+        <p:spPr>
+          <a:xfrm>
+            <a:off x="4386072" y="3383280"/>
+            <a:ext cx="3215640" cy="2011680"/>
+          </a:xfrm>
+          <a:prstGeom prst="rect">
+            <a:avLst/>
+          </a:prstGeom>
+          <a:noFill/>
+        </p:spPr>
+        <p:txBody>
+          <a:bodyPr wrap="square" lIns="109728" rIns="109728">
+            <a:spAutoFit/>
+          </a:bodyPr>
+          <a:lstStyle/>
+          <a:p>
+            <a:pPr>
+              <a:spcAft>
+                <a:spcPts val="1200"/>
+              </a:spcAft>
+              <a:defRPr sz="1900" b="0">
+                <a:solidFill>
+                  <a:srgbClr val="163548"/>
+                </a:solidFill>
+                <a:latin typeface="Aptos"/>
+              </a:defRPr>
+            </a:pPr>
+            <a:r>
+              <a:t>Normalize item identity, codes, packaging and units. Route ambiguity to a data steward.</a:t>
+            </a:r>
+          </a:p>
+        </p:txBody>
+      </p:sp>
+      <p:sp>
+        <p:nvSpPr>
+          <p:cNvPr id="12" name="Rounded Rectangle 11"/>
+          <p:cNvSpPr/>
+          <p:nvPr/>
+        </p:nvSpPr>
+        <p:spPr>
+          <a:xfrm>
+            <a:off x="7903463" y="2103120"/>
+            <a:ext cx="3489960" cy="3474720"/>
+          </a:xfrm>
+          <a:prstGeom prst="roundRect">
+            <a:avLst/>
+          </a:prstGeom>
+          <a:solidFill>
+            <a:srgbClr val="FFFFFF"/>
+          </a:solidFill>
+          <a:ln>
+            <a:noFill/>
+          </a:ln>
+        </p:spPr>
+        <p:style>
+          <a:lnRef idx="1">
+            <a:schemeClr val="accent1"/>
+          </a:lnRef>
+          <a:fillRef idx="3">
+            <a:schemeClr val="accent1"/>
+          </a:fillRef>
+          <a:effectRef idx="2">
+            <a:schemeClr val="accent1"/>
+          </a:effectRef>
+          <a:fontRef idx="minor">
+            <a:schemeClr val="lt1"/>
+          </a:fontRef>
+        </p:style>
+        <p:txBody>
+          <a:bodyPr rtlCol="0" anchor="ctr" wrap="square" lIns="109728" rIns="109728"/>
+          <a:lstStyle/>
+          <a:p>
+            <a:pPr algn="ctr">
+              <a:spcAft>
+                <a:spcPts val="1200"/>
+              </a:spcAft>
+              <a:defRPr sz="2200" b="0">
+                <a:solidFill>
+                  <a:srgbClr val="163548"/>
+                </a:solidFill>
+                <a:latin typeface="Aptos"/>
+              </a:defRPr>
+            </a:pPr>
+          </a:p>
+        </p:txBody>
+      </p:sp>
+      <p:sp>
+        <p:nvSpPr>
+          <p:cNvPr id="13" name="TextBox 12"/>
+          <p:cNvSpPr txBox="1"/>
+          <p:nvPr/>
+        </p:nvSpPr>
+        <p:spPr>
+          <a:xfrm>
+            <a:off x="8040624" y="2304288"/>
+            <a:ext cx="3215640" cy="960120"/>
+          </a:xfrm>
+          <a:prstGeom prst="rect">
+            <a:avLst/>
+          </a:prstGeom>
+          <a:noFill/>
+        </p:spPr>
+        <p:txBody>
+          <a:bodyPr wrap="square" lIns="109728" rIns="109728">
+            <a:spAutoFit/>
+          </a:bodyPr>
+          <a:lstStyle/>
+          <a:p>
+            <a:pPr>
+              <a:spcAft>
+                <a:spcPts val="1200"/>
+              </a:spcAft>
+              <a:defRPr sz="2100" b="1">
+                <a:solidFill>
+                  <a:srgbClr val="037E83"/>
+                </a:solidFill>
+                <a:latin typeface="Aptos"/>
+              </a:defRPr>
+            </a:pPr>
+            <a:r>
+              <a:t>Digital channels</a:t>
+            </a:r>
+          </a:p>
+        </p:txBody>
+      </p:sp>
+      <p:sp>
+        <p:nvSpPr>
+          <p:cNvPr id="14" name="TextBox 13"/>
+          <p:cNvSpPr txBox="1"/>
+          <p:nvPr/>
+        </p:nvSpPr>
+        <p:spPr>
+          <a:xfrm>
+            <a:off x="8040624" y="3383280"/>
+            <a:ext cx="3215640" cy="2011680"/>
+          </a:xfrm>
+          <a:prstGeom prst="rect">
+            <a:avLst/>
+          </a:prstGeom>
+          <a:noFill/>
+        </p:spPr>
+        <p:txBody>
+          <a:bodyPr wrap="square" lIns="109728" rIns="109728">
+            <a:spAutoFit/>
+          </a:bodyPr>
+          <a:lstStyle/>
+          <a:p>
+            <a:pPr>
+              <a:spcAft>
+                <a:spcPts val="1200"/>
+              </a:spcAft>
+              <a:defRPr sz="1900" b="0">
+                <a:solidFill>
+                  <a:srgbClr val="163548"/>
+                </a:solidFill>
+                <a:latin typeface="Aptos"/>
+              </a:defRPr>
+            </a:pPr>
+            <a:r>
+              <a:t>Maintain versioned content, images, translations and channel rules separately from purchasing identity.</a:t>
+            </a:r>
+          </a:p>
+        </p:txBody>
+      </p:sp>
+    </p:spTree>
+  </p:cSld>
+  <p:clrMapOvr>
+    <a:masterClrMapping/>
+  </p:clrMapOvr>
+</p:sld>
+</file>
+
+<file path=ppt/slides/slide17.xml><?xml version="1.0" encoding="utf-8"?>
+<p:sld xmlns:a="http://schemas.openxmlformats.org/drawingml/2006/main" xmlns:p="http://schemas.openxmlformats.org/presentationml/2006/main" xmlns:r="http://schemas.openxmlformats.org/officeDocument/2006/relationships">
+  <p:cSld>
+    <p:bg>
+      <p:bgPr>
+        <a:solidFill>
+          <a:srgbClr val="F3F7F7"/>
+        </a:solidFill>
+        <a:effectLst/>
+      </p:bgPr>
+    </p:bg>
+    <p:spTree>
+      <p:nvGrpSpPr>
+        <p:cNvPr id="1" name=""/>
+        <p:cNvGrpSpPr/>
+        <p:nvPr/>
+      </p:nvGrpSpPr>
+      <p:grpSpPr/>
+      <p:sp>
+        <p:nvSpPr>
+          <p:cNvPr id="2" name="TextBox 1"/>
+          <p:cNvSpPr txBox="1"/>
+          <p:nvPr/>
+        </p:nvSpPr>
+        <p:spPr>
+          <a:xfrm>
+            <a:off x="548640" y="274320"/>
+            <a:ext cx="10972800" cy="274320"/>
+          </a:xfrm>
+          <a:prstGeom prst="rect">
+            <a:avLst/>
+          </a:prstGeom>
+          <a:noFill/>
+        </p:spPr>
+        <p:txBody>
+          <a:bodyPr wrap="square" lIns="109728" rIns="109728">
+            <a:spAutoFit/>
+          </a:bodyPr>
+          <a:lstStyle/>
+          <a:p>
+            <a:pPr>
+              <a:spcAft>
+                <a:spcPts val="1200"/>
+              </a:spcAft>
+              <a:defRPr sz="1100" b="1">
+                <a:solidFill>
+                  <a:srgbClr val="037E83"/>
+                </a:solidFill>
+                <a:latin typeface="Aptos"/>
+              </a:defRPr>
+            </a:pPr>
+            <a:r>
+              <a:t>INVOICE STUDIO / DECISION PACK</a:t>
+            </a:r>
+          </a:p>
+        </p:txBody>
+      </p:sp>
+      <p:sp>
+        <p:nvSpPr>
+          <p:cNvPr id="3" name="TextBox 2"/>
+          <p:cNvSpPr txBox="1"/>
+          <p:nvPr/>
+        </p:nvSpPr>
+        <p:spPr>
+          <a:xfrm>
+            <a:off x="548640" y="868680"/>
+            <a:ext cx="10972800" cy="1188720"/>
+          </a:xfrm>
+          <a:prstGeom prst="rect">
+            <a:avLst/>
+          </a:prstGeom>
+          <a:noFill/>
+        </p:spPr>
+        <p:txBody>
+          <a:bodyPr wrap="square" lIns="109728" rIns="109728">
+            <a:spAutoFit/>
+          </a:bodyPr>
+          <a:lstStyle/>
+          <a:p>
+            <a:pPr>
+              <a:spcAft>
+                <a:spcPts val="1200"/>
+              </a:spcAft>
+              <a:defRPr sz="3200" b="1">
+                <a:solidFill>
+                  <a:srgbClr val="112C3D"/>
+                </a:solidFill>
+                <a:latin typeface="Aptos"/>
+              </a:defRPr>
+            </a:pPr>
+            <a:r>
+              <a:t>The next business decisions</a:t>
+            </a:r>
+          </a:p>
+        </p:txBody>
+      </p:sp>
+      <p:sp>
+        <p:nvSpPr>
+          <p:cNvPr id="4" name="TextBox 3"/>
+          <p:cNvSpPr txBox="1"/>
+          <p:nvPr/>
+        </p:nvSpPr>
+        <p:spPr>
+          <a:xfrm>
+            <a:off x="548640" y="6419088"/>
+            <a:ext cx="10058400" cy="274320"/>
+          </a:xfrm>
+          <a:prstGeom prst="rect">
+            <a:avLst/>
+          </a:prstGeom>
+          <a:noFill/>
+        </p:spPr>
+        <p:txBody>
+          <a:bodyPr wrap="square" lIns="109728" rIns="109728">
+            <a:spAutoFit/>
+          </a:bodyPr>
+          <a:lstStyle/>
+          <a:p>
+            <a:pPr>
+              <a:spcAft>
+                <a:spcPts val="1200"/>
+              </a:spcAft>
+              <a:defRPr sz="900" b="0">
+                <a:solidFill>
+                  <a:srgbClr val="53717B"/>
+                </a:solidFill>
+                <a:latin typeface="Aptos"/>
+              </a:defRPr>
+            </a:pPr>
+            <a:r>
+              <a:t>5 OCT 2026  •  MEASURED EVIDENCE AND PROPOSED NEXT STAGES</a:t>
+            </a:r>
+          </a:p>
+        </p:txBody>
+      </p:sp>
+      <p:sp>
+        <p:nvSpPr>
+          <p:cNvPr id="5" name="TextBox 4"/>
+          <p:cNvSpPr txBox="1"/>
+          <p:nvPr/>
+        </p:nvSpPr>
+        <p:spPr>
+          <a:xfrm>
+            <a:off x="10972800" y="6355080"/>
+            <a:ext cx="548640" cy="320040"/>
+          </a:xfrm>
+          <a:prstGeom prst="rect">
+            <a:avLst/>
+          </a:prstGeom>
+          <a:noFill/>
+        </p:spPr>
+        <p:txBody>
+          <a:bodyPr wrap="square" lIns="109728" rIns="109728">
+            <a:spAutoFit/>
+          </a:bodyPr>
+          <a:lstStyle/>
+          <a:p>
+            <a:pPr>
+              <a:spcAft>
+                <a:spcPts val="1200"/>
+              </a:spcAft>
+              <a:defRPr sz="1200" b="1">
+                <a:solidFill>
+                  <a:srgbClr val="037E83"/>
+                </a:solidFill>
+                <a:latin typeface="Aptos"/>
+              </a:defRPr>
+            </a:pPr>
+            <a:r>
+              <a:t>17</a:t>
             </a:r>
           </a:p>
         </p:txBody>
@@ -6625,7 +8470,7 @@
               </a:defRPr>
             </a:pPr>
             <a:r>
-              <a:t>4 OCT 2026  •  BUILD EVIDENCE AND PROPOSED NEXT STAGES</a:t>
+              <a:t>5 OCT 2026  •  MEASURED EVIDENCE AND PROPOSED NEXT STAGES</a:t>
             </a:r>
           </a:p>
         </p:txBody>
@@ -7200,7 +9045,7 @@
               </a:defRPr>
             </a:pPr>
             <a:r>
-              <a:t>4 OCT 2026  •  BUILD EVIDENCE AND PROPOSED NEXT STAGES</a:t>
+              <a:t>5 OCT 2026  •  MEASURED EVIDENCE AND PROPOSED NEXT STAGES</a:t>
             </a:r>
           </a:p>
         </p:txBody>
@@ -7370,7 +9215,7 @@
               </a:defRPr>
             </a:pPr>
             <a:r>
-              <a:t>One invoice per file; batch selection.</a:t>
+              <a:t>One invoice per file; two workers, remaining files queued.</a:t>
             </a:r>
           </a:p>
         </p:txBody>
@@ -7632,7 +9477,7 @@
               </a:defRPr>
             </a:pPr>
             <a:r>
-              <a:t>Template, native-PDF fast path, OCR or permitted AI.</a:t>
+              <a:t>Template, native layout, OCR or permitted AI.</a:t>
             </a:r>
           </a:p>
         </p:txBody>
@@ -7894,7 +9739,7 @@
               </a:defRPr>
             </a:pPr>
             <a:r>
-              <a:t>Visible stage, evidence and exceptions.</a:t>
+              <a:t>Edit and save each invoice before batch selection.</a:t>
             </a:r>
           </a:p>
         </p:txBody>
@@ -8025,7 +9870,7 @@
               </a:defRPr>
             </a:pPr>
             <a:r>
-              <a:t>Approved workbook or labelled manual draft.</a:t>
+              <a:t>Review-only, approved or manual draft workbook.</a:t>
             </a:r>
           </a:p>
         </p:txBody>
@@ -8168,7 +10013,7 @@
               </a:defRPr>
             </a:pPr>
             <a:r>
-              <a:t>4 OCT 2026  •  BUILD EVIDENCE AND PROPOSED NEXT STAGES</a:t>
+              <a:t>5 OCT 2026  •  MEASURED EVIDENCE AND PROPOSED NEXT STAGES</a:t>
             </a:r>
           </a:p>
         </p:txBody>
@@ -8469,7 +10314,7 @@
               </a:defRPr>
             </a:pPr>
             <a:r>
-              <a:t>Selected OpenAI or Claude model proposes structured fields when local reading is incomplete.</a:t>
+              <a:t>Managed Vertex or a selected API/subscription model proposes structured fields when local reading is incomplete.</a:t>
             </a:r>
           </a:p>
         </p:txBody>
@@ -8782,7 +10627,7 @@
               </a:defRPr>
             </a:pPr>
             <a:r>
-              <a:t>4 OCT 2026  •  BUILD EVIDENCE AND PROPOSED NEXT STAGES</a:t>
+              <a:t>5 OCT 2026  •  MEASURED EVIDENCE AND PROPOSED NEXT STAGES</a:t>
             </a:r>
           </a:p>
         </p:txBody>
@@ -9357,7 +11202,7 @@
               </a:defRPr>
             </a:pPr>
             <a:r>
-              <a:t>Two controlled routes to the workbook</a:t>
+              <a:t>Three controlled routes to the workbook</a:t>
             </a:r>
           </a:p>
         </p:txBody>
@@ -9396,7 +11241,7 @@
               </a:defRPr>
             </a:pPr>
             <a:r>
-              <a:t>4 OCT 2026  •  BUILD EVIDENCE AND PROPOSED NEXT STAGES</a:t>
+              <a:t>5 OCT 2026  •  MEASURED EVIDENCE AND PROPOSED NEXT STAGES</a:t>
             </a:r>
           </a:p>
         </p:txBody>
@@ -9658,7 +11503,7 @@
               </a:defRPr>
             </a:pPr>
             <a:r>
-              <a:t>Manual draft</a:t>
+              <a:t>Combined review</a:t>
             </a:r>
           </a:p>
         </p:txBody>
@@ -9697,7 +11542,7 @@
               </a:defRPr>
             </a:pPr>
             <a:r>
-              <a:t>Every target field is editable during OCR. Explicit acknowledgement, one joined transaction and no formulas.</a:t>
+              <a:t>Saved processed facts join into EXTRACTION_REVIEW_ONLY without approval, allocation or ledger change.</a:t>
             </a:r>
           </a:p>
         </p:txBody>
@@ -9789,7 +11634,7 @@
               </a:defRPr>
             </a:pPr>
             <a:r>
-              <a:t>Visible boundary</a:t>
+              <a:t>Manual draft</a:t>
             </a:r>
           </a:p>
         </p:txBody>
@@ -9828,7 +11673,7 @@
               </a:defRPr>
             </a:pPr>
             <a:r>
-              <a:t>Filename, workbook properties and comments say DRAFT_UNVALIDATED, references not validated and no receipt reserved.</a:t>
+              <a:t>Every target field is editable during OCR. Explicit acknowledgement; DRAFT_UNVALIDATED reserves nothing.</a:t>
             </a:r>
           </a:p>
         </p:txBody>
@@ -9867,7 +11712,7 @@
               </a:defRPr>
             </a:pPr>
             <a:r>
-              <a:t>The draft does not change job status, revision, extracted invoice, reference approval or the approved-export ledger.</a:t>
+              <a:t>All three use exact 13/3/6 sheets. Only approved export can reserve receipt quantity.</a:t>
             </a:r>
           </a:p>
         </p:txBody>
@@ -10010,7 +11855,7 @@
               </a:defRPr>
             </a:pPr>
             <a:r>
-              <a:t>4 OCT 2026  •  BUILD EVIDENCE AND PROPOSED NEXT STAGES</a:t>
+              <a:t>5 OCT 2026  •  MEASURED EVIDENCE AND PROPOSED NEXT STAGES</a:t>
             </a:r>
           </a:p>
         </p:txBody>
@@ -10585,7 +12430,7 @@
               </a:defRPr>
             </a:pPr>
             <a:r>
-              <a:t>4 OCT 2026  •  BUILD EVIDENCE AND PROPOSED NEXT STAGES</a:t>
+              <a:t>5 OCT 2026  •  MEASURED EVIDENCE AND PROPOSED NEXT STAGES</a:t>
             </a:r>
           </a:p>
         </p:txBody>
@@ -10716,7 +12561,7 @@
               </a:defRPr>
             </a:pPr>
             <a:r>
-              <a:t>Search actual scale</a:t>
+              <a:t>Known source profile</a:t>
             </a:r>
           </a:p>
         </p:txBody>
@@ -10755,7 +12600,7 @@
               </a:defRPr>
             </a:pPr>
             <a:r>
-              <a:t>Lookup covers 114,940 item rows and 297,199 PO rows by exact identifier or product-name token.</a:t>
+              <a:t>Private source files contain 412,139 item and PO/GRN rows, but hosted lookup currently reports zero loaded rows.</a:t>
             </a:r>
           </a:p>
         </p:txBody>
@@ -11017,7 +12862,7 @@
               </a:defRPr>
             </a:pPr>
             <a:r>
-              <a:t>Lookup never approves matching. Buyer, receipt, prior invoicing, route and tax meaning still need owners.</a:t>
+              <a:t>Lookup never approves matching. Supplier/site, receipt, prior invoicing, route and tax meaning still need owners.</a:t>
             </a:r>
           </a:p>
         </p:txBody>
@@ -11199,7 +13044,7 @@
               </a:defRPr>
             </a:pPr>
             <a:r>
-              <a:t>4 OCT 2026  •  BUILD EVIDENCE AND PROPOSED NEXT STAGES</a:t>
+              <a:t>5 OCT 2026  •  MEASURED EVIDENCE AND PROPOSED NEXT STAGES</a:t>
             </a:r>
           </a:p>
         </p:txBody>
@@ -11500,7 +13345,7 @@
               </a:defRPr>
             </a:pPr>
             <a:r>
-              <a:t>Cloud Run readers and API. Cloud SQL records/ledger. Private Cloud Storage evidence.</a:t>
+              <a:t>Cloud Run readers/API and managed Vertex through the service identity. Cloud SQL ledger; private evidence.</a:t>
             </a:r>
           </a:p>
         </p:txBody>
@@ -11631,7 +13476,7 @@
               </a:defRPr>
             </a:pPr>
             <a:r>
-              <a:t>Re-run auth, draft immutability, lookup, connections, extraction/export and persistence before handoff.</a:t>
+              <a:t>Deploy the complete feature bundle, restore lookup, then rerun authenticated extraction/export and persistence checks.</a:t>
             </a:r>
           </a:p>
         </p:txBody>
@@ -11670,7 +13515,7 @@
               </a:defRPr>
             </a:pPr>
             <a:r>
-              <a:t>The deployed URL is the earlier baseline. Current source additions are not yet claimed as deployed.</a:t>
+              <a:t>Access hotfix 00005-zdk is verified; the full feature release and hosted catalog are not yet live.</a:t>
             </a:r>
           </a:p>
         </p:txBody>

</xml_diff>

<commit_message>
Document verified cloud release, reader evidence, and remaining pilot gates
</commit_message>
<xml_diff>
--- a/docs/delivery/Invoice_Studio_SLT.pptx
+++ b/docs/delivery/Invoice_Studio_SLT.pptx
@@ -22,6 +22,7 @@
     <p:sldId id="270" r:id="rId21"/>
     <p:sldId id="271" r:id="rId22"/>
     <p:sldId id="272" r:id="rId23"/>
+    <p:sldId id="273" r:id="rId24"/>
   </p:sldIdLst>
   <p:sldSz cx="12191695" cy="6858000" type="screen4x3"/>
   <p:notesSz cx="6858000" cy="9144000"/>
@@ -3445,7 +3446,7 @@
               </a:defRPr>
             </a:pPr>
             <a:r>
-              <a:t>Access hotfix 00005-zdk is verified. 148 backend tests, Chromium and three Docker reader warmups pass. Full feature deployment and hosted catalog recovery remain pending.</a:t>
+              <a:t>Revision 00009-vxw is live. 214 tests, PostgreSQL, browsers, CI and reader warm-ups pass.</a:t>
             </a:r>
           </a:p>
         </p:txBody>
@@ -3719,7 +3720,7 @@
               </a:defRPr>
             </a:pPr>
             <a:r>
-              <a:t>Claude setup token</a:t>
+              <a:t>Saved vs verified</a:t>
             </a:r>
           </a:p>
         </p:txBody>
@@ -3758,7 +3759,7 @@
               </a:defRPr>
             </a:pPr>
             <a:r>
-              <a:t>Encrypted on the server and provided only to a restricted hosted CLI invocation with tools disabled.</a:t>
+              <a:t>An encrypted saved key is not verified access. Model retrieval or an explicit probe verifies the connection.</a:t>
             </a:r>
           </a:p>
         </p:txBody>
@@ -3981,7 +3982,7 @@
               </a:defRPr>
             </a:pPr>
             <a:r>
-              <a:t>Hosted owner import</a:t>
+              <a:t>Model selection</a:t>
             </a:r>
           </a:p>
         </p:txBody>
@@ -4020,7 +4021,7 @@
               </a:defRPr>
             </a:pPr>
             <a:r>
-              <a:t>Authenticated import verifies and encrypts the one-time bundle. Protect it, import promptly, then delete it.</a:t>
+              <a:t>Offer a connected model only when none is selected; never replace a still-connected user choice.</a:t>
             </a:r>
           </a:p>
         </p:txBody>
@@ -4163,7 +4164,7 @@
               </a:defRPr>
             </a:pPr>
             <a:r>
-              <a:t>Release checks are green; deployment remains bounded</a:t>
+              <a:t>Review and deletion keep meanings explicit</a:t>
             </a:r>
           </a:p>
         </p:txBody>
@@ -4333,7 +4334,7 @@
               </a:defRPr>
             </a:pPr>
             <a:r>
-              <a:t>Repository gate</a:t>
+              <a:t>Buyer identity</a:t>
             </a:r>
           </a:p>
         </p:txBody>
@@ -4372,7 +4373,7 @@
               </a:defRPr>
             </a:pPr>
             <a:r>
-              <a:t>148 backend tests pass with PostgreSQL included and no skips. Ruff and the latest full Chromium workflow pass.</a:t>
+              <a:t>Printed buyer name stays separate from the approved internal buyer/company code.</a:t>
             </a:r>
           </a:p>
         </p:txBody>
@@ -4464,7 +4465,7 @@
               </a:defRPr>
             </a:pPr>
             <a:r>
-              <a:t>Reader image</a:t>
+              <a:t>Reader trace</a:t>
             </a:r>
           </a:p>
         </p:txBody>
@@ -4503,7 +4504,7 @@
               </a:defRPr>
             </a:pPr>
             <a:r>
-              <a:t>All three Docker reader warmups passed in 63 seconds and recovered both synthetic lines.</a:t>
+              <a:t>Scanned invoice2data names Paddle input. Failed and text-only attempts are separate; coverage is not accuracy.</a:t>
             </a:r>
           </a:p>
         </p:txBody>
@@ -4595,7 +4596,7 @@
               </a:defRPr>
             </a:pPr>
             <a:r>
-              <a:t>Hosted boundary</a:t>
+              <a:t>Permanent deletion</a:t>
             </a:r>
           </a:p>
         </p:txBody>
@@ -4634,7 +4635,7 @@
               </a:defRPr>
             </a:pPr>
             <a:r>
-              <a:t>00005-zdk restored access. The complete feature release is not live; hosted lookup reports zero rows.</a:t>
+              <a:t>Confirmed deletion removes live evidence; minimal ledger tombstones remain, and provider retention still applies.</a:t>
             </a:r>
           </a:p>
         </p:txBody>
@@ -4738,7 +4739,7 @@
               </a:defRPr>
             </a:pPr>
             <a:r>
-              <a:t>Measured AI-off reader evidence</a:t>
+              <a:t>Release checks are green; deployment remains bounded</a:t>
             </a:r>
           </a:p>
         </p:txBody>
@@ -4908,7 +4909,7 @@
               </a:defRPr>
             </a:pPr>
             <a:r>
-              <a:t>Native tables</a:t>
+              <a:t>Repository gate</a:t>
             </a:r>
           </a:p>
         </p:txBody>
@@ -4947,7 +4948,7 @@
               </a:defRPr>
             </a:pPr>
             <a:r>
-              <a:t>15/15 PDFs, 570/570 rows and 3,990/3,990 tested line facts exact in one layout family; 24.6 s first total, 12.9 s warm.</a:t>
+              <a:t>214 backend tests pass with PostgreSQL included and no skips. Ruff, both Chromium workflows and all four GitHub checks pass.</a:t>
             </a:r>
           </a:p>
         </p:txBody>
@@ -5039,7 +5040,7 @@
               </a:defRPr>
             </a:pPr>
             <a:r>
-              <a:t>PaddleOCR</a:t>
+              <a:t>Reader image</a:t>
             </a:r>
           </a:p>
         </p:txBody>
@@ -5078,7 +5079,7 @@
               </a:defRPr>
             </a:pPr>
             <a:r>
-              <a:t>6/6 scan lines and 60/60 tested facts exact. Treating six descriptions as wrong gives a 60/66 = 90.91% floor.</a:t>
+              <a:t>All three packaged reader warm-ups recovered two synthetic lines.</a:t>
             </a:r>
           </a:p>
         </p:txBody>
@@ -5170,7 +5171,7 @@
               </a:defRPr>
             </a:pPr>
             <a:r>
-              <a:t>Docling</a:t>
+              <a:t>Hosted boundary</a:t>
             </a:r>
           </a:p>
         </p:txBody>
@@ -5209,46 +5210,7 @@
               </a:defRPr>
             </a:pPr>
             <a:r>
-              <a:t>5/5, 1/1 and 17/17 native lines. Ten pages exceeded 528 s; three scans took 103–170 s and returned no reliable lines.</a:t>
-            </a:r>
-          </a:p>
-        </p:txBody>
-      </p:sp>
-      <p:sp>
-        <p:nvSpPr>
-          <p:cNvPr id="15" name="TextBox 14"/>
-          <p:cNvSpPr txBox="1"/>
-          <p:nvPr/>
-        </p:nvSpPr>
-        <p:spPr>
-          <a:xfrm>
-            <a:off x="640080" y="5806440"/>
-            <a:ext cx="10789920" cy="411480"/>
-          </a:xfrm>
-          <a:prstGeom prst="rect">
-            <a:avLst/>
-          </a:prstGeom>
-          <a:noFill/>
-        </p:spPr>
-        <p:txBody>
-          <a:bodyPr wrap="square" lIns="109728" rIns="109728">
-            <a:spAutoFit/>
-          </a:bodyPr>
-          <a:lstStyle/>
-          <a:p>
-            <a:pPr>
-              <a:spcAft>
-                <a:spcPts val="1200"/>
-              </a:spcAft>
-              <a:defRPr sz="1400" b="0">
-                <a:solidFill>
-                  <a:srgbClr val="53717B"/>
-                </a:solidFill>
-                <a:latin typeface="Aptos"/>
-              </a:defRPr>
-            </a:pPr>
-            <a:r>
-              <a:t>These bounded cohorts do not prove the expected 95% across suppliers, scans, languages and lengths.</a:t>
+              <a:t>Revision 00009-vxw has 100% traffic. The allowlist is owner-only; public and direct-service APIs returned 401.</a:t>
             </a:r>
           </a:p>
         </p:txBody>
@@ -5352,7 +5314,7 @@
               </a:defRPr>
             </a:pPr>
             <a:r>
-              <a:t>Managed Vertex: useful evidence, narrow cohort</a:t>
+              <a:t>Measured AI-off reader evidence</a:t>
             </a:r>
           </a:p>
         </p:txBody>
@@ -5522,7 +5484,7 @@
               </a:defRPr>
             </a:pPr>
             <a:r>
-              <a:t>Measured result</a:t>
+              <a:t>Native tables</a:t>
             </a:r>
           </a:p>
         </p:txBody>
@@ -5561,7 +5523,7 @@
               </a:defRPr>
             </a:pPr>
             <a:r>
-              <a:t>All source-tested fields were exact across 15 documents and 570 lines from one layout family.</a:t>
+              <a:t>15/15 PDFs, 570/570 rows and 3,990/3,990 tested line facts exact in one family. Hosted: 193 rows and 1,351/1,351 line facts in 10.21 s.</a:t>
             </a:r>
           </a:p>
         </p:txBody>
@@ -5653,7 +5615,7 @@
               </a:defRPr>
             </a:pPr>
             <a:r>
-              <a:t>Measured usage</a:t>
+              <a:t>PaddleOCR</a:t>
             </a:r>
           </a:p>
         </p:txBody>
@@ -5692,7 +5654,7 @@
               </a:defRPr>
             </a:pPr>
             <a:r>
-              <a:t>36,450 input and 91,892 output tokens including reasoning across 15 successful calls.</a:t>
+              <a:t>Adaptive two-page path: 90/99 to 96/99 (97.0%), 23/23 rows locally; revision 00008 returned the same hosted result in 242.98 s.</a:t>
             </a:r>
           </a:p>
         </p:txBody>
@@ -5784,7 +5746,7 @@
               </a:defRPr>
             </a:pPr>
             <a:r>
-              <a:t>Calculated cost</a:t>
+              <a:t>Docling</a:t>
             </a:r>
           </a:p>
         </p:txBody>
@@ -5823,7 +5785,7 @@
               </a:defRPr>
             </a:pPr>
             <a:r>
-              <a:t>USD 0.3719325 at the published time-bounded rate; USD 24.7955 per 1,000 at the same mix.</a:t>
+              <a:t>Native examples and three small scans yielded 6/6 rows. A challenging scan gave 10/23 poor matches; ten pages exceeded 528 s.</a:t>
             </a:r>
           </a:p>
         </p:txBody>
@@ -5862,7 +5824,7 @@
               </a:defRPr>
             </a:pPr>
             <a:r>
-              <a:t>Not an actual bill. Excludes retries, hosting, database, storage and network. Broad accuracy remains unproven.</a:t>
+              <a:t>These bounded cohorts do not prove the expected 95% across suppliers, scans, languages and lengths.</a:t>
             </a:r>
           </a:p>
         </p:txBody>
@@ -5966,7 +5928,7 @@
               </a:defRPr>
             </a:pPr>
             <a:r>
-              <a:t>Define 90% before measuring it</a:t>
+              <a:t>Managed Vertex: useful evidence, narrow cohort</a:t>
             </a:r>
           </a:p>
         </p:txBody>
@@ -6136,7 +6098,7 @@
               </a:defRPr>
             </a:pPr>
             <a:r>
-              <a:t>Header exact</a:t>
+              <a:t>Measured result</a:t>
             </a:r>
           </a:p>
         </p:txBody>
@@ -6175,7 +6137,7 @@
               </a:defRPr>
             </a:pPr>
             <a:r>
-              <a:t>Target ≥90% over every frozen gold header cell, including expected nulls. Failures and timeouts score zero.</a:t>
+              <a:t>All source-tested fields were exact across 15 documents and 570 lines from one layout family.</a:t>
             </a:r>
           </a:p>
         </p:txBody>
@@ -6267,7 +6229,7 @@
               </a:defRPr>
             </a:pPr>
             <a:r>
-              <a:t>Line exact</a:t>
+              <a:t>Measured usage</a:t>
             </a:r>
           </a:p>
         </p:txBody>
@@ -6306,7 +6268,7 @@
               </a:defRPr>
             </a:pPr>
             <a:r>
-              <a:t>Target ≥90% exact cells after adjudicated line alignment; also report missing, extra and misaligned lines.</a:t>
+              <a:t>36,450 input and 91,892 output tokens including reasoning across 15 successful calls.</a:t>
             </a:r>
           </a:p>
         </p:txBody>
@@ -6398,7 +6360,7 @@
               </a:defRPr>
             </a:pPr>
             <a:r>
-              <a:t>Zero correction</a:t>
+              <a:t>Calculated cost</a:t>
             </a:r>
           </a:p>
         </p:txBody>
@@ -6437,7 +6399,7 @@
               </a:defRPr>
             </a:pPr>
             <a:r>
-              <a:t>Target ≥90% of all attempted invoices needing no extraction edit, plus zero false-ready approvals.</a:t>
+              <a:t>USD 0.3719325 at the published time-bounded rate; USD 24.7955 per 1,000 at the same mix.</a:t>
             </a:r>
           </a:p>
         </p:txBody>
@@ -6476,7 +6438,7 @@
               </a:defRPr>
             </a:pPr>
             <a:r>
-              <a:t>Stratify by supplier, native/scan, language, quality and length. Completeness, schema and arithmetic are diagnostics, not accuracy.</a:t>
+              <a:t>Not an actual bill. Excludes retries, hosting, database, storage and network. Broad accuracy remains unproven.</a:t>
             </a:r>
           </a:p>
         </p:txBody>
@@ -6580,7 +6542,7 @@
               </a:defRPr>
             </a:pPr>
             <a:r>
-              <a:t>A staged build plan with clear exits</a:t>
+              <a:t>Define 90% before measuring it</a:t>
             </a:r>
           </a:p>
         </p:txBody>
@@ -6750,23 +6712,7 @@
               </a:defRPr>
             </a:pPr>
             <a:r>
-              <a:t>Data contract</a:t>
-            </a:r>
-          </a:p>
-          <a:p>
-            <a:pPr>
-              <a:spcAft>
-                <a:spcPts val="1200"/>
-              </a:spcAft>
-              <a:defRPr sz="2100" b="1">
-                <a:solidFill>
-                  <a:srgbClr val="037E83"/>
-                </a:solidFill>
-                <a:latin typeface="Aptos"/>
-              </a:defRPr>
-            </a:pPr>
-            <a:r>
-              <a:t>1–2 weeks</a:t>
+              <a:t>Header exact</a:t>
             </a:r>
           </a:p>
         </p:txBody>
@@ -6805,7 +6751,7 @@
               </a:defRPr>
             </a:pPr>
             <a:r>
-              <a:t>Approve mappings and missing values. Accept the target workbook with the receiving team.</a:t>
+              <a:t>Target ≥90% over every frozen gold header cell, including expected nulls. Failures and timeouts score zero.</a:t>
             </a:r>
           </a:p>
         </p:txBody>
@@ -6897,23 +6843,7 @@
               </a:defRPr>
             </a:pPr>
             <a:r>
-              <a:t>Supplier evaluation</a:t>
-            </a:r>
-          </a:p>
-          <a:p>
-            <a:pPr>
-              <a:spcAft>
-                <a:spcPts val="1200"/>
-              </a:spcAft>
-              <a:defRPr sz="2100" b="1">
-                <a:solidFill>
-                  <a:srgbClr val="037E83"/>
-                </a:solidFill>
-                <a:latin typeface="Aptos"/>
-              </a:defRPr>
-            </a:pPr>
-            <a:r>
-              <a:t>2–3 weeks</a:t>
+              <a:t>Line exact</a:t>
             </a:r>
           </a:p>
         </p:txBody>
@@ -6952,7 +6882,7 @@
               </a:defRPr>
             </a:pPr>
             <a:r>
-              <a:t>Evaluate at least 100 representative invoices and the difficult exception cases.</a:t>
+              <a:t>Target ≥90% exact cells after adjudicated line alignment; also report missing, extra and misaligned lines.</a:t>
             </a:r>
           </a:p>
         </p:txBody>
@@ -7044,23 +6974,7 @@
               </a:defRPr>
             </a:pPr>
             <a:r>
-              <a:t>Production pilot</a:t>
-            </a:r>
-          </a:p>
-          <a:p>
-            <a:pPr>
-              <a:spcAft>
-                <a:spcPts val="1200"/>
-              </a:spcAft>
-              <a:defRPr sz="2100" b="1">
-                <a:solidFill>
-                  <a:srgbClr val="037E83"/>
-                </a:solidFill>
-                <a:latin typeface="Aptos"/>
-              </a:defRPr>
-            </a:pPr>
-            <a:r>
-              <a:t>3–5 weeks</a:t>
+              <a:t>Zero correction</a:t>
             </a:r>
           </a:p>
         </p:txBody>
@@ -7099,7 +7013,7 @@
               </a:defRPr>
             </a:pPr>
             <a:r>
-              <a:t>Add role separation, durable workers, backup restoration, monitoring and controlled UAT.</a:t>
+              <a:t>Target ≥90% of all attempted invoices needing no extraction edit, plus zero false-ready approvals.</a:t>
             </a:r>
           </a:p>
         </p:txBody>
@@ -7138,7 +7052,7 @@
               </a:defRPr>
             </a:pPr>
             <a:r>
-              <a:t>Planning ranges assume available AP/data owners and a deliberately bounded initial invoice contract.</a:t>
+              <a:t>Stratify by supplier, native/scan, language, quality and length. Completeness, schema and arithmetic are diagnostics, not accuracy.</a:t>
             </a:r>
           </a:p>
         </p:txBody>
@@ -7242,7 +7156,7 @@
               </a:defRPr>
             </a:pPr>
             <a:r>
-              <a:t>Extend the platform after invoice proof</a:t>
+              <a:t>A staged build plan with clear exits</a:t>
             </a:r>
           </a:p>
         </p:txBody>
@@ -7412,7 +7326,23 @@
               </a:defRPr>
             </a:pPr>
             <a:r>
-              <a:t>New store or market</a:t>
+              <a:t>Data contract</a:t>
+            </a:r>
+          </a:p>
+          <a:p>
+            <a:pPr>
+              <a:spcAft>
+                <a:spcPts val="1200"/>
+              </a:spcAft>
+              <a:defRPr sz="2100" b="1">
+                <a:solidFill>
+                  <a:srgbClr val="037E83"/>
+                </a:solidFill>
+                <a:latin typeface="Aptos"/>
+              </a:defRPr>
+            </a:pPr>
+            <a:r>
+              <a:t>1–2 weeks</a:t>
             </a:r>
           </a:p>
         </p:txBody>
@@ -7451,7 +7381,7 @@
               </a:defRPr>
             </a:pPr>
             <a:r>
-              <a:t>Search approved coverage; create supplier discovery and qualification cases only for gaps.</a:t>
+              <a:t>Approve mappings and missing values. Accept the target workbook with the receiving team.</a:t>
             </a:r>
           </a:p>
         </p:txBody>
@@ -7543,7 +7473,23 @@
               </a:defRPr>
             </a:pPr>
             <a:r>
-              <a:t>Supplier item intake</a:t>
+              <a:t>Supplier evaluation</a:t>
+            </a:r>
+          </a:p>
+          <a:p>
+            <a:pPr>
+              <a:spcAft>
+                <a:spcPts val="1200"/>
+              </a:spcAft>
+              <a:defRPr sz="2100" b="1">
+                <a:solidFill>
+                  <a:srgbClr val="037E83"/>
+                </a:solidFill>
+                <a:latin typeface="Aptos"/>
+              </a:defRPr>
+            </a:pPr>
+            <a:r>
+              <a:t>2–3 weeks</a:t>
             </a:r>
           </a:p>
         </p:txBody>
@@ -7582,7 +7528,7 @@
               </a:defRPr>
             </a:pPr>
             <a:r>
-              <a:t>Normalize item identity, codes, packaging and units. Route ambiguity to a data steward.</a:t>
+              <a:t>Evaluate at least 100 representative invoices and the difficult exception cases.</a:t>
             </a:r>
           </a:p>
         </p:txBody>
@@ -7674,7 +7620,23 @@
               </a:defRPr>
             </a:pPr>
             <a:r>
-              <a:t>Digital channels</a:t>
+              <a:t>Production pilot</a:t>
+            </a:r>
+          </a:p>
+          <a:p>
+            <a:pPr>
+              <a:spcAft>
+                <a:spcPts val="1200"/>
+              </a:spcAft>
+              <a:defRPr sz="2100" b="1">
+                <a:solidFill>
+                  <a:srgbClr val="037E83"/>
+                </a:solidFill>
+                <a:latin typeface="Aptos"/>
+              </a:defRPr>
+            </a:pPr>
+            <a:r>
+              <a:t>3–5 weeks</a:t>
             </a:r>
           </a:p>
         </p:txBody>
@@ -7713,7 +7675,46 @@
               </a:defRPr>
             </a:pPr>
             <a:r>
-              <a:t>Maintain versioned content, images, translations and channel rules separately from purchasing identity.</a:t>
+              <a:t>Add role separation, durable workers, backup restoration, monitoring and controlled UAT.</a:t>
+            </a:r>
+          </a:p>
+        </p:txBody>
+      </p:sp>
+      <p:sp>
+        <p:nvSpPr>
+          <p:cNvPr id="15" name="TextBox 14"/>
+          <p:cNvSpPr txBox="1"/>
+          <p:nvPr/>
+        </p:nvSpPr>
+        <p:spPr>
+          <a:xfrm>
+            <a:off x="640080" y="5806440"/>
+            <a:ext cx="10789920" cy="411480"/>
+          </a:xfrm>
+          <a:prstGeom prst="rect">
+            <a:avLst/>
+          </a:prstGeom>
+          <a:noFill/>
+        </p:spPr>
+        <p:txBody>
+          <a:bodyPr wrap="square" lIns="109728" rIns="109728">
+            <a:spAutoFit/>
+          </a:bodyPr>
+          <a:lstStyle/>
+          <a:p>
+            <a:pPr>
+              <a:spcAft>
+                <a:spcPts val="1200"/>
+              </a:spcAft>
+              <a:defRPr sz="1400" b="0">
+                <a:solidFill>
+                  <a:srgbClr val="53717B"/>
+                </a:solidFill>
+                <a:latin typeface="Aptos"/>
+              </a:defRPr>
+            </a:pPr>
+            <a:r>
+              <a:t>Planning ranges assume available AP/data owners and a deliberately bounded initial invoice contract.</a:t>
             </a:r>
           </a:p>
         </p:txBody>
@@ -7817,7 +7818,7 @@
               </a:defRPr>
             </a:pPr>
             <a:r>
-              <a:t>The next business decisions</a:t>
+              <a:t>Extend the platform after invoice proof</a:t>
             </a:r>
           </a:p>
         </p:txBody>
@@ -7987,7 +7988,7 @@
               </a:defRPr>
             </a:pPr>
             <a:r>
-              <a:t>Name the owners</a:t>
+              <a:t>New store or market</a:t>
             </a:r>
           </a:p>
         </p:txBody>
@@ -8026,7 +8027,7 @@
               </a:defRPr>
             </a:pPr>
             <a:r>
-              <a:t>AP process owner, reference steward, receiving owner and finance/tax approver.</a:t>
+              <a:t>Search approved coverage; create supplier discovery and qualification cases only for gaps.</a:t>
             </a:r>
           </a:p>
         </p:txBody>
@@ -8118,7 +8119,7 @@
               </a:defRPr>
             </a:pPr>
             <a:r>
-              <a:t>Accept the evidence</a:t>
+              <a:t>Supplier item intake</a:t>
             </a:r>
           </a:p>
         </p:txBody>
@@ -8157,7 +8158,7 @@
               </a:defRPr>
             </a:pPr>
             <a:r>
-              <a:t>Confirm receipt status meaning, invoice baseline, route scope and the initial supplier test set.</a:t>
+              <a:t>Normalize item identity, codes, packaging and units. Route ambiguity to a data steward.</a:t>
             </a:r>
           </a:p>
         </p:txBody>
@@ -8249,7 +8250,7 @@
               </a:defRPr>
             </a:pPr>
             <a:r>
-              <a:t>Authorize the rollout</a:t>
+              <a:t>Digital channels</a:t>
             </a:r>
           </a:p>
         </p:txBody>
@@ -8288,6 +8289,581 @@
               </a:defRPr>
             </a:pPr>
             <a:r>
+              <a:t>Maintain versioned content, images, translations and channel rules separately from purchasing identity.</a:t>
+            </a:r>
+          </a:p>
+        </p:txBody>
+      </p:sp>
+    </p:spTree>
+  </p:cSld>
+  <p:clrMapOvr>
+    <a:masterClrMapping/>
+  </p:clrMapOvr>
+</p:sld>
+</file>
+
+<file path=ppt/slides/slide18.xml><?xml version="1.0" encoding="utf-8"?>
+<p:sld xmlns:a="http://schemas.openxmlformats.org/drawingml/2006/main" xmlns:p="http://schemas.openxmlformats.org/presentationml/2006/main" xmlns:r="http://schemas.openxmlformats.org/officeDocument/2006/relationships">
+  <p:cSld>
+    <p:bg>
+      <p:bgPr>
+        <a:solidFill>
+          <a:srgbClr val="F3F7F7"/>
+        </a:solidFill>
+        <a:effectLst/>
+      </p:bgPr>
+    </p:bg>
+    <p:spTree>
+      <p:nvGrpSpPr>
+        <p:cNvPr id="1" name=""/>
+        <p:cNvGrpSpPr/>
+        <p:nvPr/>
+      </p:nvGrpSpPr>
+      <p:grpSpPr/>
+      <p:sp>
+        <p:nvSpPr>
+          <p:cNvPr id="2" name="TextBox 1"/>
+          <p:cNvSpPr txBox="1"/>
+          <p:nvPr/>
+        </p:nvSpPr>
+        <p:spPr>
+          <a:xfrm>
+            <a:off x="548640" y="274320"/>
+            <a:ext cx="10972800" cy="274320"/>
+          </a:xfrm>
+          <a:prstGeom prst="rect">
+            <a:avLst/>
+          </a:prstGeom>
+          <a:noFill/>
+        </p:spPr>
+        <p:txBody>
+          <a:bodyPr wrap="square" lIns="109728" rIns="109728">
+            <a:spAutoFit/>
+          </a:bodyPr>
+          <a:lstStyle/>
+          <a:p>
+            <a:pPr>
+              <a:spcAft>
+                <a:spcPts val="1200"/>
+              </a:spcAft>
+              <a:defRPr sz="1100" b="1">
+                <a:solidFill>
+                  <a:srgbClr val="037E83"/>
+                </a:solidFill>
+                <a:latin typeface="Aptos"/>
+              </a:defRPr>
+            </a:pPr>
+            <a:r>
+              <a:t>INVOICE STUDIO / DECISION PACK</a:t>
+            </a:r>
+          </a:p>
+        </p:txBody>
+      </p:sp>
+      <p:sp>
+        <p:nvSpPr>
+          <p:cNvPr id="3" name="TextBox 2"/>
+          <p:cNvSpPr txBox="1"/>
+          <p:nvPr/>
+        </p:nvSpPr>
+        <p:spPr>
+          <a:xfrm>
+            <a:off x="548640" y="868680"/>
+            <a:ext cx="10972800" cy="1188720"/>
+          </a:xfrm>
+          <a:prstGeom prst="rect">
+            <a:avLst/>
+          </a:prstGeom>
+          <a:noFill/>
+        </p:spPr>
+        <p:txBody>
+          <a:bodyPr wrap="square" lIns="109728" rIns="109728">
+            <a:spAutoFit/>
+          </a:bodyPr>
+          <a:lstStyle/>
+          <a:p>
+            <a:pPr>
+              <a:spcAft>
+                <a:spcPts val="1200"/>
+              </a:spcAft>
+              <a:defRPr sz="3200" b="1">
+                <a:solidFill>
+                  <a:srgbClr val="112C3D"/>
+                </a:solidFill>
+                <a:latin typeface="Aptos"/>
+              </a:defRPr>
+            </a:pPr>
+            <a:r>
+              <a:t>The next business decisions</a:t>
+            </a:r>
+          </a:p>
+        </p:txBody>
+      </p:sp>
+      <p:sp>
+        <p:nvSpPr>
+          <p:cNvPr id="4" name="TextBox 3"/>
+          <p:cNvSpPr txBox="1"/>
+          <p:nvPr/>
+        </p:nvSpPr>
+        <p:spPr>
+          <a:xfrm>
+            <a:off x="548640" y="6419088"/>
+            <a:ext cx="10058400" cy="274320"/>
+          </a:xfrm>
+          <a:prstGeom prst="rect">
+            <a:avLst/>
+          </a:prstGeom>
+          <a:noFill/>
+        </p:spPr>
+        <p:txBody>
+          <a:bodyPr wrap="square" lIns="109728" rIns="109728">
+            <a:spAutoFit/>
+          </a:bodyPr>
+          <a:lstStyle/>
+          <a:p>
+            <a:pPr>
+              <a:spcAft>
+                <a:spcPts val="1200"/>
+              </a:spcAft>
+              <a:defRPr sz="900" b="0">
+                <a:solidFill>
+                  <a:srgbClr val="53717B"/>
+                </a:solidFill>
+                <a:latin typeface="Aptos"/>
+              </a:defRPr>
+            </a:pPr>
+            <a:r>
+              <a:t>5 OCT 2026  •  MEASURED EVIDENCE AND PROPOSED NEXT STAGES</a:t>
+            </a:r>
+          </a:p>
+        </p:txBody>
+      </p:sp>
+      <p:sp>
+        <p:nvSpPr>
+          <p:cNvPr id="5" name="TextBox 4"/>
+          <p:cNvSpPr txBox="1"/>
+          <p:nvPr/>
+        </p:nvSpPr>
+        <p:spPr>
+          <a:xfrm>
+            <a:off x="10972800" y="6355080"/>
+            <a:ext cx="548640" cy="320040"/>
+          </a:xfrm>
+          <a:prstGeom prst="rect">
+            <a:avLst/>
+          </a:prstGeom>
+          <a:noFill/>
+        </p:spPr>
+        <p:txBody>
+          <a:bodyPr wrap="square" lIns="109728" rIns="109728">
+            <a:spAutoFit/>
+          </a:bodyPr>
+          <a:lstStyle/>
+          <a:p>
+            <a:pPr>
+              <a:spcAft>
+                <a:spcPts val="1200"/>
+              </a:spcAft>
+              <a:defRPr sz="1200" b="1">
+                <a:solidFill>
+                  <a:srgbClr val="037E83"/>
+                </a:solidFill>
+                <a:latin typeface="Aptos"/>
+              </a:defRPr>
+            </a:pPr>
+            <a:r>
+              <a:t>18</a:t>
+            </a:r>
+          </a:p>
+        </p:txBody>
+      </p:sp>
+      <p:sp>
+        <p:nvSpPr>
+          <p:cNvPr id="6" name="Rounded Rectangle 5"/>
+          <p:cNvSpPr/>
+          <p:nvPr/>
+        </p:nvSpPr>
+        <p:spPr>
+          <a:xfrm>
+            <a:off x="594360" y="2103120"/>
+            <a:ext cx="3489960" cy="3474720"/>
+          </a:xfrm>
+          <a:prstGeom prst="roundRect">
+            <a:avLst/>
+          </a:prstGeom>
+          <a:solidFill>
+            <a:srgbClr val="FFFFFF"/>
+          </a:solidFill>
+          <a:ln>
+            <a:noFill/>
+          </a:ln>
+        </p:spPr>
+        <p:style>
+          <a:lnRef idx="1">
+            <a:schemeClr val="accent1"/>
+          </a:lnRef>
+          <a:fillRef idx="3">
+            <a:schemeClr val="accent1"/>
+          </a:fillRef>
+          <a:effectRef idx="2">
+            <a:schemeClr val="accent1"/>
+          </a:effectRef>
+          <a:fontRef idx="minor">
+            <a:schemeClr val="lt1"/>
+          </a:fontRef>
+        </p:style>
+        <p:txBody>
+          <a:bodyPr rtlCol="0" anchor="ctr" wrap="square" lIns="109728" rIns="109728"/>
+          <a:lstStyle/>
+          <a:p>
+            <a:pPr algn="ctr">
+              <a:spcAft>
+                <a:spcPts val="1200"/>
+              </a:spcAft>
+              <a:defRPr sz="2200" b="0">
+                <a:solidFill>
+                  <a:srgbClr val="163548"/>
+                </a:solidFill>
+                <a:latin typeface="Aptos"/>
+              </a:defRPr>
+            </a:pPr>
+          </a:p>
+        </p:txBody>
+      </p:sp>
+      <p:sp>
+        <p:nvSpPr>
+          <p:cNvPr id="7" name="TextBox 6"/>
+          <p:cNvSpPr txBox="1"/>
+          <p:nvPr/>
+        </p:nvSpPr>
+        <p:spPr>
+          <a:xfrm>
+            <a:off x="731520" y="2304288"/>
+            <a:ext cx="3215640" cy="960120"/>
+          </a:xfrm>
+          <a:prstGeom prst="rect">
+            <a:avLst/>
+          </a:prstGeom>
+          <a:noFill/>
+        </p:spPr>
+        <p:txBody>
+          <a:bodyPr wrap="square" lIns="109728" rIns="109728">
+            <a:spAutoFit/>
+          </a:bodyPr>
+          <a:lstStyle/>
+          <a:p>
+            <a:pPr>
+              <a:spcAft>
+                <a:spcPts val="1200"/>
+              </a:spcAft>
+              <a:defRPr sz="2100" b="1">
+                <a:solidFill>
+                  <a:srgbClr val="037E83"/>
+                </a:solidFill>
+                <a:latin typeface="Aptos"/>
+              </a:defRPr>
+            </a:pPr>
+            <a:r>
+              <a:t>Name the owners</a:t>
+            </a:r>
+          </a:p>
+        </p:txBody>
+      </p:sp>
+      <p:sp>
+        <p:nvSpPr>
+          <p:cNvPr id="8" name="TextBox 7"/>
+          <p:cNvSpPr txBox="1"/>
+          <p:nvPr/>
+        </p:nvSpPr>
+        <p:spPr>
+          <a:xfrm>
+            <a:off x="731520" y="3383280"/>
+            <a:ext cx="3215640" cy="2011680"/>
+          </a:xfrm>
+          <a:prstGeom prst="rect">
+            <a:avLst/>
+          </a:prstGeom>
+          <a:noFill/>
+        </p:spPr>
+        <p:txBody>
+          <a:bodyPr wrap="square" lIns="109728" rIns="109728">
+            <a:spAutoFit/>
+          </a:bodyPr>
+          <a:lstStyle/>
+          <a:p>
+            <a:pPr>
+              <a:spcAft>
+                <a:spcPts val="1200"/>
+              </a:spcAft>
+              <a:defRPr sz="1900" b="0">
+                <a:solidFill>
+                  <a:srgbClr val="163548"/>
+                </a:solidFill>
+                <a:latin typeface="Aptos"/>
+              </a:defRPr>
+            </a:pPr>
+            <a:r>
+              <a:t>AP process owner, reference steward, receiving owner and finance/tax approver.</a:t>
+            </a:r>
+          </a:p>
+        </p:txBody>
+      </p:sp>
+      <p:sp>
+        <p:nvSpPr>
+          <p:cNvPr id="9" name="Rounded Rectangle 8"/>
+          <p:cNvSpPr/>
+          <p:nvPr/>
+        </p:nvSpPr>
+        <p:spPr>
+          <a:xfrm>
+            <a:off x="4248912" y="2103120"/>
+            <a:ext cx="3489960" cy="3474720"/>
+          </a:xfrm>
+          <a:prstGeom prst="roundRect">
+            <a:avLst/>
+          </a:prstGeom>
+          <a:solidFill>
+            <a:srgbClr val="FFFFFF"/>
+          </a:solidFill>
+          <a:ln>
+            <a:noFill/>
+          </a:ln>
+        </p:spPr>
+        <p:style>
+          <a:lnRef idx="1">
+            <a:schemeClr val="accent1"/>
+          </a:lnRef>
+          <a:fillRef idx="3">
+            <a:schemeClr val="accent1"/>
+          </a:fillRef>
+          <a:effectRef idx="2">
+            <a:schemeClr val="accent1"/>
+          </a:effectRef>
+          <a:fontRef idx="minor">
+            <a:schemeClr val="lt1"/>
+          </a:fontRef>
+        </p:style>
+        <p:txBody>
+          <a:bodyPr rtlCol="0" anchor="ctr" wrap="square" lIns="109728" rIns="109728"/>
+          <a:lstStyle/>
+          <a:p>
+            <a:pPr algn="ctr">
+              <a:spcAft>
+                <a:spcPts val="1200"/>
+              </a:spcAft>
+              <a:defRPr sz="2200" b="0">
+                <a:solidFill>
+                  <a:srgbClr val="163548"/>
+                </a:solidFill>
+                <a:latin typeface="Aptos"/>
+              </a:defRPr>
+            </a:pPr>
+          </a:p>
+        </p:txBody>
+      </p:sp>
+      <p:sp>
+        <p:nvSpPr>
+          <p:cNvPr id="10" name="TextBox 9"/>
+          <p:cNvSpPr txBox="1"/>
+          <p:nvPr/>
+        </p:nvSpPr>
+        <p:spPr>
+          <a:xfrm>
+            <a:off x="4386072" y="2304288"/>
+            <a:ext cx="3215640" cy="960120"/>
+          </a:xfrm>
+          <a:prstGeom prst="rect">
+            <a:avLst/>
+          </a:prstGeom>
+          <a:noFill/>
+        </p:spPr>
+        <p:txBody>
+          <a:bodyPr wrap="square" lIns="109728" rIns="109728">
+            <a:spAutoFit/>
+          </a:bodyPr>
+          <a:lstStyle/>
+          <a:p>
+            <a:pPr>
+              <a:spcAft>
+                <a:spcPts val="1200"/>
+              </a:spcAft>
+              <a:defRPr sz="2100" b="1">
+                <a:solidFill>
+                  <a:srgbClr val="037E83"/>
+                </a:solidFill>
+                <a:latin typeface="Aptos"/>
+              </a:defRPr>
+            </a:pPr>
+            <a:r>
+              <a:t>Accept the evidence</a:t>
+            </a:r>
+          </a:p>
+        </p:txBody>
+      </p:sp>
+      <p:sp>
+        <p:nvSpPr>
+          <p:cNvPr id="11" name="TextBox 10"/>
+          <p:cNvSpPr txBox="1"/>
+          <p:nvPr/>
+        </p:nvSpPr>
+        <p:spPr>
+          <a:xfrm>
+            <a:off x="4386072" y="3383280"/>
+            <a:ext cx="3215640" cy="2011680"/>
+          </a:xfrm>
+          <a:prstGeom prst="rect">
+            <a:avLst/>
+          </a:prstGeom>
+          <a:noFill/>
+        </p:spPr>
+        <p:txBody>
+          <a:bodyPr wrap="square" lIns="109728" rIns="109728">
+            <a:spAutoFit/>
+          </a:bodyPr>
+          <a:lstStyle/>
+          <a:p>
+            <a:pPr>
+              <a:spcAft>
+                <a:spcPts val="1200"/>
+              </a:spcAft>
+              <a:defRPr sz="1900" b="0">
+                <a:solidFill>
+                  <a:srgbClr val="163548"/>
+                </a:solidFill>
+                <a:latin typeface="Aptos"/>
+              </a:defRPr>
+            </a:pPr>
+            <a:r>
+              <a:t>Confirm receipt status meaning, invoice baseline, route scope and the initial supplier test set.</a:t>
+            </a:r>
+          </a:p>
+        </p:txBody>
+      </p:sp>
+      <p:sp>
+        <p:nvSpPr>
+          <p:cNvPr id="12" name="Rounded Rectangle 11"/>
+          <p:cNvSpPr/>
+          <p:nvPr/>
+        </p:nvSpPr>
+        <p:spPr>
+          <a:xfrm>
+            <a:off x="7903463" y="2103120"/>
+            <a:ext cx="3489960" cy="3474720"/>
+          </a:xfrm>
+          <a:prstGeom prst="roundRect">
+            <a:avLst/>
+          </a:prstGeom>
+          <a:solidFill>
+            <a:srgbClr val="FFFFFF"/>
+          </a:solidFill>
+          <a:ln>
+            <a:noFill/>
+          </a:ln>
+        </p:spPr>
+        <p:style>
+          <a:lnRef idx="1">
+            <a:schemeClr val="accent1"/>
+          </a:lnRef>
+          <a:fillRef idx="3">
+            <a:schemeClr val="accent1"/>
+          </a:fillRef>
+          <a:effectRef idx="2">
+            <a:schemeClr val="accent1"/>
+          </a:effectRef>
+          <a:fontRef idx="minor">
+            <a:schemeClr val="lt1"/>
+          </a:fontRef>
+        </p:style>
+        <p:txBody>
+          <a:bodyPr rtlCol="0" anchor="ctr" wrap="square" lIns="109728" rIns="109728"/>
+          <a:lstStyle/>
+          <a:p>
+            <a:pPr algn="ctr">
+              <a:spcAft>
+                <a:spcPts val="1200"/>
+              </a:spcAft>
+              <a:defRPr sz="2200" b="0">
+                <a:solidFill>
+                  <a:srgbClr val="163548"/>
+                </a:solidFill>
+                <a:latin typeface="Aptos"/>
+              </a:defRPr>
+            </a:pPr>
+          </a:p>
+        </p:txBody>
+      </p:sp>
+      <p:sp>
+        <p:nvSpPr>
+          <p:cNvPr id="13" name="TextBox 12"/>
+          <p:cNvSpPr txBox="1"/>
+          <p:nvPr/>
+        </p:nvSpPr>
+        <p:spPr>
+          <a:xfrm>
+            <a:off x="8040624" y="2304288"/>
+            <a:ext cx="3215640" cy="960120"/>
+          </a:xfrm>
+          <a:prstGeom prst="rect">
+            <a:avLst/>
+          </a:prstGeom>
+          <a:noFill/>
+        </p:spPr>
+        <p:txBody>
+          <a:bodyPr wrap="square" lIns="109728" rIns="109728">
+            <a:spAutoFit/>
+          </a:bodyPr>
+          <a:lstStyle/>
+          <a:p>
+            <a:pPr>
+              <a:spcAft>
+                <a:spcPts val="1200"/>
+              </a:spcAft>
+              <a:defRPr sz="2100" b="1">
+                <a:solidFill>
+                  <a:srgbClr val="037E83"/>
+                </a:solidFill>
+                <a:latin typeface="Aptos"/>
+              </a:defRPr>
+            </a:pPr>
+            <a:r>
+              <a:t>Authorize the rollout</a:t>
+            </a:r>
+          </a:p>
+        </p:txBody>
+      </p:sp>
+      <p:sp>
+        <p:nvSpPr>
+          <p:cNvPr id="14" name="TextBox 13"/>
+          <p:cNvSpPr txBox="1"/>
+          <p:nvPr/>
+        </p:nvSpPr>
+        <p:spPr>
+          <a:xfrm>
+            <a:off x="8040624" y="3383280"/>
+            <a:ext cx="3215640" cy="2011680"/>
+          </a:xfrm>
+          <a:prstGeom prst="rect">
+            <a:avLst/>
+          </a:prstGeom>
+          <a:noFill/>
+        </p:spPr>
+        <p:txBody>
+          <a:bodyPr wrap="square" lIns="109728" rIns="109728">
+            <a:spAutoFit/>
+          </a:bodyPr>
+          <a:lstStyle/>
+          <a:p>
+            <a:pPr>
+              <a:spcAft>
+                <a:spcPts val="1200"/>
+              </a:spcAft>
+              <a:defRPr sz="1900" b="0">
+                <a:solidFill>
+                  <a:srgbClr val="163548"/>
+                </a:solidFill>
+                <a:latin typeface="Aptos"/>
+              </a:defRPr>
+            </a:pPr>
+            <a:r>
               <a:t>Set approved users, provider choices and budget; sign off downstream workbook compatibility.</a:t>
             </a:r>
           </a:p>
@@ -8327,7 +8903,7 @@
               </a:defRPr>
             </a:pPr>
             <a:r>
-              <a:t>Fifteen acceptance-driven implementation stories accompany the design and operator guide.</a:t>
+              <a:t>Sixteen acceptance-driven implementation stories accompany the design and operator guide.</a:t>
             </a:r>
           </a:p>
         </p:txBody>
@@ -12156,7 +12732,7 @@
               </a:defRPr>
             </a:pPr>
             <a:r>
-              <a:t>The same seller may serve different owned companies. PO scope must identify the correct buyer.</a:t>
+              <a:t>Printed buyer name is evidence, not an internal code. PO scope must identify the approved buyer.</a:t>
             </a:r>
           </a:p>
         </p:txBody>
@@ -12600,7 +13176,7 @@
               </a:defRPr>
             </a:pPr>
             <a:r>
-              <a:t>Private source files contain 412,139 item and PO/GRN rows, but hosted lookup currently reports zero loaded rows.</a:t>
+              <a:t>Atomic cutover completed with 412,139 rows: 114,940 item and 297,199 PO/GRN. Authenticated API ranking/filter checks passed.</a:t>
             </a:r>
           </a:p>
         </p:txBody>
@@ -12731,7 +13307,7 @@
               </a:defRPr>
             </a:pPr>
             <a:r>
-              <a:t>Keep source sheet/row and duplicate context. Require explicit operator confirmation before copying evidence.</a:t>
+              <a:t>Keep provenance and duplicates. Name, price, quantity and unit clues rank candidates; a person confirms.</a:t>
             </a:r>
           </a:p>
         </p:txBody>
@@ -13345,7 +13921,7 @@
               </a:defRPr>
             </a:pPr>
             <a:r>
-              <a:t>Cloud Run readers/API and managed Vertex through the service identity. Cloud SQL ledger; private evidence.</a:t>
+              <a:t>Cloud Run readers/API and managed Vertex through the service identity. Cloud SQL is 1 vCPU / 3.75 GB; estimated compute about USD 49/month, plus storage.</a:t>
             </a:r>
           </a:p>
         </p:txBody>
@@ -13437,7 +14013,7 @@
               </a:defRPr>
             </a:pPr>
             <a:r>
-              <a:t>Release gates</a:t>
+              <a:t>Release status</a:t>
             </a:r>
           </a:p>
         </p:txBody>
@@ -13476,7 +14052,7 @@
               </a:defRPr>
             </a:pPr>
             <a:r>
-              <a:t>Deploy the complete feature bundle, restore lookup, then rerun authenticated extraction/export and persistence checks.</a:t>
+              <a:t>Revision 00009-vxw is live. Reader, lookup and control checks passed; the allowlist is owner-only.</a:t>
             </a:r>
           </a:p>
         </p:txBody>
@@ -13515,7 +14091,7 @@
               </a:defRPr>
             </a:pPr>
             <a:r>
-              <a:t>Access hotfix 00005-zdk is verified; the full feature release and hosted catalog are not yet live.</a:t>
+              <a:t>The 412,139-row evidence catalog is live; catalog evidence is not canonical approval.</a:t>
             </a:r>
           </a:p>
         </p:txBody>

</xml_diff>

<commit_message>
Make the delivery pack render clearly and align capability status
</commit_message>
<xml_diff>
--- a/docs/delivery/Invoice_Studio_SLT.pptx
+++ b/docs/delivery/Invoice_Studio_SLT.pptx
@@ -3143,7 +3143,7 @@
                 <a:solidFill>
                   <a:srgbClr val="037E83"/>
                 </a:solidFill>
-                <a:latin typeface="Aptos"/>
+                <a:latin typeface="Arial"/>
               </a:defRPr>
             </a:pPr>
             <a:r>
@@ -3182,7 +3182,7 @@
                 <a:solidFill>
                   <a:srgbClr val="112C3D"/>
                 </a:solidFill>
-                <a:latin typeface="Aptos"/>
+                <a:latin typeface="Arial"/>
               </a:defRPr>
             </a:pPr>
             <a:r>
@@ -3198,7 +3198,7 @@
                 <a:solidFill>
                   <a:srgbClr val="112C3D"/>
                 </a:solidFill>
-                <a:latin typeface="Aptos"/>
+                <a:latin typeface="Arial"/>
               </a:defRPr>
             </a:pPr>
             <a:r>
@@ -3237,7 +3237,7 @@
                 <a:solidFill>
                   <a:srgbClr val="53717B"/>
                 </a:solidFill>
-                <a:latin typeface="Aptos"/>
+                <a:latin typeface="Arial"/>
               </a:defRPr>
             </a:pPr>
             <a:r>
@@ -3276,7 +3276,7 @@
                 <a:solidFill>
                   <a:srgbClr val="037E83"/>
                 </a:solidFill>
-                <a:latin typeface="Aptos"/>
+                <a:latin typeface="Arial"/>
               </a:defRPr>
             </a:pPr>
             <a:r>
@@ -3315,7 +3315,7 @@
                 <a:solidFill>
                   <a:srgbClr val="163548"/>
                 </a:solidFill>
-                <a:latin typeface="Aptos"/>
+                <a:latin typeface="Arial"/>
               </a:defRPr>
             </a:pPr>
             <a:r>
@@ -3331,7 +3331,7 @@
                 <a:solidFill>
                   <a:srgbClr val="163548"/>
                 </a:solidFill>
-                <a:latin typeface="Aptos"/>
+                <a:latin typeface="Arial"/>
               </a:defRPr>
             </a:pPr>
             <a:r>
@@ -3387,7 +3387,7 @@
                 <a:solidFill>
                   <a:srgbClr val="FFFFFF"/>
                 </a:solidFill>
-                <a:latin typeface="Aptos"/>
+                <a:latin typeface="Arial"/>
               </a:defRPr>
             </a:pPr>
             <a:r>
@@ -3403,7 +3403,7 @@
                 <a:solidFill>
                   <a:srgbClr val="FFFFFF"/>
                 </a:solidFill>
-                <a:latin typeface="Aptos"/>
+                <a:latin typeface="Arial"/>
               </a:defRPr>
             </a:pPr>
             <a:r>
@@ -3442,7 +3442,7 @@
                 <a:solidFill>
                   <a:srgbClr val="53717B"/>
                 </a:solidFill>
-                <a:latin typeface="Aptos"/>
+                <a:latin typeface="Arial"/>
               </a:defRPr>
             </a:pPr>
             <a:r>
@@ -3507,7 +3507,7 @@
                 <a:solidFill>
                   <a:srgbClr val="037E83"/>
                 </a:solidFill>
-                <a:latin typeface="Aptos"/>
+                <a:latin typeface="Arial"/>
               </a:defRPr>
             </a:pPr>
             <a:r>
@@ -3546,7 +3546,7 @@
                 <a:solidFill>
                   <a:srgbClr val="112C3D"/>
                 </a:solidFill>
-                <a:latin typeface="Aptos"/>
+                <a:latin typeface="Arial"/>
               </a:defRPr>
             </a:pPr>
             <a:r>
@@ -3585,7 +3585,7 @@
                 <a:solidFill>
                   <a:srgbClr val="53717B"/>
                 </a:solidFill>
-                <a:latin typeface="Aptos"/>
+                <a:latin typeface="Arial"/>
               </a:defRPr>
             </a:pPr>
             <a:r>
@@ -3624,7 +3624,7 @@
                 <a:solidFill>
                   <a:srgbClr val="037E83"/>
                 </a:solidFill>
-                <a:latin typeface="Aptos"/>
+                <a:latin typeface="Arial"/>
               </a:defRPr>
             </a:pPr>
             <a:r>
@@ -3680,7 +3680,7 @@
                 <a:solidFill>
                   <a:srgbClr val="163548"/>
                 </a:solidFill>
-                <a:latin typeface="Aptos"/>
+                <a:latin typeface="Arial"/>
               </a:defRPr>
             </a:pPr>
           </a:p>
@@ -3716,7 +3716,7 @@
                 <a:solidFill>
                   <a:srgbClr val="037E83"/>
                 </a:solidFill>
-                <a:latin typeface="Aptos"/>
+                <a:latin typeface="Arial"/>
               </a:defRPr>
             </a:pPr>
             <a:r>
@@ -3755,7 +3755,7 @@
                 <a:solidFill>
                   <a:srgbClr val="163548"/>
                 </a:solidFill>
-                <a:latin typeface="Aptos"/>
+                <a:latin typeface="Arial"/>
               </a:defRPr>
             </a:pPr>
             <a:r>
@@ -3811,7 +3811,7 @@
                 <a:solidFill>
                   <a:srgbClr val="163548"/>
                 </a:solidFill>
-                <a:latin typeface="Aptos"/>
+                <a:latin typeface="Arial"/>
               </a:defRPr>
             </a:pPr>
           </a:p>
@@ -3847,7 +3847,7 @@
                 <a:solidFill>
                   <a:srgbClr val="037E83"/>
                 </a:solidFill>
-                <a:latin typeface="Aptos"/>
+                <a:latin typeface="Arial"/>
               </a:defRPr>
             </a:pPr>
             <a:r>
@@ -3886,7 +3886,7 @@
                 <a:solidFill>
                   <a:srgbClr val="163548"/>
                 </a:solidFill>
-                <a:latin typeface="Aptos"/>
+                <a:latin typeface="Arial"/>
               </a:defRPr>
             </a:pPr>
             <a:r>
@@ -3942,7 +3942,7 @@
                 <a:solidFill>
                   <a:srgbClr val="163548"/>
                 </a:solidFill>
-                <a:latin typeface="Aptos"/>
+                <a:latin typeface="Arial"/>
               </a:defRPr>
             </a:pPr>
           </a:p>
@@ -3978,7 +3978,7 @@
                 <a:solidFill>
                   <a:srgbClr val="037E83"/>
                 </a:solidFill>
-                <a:latin typeface="Aptos"/>
+                <a:latin typeface="Arial"/>
               </a:defRPr>
             </a:pPr>
             <a:r>
@@ -4017,7 +4017,7 @@
                 <a:solidFill>
                   <a:srgbClr val="163548"/>
                 </a:solidFill>
-                <a:latin typeface="Aptos"/>
+                <a:latin typeface="Arial"/>
               </a:defRPr>
             </a:pPr>
             <a:r>
@@ -4056,7 +4056,7 @@
                 <a:solidFill>
                   <a:srgbClr val="53717B"/>
                 </a:solidFill>
-                <a:latin typeface="Aptos"/>
+                <a:latin typeface="Arial"/>
               </a:defRPr>
             </a:pPr>
             <a:r>
@@ -4121,7 +4121,7 @@
                 <a:solidFill>
                   <a:srgbClr val="037E83"/>
                 </a:solidFill>
-                <a:latin typeface="Aptos"/>
+                <a:latin typeface="Arial"/>
               </a:defRPr>
             </a:pPr>
             <a:r>
@@ -4160,7 +4160,7 @@
                 <a:solidFill>
                   <a:srgbClr val="112C3D"/>
                 </a:solidFill>
-                <a:latin typeface="Aptos"/>
+                <a:latin typeface="Arial"/>
               </a:defRPr>
             </a:pPr>
             <a:r>
@@ -4199,7 +4199,7 @@
                 <a:solidFill>
                   <a:srgbClr val="53717B"/>
                 </a:solidFill>
-                <a:latin typeface="Aptos"/>
+                <a:latin typeface="Arial"/>
               </a:defRPr>
             </a:pPr>
             <a:r>
@@ -4238,7 +4238,7 @@
                 <a:solidFill>
                   <a:srgbClr val="037E83"/>
                 </a:solidFill>
-                <a:latin typeface="Aptos"/>
+                <a:latin typeface="Arial"/>
               </a:defRPr>
             </a:pPr>
             <a:r>
@@ -4294,7 +4294,7 @@
                 <a:solidFill>
                   <a:srgbClr val="163548"/>
                 </a:solidFill>
-                <a:latin typeface="Aptos"/>
+                <a:latin typeface="Arial"/>
               </a:defRPr>
             </a:pPr>
           </a:p>
@@ -4330,7 +4330,7 @@
                 <a:solidFill>
                   <a:srgbClr val="037E83"/>
                 </a:solidFill>
-                <a:latin typeface="Aptos"/>
+                <a:latin typeface="Arial"/>
               </a:defRPr>
             </a:pPr>
             <a:r>
@@ -4369,7 +4369,7 @@
                 <a:solidFill>
                   <a:srgbClr val="163548"/>
                 </a:solidFill>
-                <a:latin typeface="Aptos"/>
+                <a:latin typeface="Arial"/>
               </a:defRPr>
             </a:pPr>
             <a:r>
@@ -4425,7 +4425,7 @@
                 <a:solidFill>
                   <a:srgbClr val="163548"/>
                 </a:solidFill>
-                <a:latin typeface="Aptos"/>
+                <a:latin typeface="Arial"/>
               </a:defRPr>
             </a:pPr>
           </a:p>
@@ -4461,7 +4461,7 @@
                 <a:solidFill>
                   <a:srgbClr val="037E83"/>
                 </a:solidFill>
-                <a:latin typeface="Aptos"/>
+                <a:latin typeface="Arial"/>
               </a:defRPr>
             </a:pPr>
             <a:r>
@@ -4500,7 +4500,7 @@
                 <a:solidFill>
                   <a:srgbClr val="163548"/>
                 </a:solidFill>
-                <a:latin typeface="Aptos"/>
+                <a:latin typeface="Arial"/>
               </a:defRPr>
             </a:pPr>
             <a:r>
@@ -4556,7 +4556,7 @@
                 <a:solidFill>
                   <a:srgbClr val="163548"/>
                 </a:solidFill>
-                <a:latin typeface="Aptos"/>
+                <a:latin typeface="Arial"/>
               </a:defRPr>
             </a:pPr>
           </a:p>
@@ -4592,7 +4592,7 @@
                 <a:solidFill>
                   <a:srgbClr val="037E83"/>
                 </a:solidFill>
-                <a:latin typeface="Aptos"/>
+                <a:latin typeface="Arial"/>
               </a:defRPr>
             </a:pPr>
             <a:r>
@@ -4631,7 +4631,7 @@
                 <a:solidFill>
                   <a:srgbClr val="163548"/>
                 </a:solidFill>
-                <a:latin typeface="Aptos"/>
+                <a:latin typeface="Arial"/>
               </a:defRPr>
             </a:pPr>
             <a:r>
@@ -4696,7 +4696,7 @@
                 <a:solidFill>
                   <a:srgbClr val="037E83"/>
                 </a:solidFill>
-                <a:latin typeface="Aptos"/>
+                <a:latin typeface="Arial"/>
               </a:defRPr>
             </a:pPr>
             <a:r>
@@ -4735,7 +4735,7 @@
                 <a:solidFill>
                   <a:srgbClr val="112C3D"/>
                 </a:solidFill>
-                <a:latin typeface="Aptos"/>
+                <a:latin typeface="Arial"/>
               </a:defRPr>
             </a:pPr>
             <a:r>
@@ -4774,7 +4774,7 @@
                 <a:solidFill>
                   <a:srgbClr val="53717B"/>
                 </a:solidFill>
-                <a:latin typeface="Aptos"/>
+                <a:latin typeface="Arial"/>
               </a:defRPr>
             </a:pPr>
             <a:r>
@@ -4813,7 +4813,7 @@
                 <a:solidFill>
                   <a:srgbClr val="037E83"/>
                 </a:solidFill>
-                <a:latin typeface="Aptos"/>
+                <a:latin typeface="Arial"/>
               </a:defRPr>
             </a:pPr>
             <a:r>
@@ -4869,7 +4869,7 @@
                 <a:solidFill>
                   <a:srgbClr val="163548"/>
                 </a:solidFill>
-                <a:latin typeface="Aptos"/>
+                <a:latin typeface="Arial"/>
               </a:defRPr>
             </a:pPr>
           </a:p>
@@ -4905,7 +4905,7 @@
                 <a:solidFill>
                   <a:srgbClr val="037E83"/>
                 </a:solidFill>
-                <a:latin typeface="Aptos"/>
+                <a:latin typeface="Arial"/>
               </a:defRPr>
             </a:pPr>
             <a:r>
@@ -4944,7 +4944,7 @@
                 <a:solidFill>
                   <a:srgbClr val="163548"/>
                 </a:solidFill>
-                <a:latin typeface="Aptos"/>
+                <a:latin typeface="Arial"/>
               </a:defRPr>
             </a:pPr>
             <a:r>
@@ -5000,7 +5000,7 @@
                 <a:solidFill>
                   <a:srgbClr val="163548"/>
                 </a:solidFill>
-                <a:latin typeface="Aptos"/>
+                <a:latin typeface="Arial"/>
               </a:defRPr>
             </a:pPr>
           </a:p>
@@ -5036,7 +5036,7 @@
                 <a:solidFill>
                   <a:srgbClr val="037E83"/>
                 </a:solidFill>
-                <a:latin typeface="Aptos"/>
+                <a:latin typeface="Arial"/>
               </a:defRPr>
             </a:pPr>
             <a:r>
@@ -5075,7 +5075,7 @@
                 <a:solidFill>
                   <a:srgbClr val="163548"/>
                 </a:solidFill>
-                <a:latin typeface="Aptos"/>
+                <a:latin typeface="Arial"/>
               </a:defRPr>
             </a:pPr>
             <a:r>
@@ -5131,7 +5131,7 @@
                 <a:solidFill>
                   <a:srgbClr val="163548"/>
                 </a:solidFill>
-                <a:latin typeface="Aptos"/>
+                <a:latin typeface="Arial"/>
               </a:defRPr>
             </a:pPr>
           </a:p>
@@ -5167,7 +5167,7 @@
                 <a:solidFill>
                   <a:srgbClr val="037E83"/>
                 </a:solidFill>
-                <a:latin typeface="Aptos"/>
+                <a:latin typeface="Arial"/>
               </a:defRPr>
             </a:pPr>
             <a:r>
@@ -5206,7 +5206,7 @@
                 <a:solidFill>
                   <a:srgbClr val="163548"/>
                 </a:solidFill>
-                <a:latin typeface="Aptos"/>
+                <a:latin typeface="Arial"/>
               </a:defRPr>
             </a:pPr>
             <a:r>
@@ -5271,7 +5271,7 @@
                 <a:solidFill>
                   <a:srgbClr val="037E83"/>
                 </a:solidFill>
-                <a:latin typeface="Aptos"/>
+                <a:latin typeface="Arial"/>
               </a:defRPr>
             </a:pPr>
             <a:r>
@@ -5310,7 +5310,7 @@
                 <a:solidFill>
                   <a:srgbClr val="112C3D"/>
                 </a:solidFill>
-                <a:latin typeface="Aptos"/>
+                <a:latin typeface="Arial"/>
               </a:defRPr>
             </a:pPr>
             <a:r>
@@ -5349,7 +5349,7 @@
                 <a:solidFill>
                   <a:srgbClr val="53717B"/>
                 </a:solidFill>
-                <a:latin typeface="Aptos"/>
+                <a:latin typeface="Arial"/>
               </a:defRPr>
             </a:pPr>
             <a:r>
@@ -5388,7 +5388,7 @@
                 <a:solidFill>
                   <a:srgbClr val="037E83"/>
                 </a:solidFill>
-                <a:latin typeface="Aptos"/>
+                <a:latin typeface="Arial"/>
               </a:defRPr>
             </a:pPr>
             <a:r>
@@ -5444,7 +5444,7 @@
                 <a:solidFill>
                   <a:srgbClr val="163548"/>
                 </a:solidFill>
-                <a:latin typeface="Aptos"/>
+                <a:latin typeface="Arial"/>
               </a:defRPr>
             </a:pPr>
           </a:p>
@@ -5480,7 +5480,7 @@
                 <a:solidFill>
                   <a:srgbClr val="037E83"/>
                 </a:solidFill>
-                <a:latin typeface="Aptos"/>
+                <a:latin typeface="Arial"/>
               </a:defRPr>
             </a:pPr>
             <a:r>
@@ -5519,7 +5519,7 @@
                 <a:solidFill>
                   <a:srgbClr val="163548"/>
                 </a:solidFill>
-                <a:latin typeface="Aptos"/>
+                <a:latin typeface="Arial"/>
               </a:defRPr>
             </a:pPr>
             <a:r>
@@ -5575,7 +5575,7 @@
                 <a:solidFill>
                   <a:srgbClr val="163548"/>
                 </a:solidFill>
-                <a:latin typeface="Aptos"/>
+                <a:latin typeface="Arial"/>
               </a:defRPr>
             </a:pPr>
           </a:p>
@@ -5611,7 +5611,7 @@
                 <a:solidFill>
                   <a:srgbClr val="037E83"/>
                 </a:solidFill>
-                <a:latin typeface="Aptos"/>
+                <a:latin typeface="Arial"/>
               </a:defRPr>
             </a:pPr>
             <a:r>
@@ -5650,7 +5650,7 @@
                 <a:solidFill>
                   <a:srgbClr val="163548"/>
                 </a:solidFill>
-                <a:latin typeface="Aptos"/>
+                <a:latin typeface="Arial"/>
               </a:defRPr>
             </a:pPr>
             <a:r>
@@ -5706,7 +5706,7 @@
                 <a:solidFill>
                   <a:srgbClr val="163548"/>
                 </a:solidFill>
-                <a:latin typeface="Aptos"/>
+                <a:latin typeface="Arial"/>
               </a:defRPr>
             </a:pPr>
           </a:p>
@@ -5742,7 +5742,7 @@
                 <a:solidFill>
                   <a:srgbClr val="037E83"/>
                 </a:solidFill>
-                <a:latin typeface="Aptos"/>
+                <a:latin typeface="Arial"/>
               </a:defRPr>
             </a:pPr>
             <a:r>
@@ -5781,7 +5781,7 @@
                 <a:solidFill>
                   <a:srgbClr val="163548"/>
                 </a:solidFill>
-                <a:latin typeface="Aptos"/>
+                <a:latin typeface="Arial"/>
               </a:defRPr>
             </a:pPr>
             <a:r>
@@ -5820,7 +5820,7 @@
                 <a:solidFill>
                   <a:srgbClr val="53717B"/>
                 </a:solidFill>
-                <a:latin typeface="Aptos"/>
+                <a:latin typeface="Arial"/>
               </a:defRPr>
             </a:pPr>
             <a:r>
@@ -5885,7 +5885,7 @@
                 <a:solidFill>
                   <a:srgbClr val="037E83"/>
                 </a:solidFill>
-                <a:latin typeface="Aptos"/>
+                <a:latin typeface="Arial"/>
               </a:defRPr>
             </a:pPr>
             <a:r>
@@ -5924,7 +5924,7 @@
                 <a:solidFill>
                   <a:srgbClr val="112C3D"/>
                 </a:solidFill>
-                <a:latin typeface="Aptos"/>
+                <a:latin typeface="Arial"/>
               </a:defRPr>
             </a:pPr>
             <a:r>
@@ -5963,7 +5963,7 @@
                 <a:solidFill>
                   <a:srgbClr val="53717B"/>
                 </a:solidFill>
-                <a:latin typeface="Aptos"/>
+                <a:latin typeface="Arial"/>
               </a:defRPr>
             </a:pPr>
             <a:r>
@@ -6002,7 +6002,7 @@
                 <a:solidFill>
                   <a:srgbClr val="037E83"/>
                 </a:solidFill>
-                <a:latin typeface="Aptos"/>
+                <a:latin typeface="Arial"/>
               </a:defRPr>
             </a:pPr>
             <a:r>
@@ -6058,7 +6058,7 @@
                 <a:solidFill>
                   <a:srgbClr val="163548"/>
                 </a:solidFill>
-                <a:latin typeface="Aptos"/>
+                <a:latin typeface="Arial"/>
               </a:defRPr>
             </a:pPr>
           </a:p>
@@ -6094,7 +6094,7 @@
                 <a:solidFill>
                   <a:srgbClr val="037E83"/>
                 </a:solidFill>
-                <a:latin typeface="Aptos"/>
+                <a:latin typeface="Arial"/>
               </a:defRPr>
             </a:pPr>
             <a:r>
@@ -6133,7 +6133,7 @@
                 <a:solidFill>
                   <a:srgbClr val="163548"/>
                 </a:solidFill>
-                <a:latin typeface="Aptos"/>
+                <a:latin typeface="Arial"/>
               </a:defRPr>
             </a:pPr>
             <a:r>
@@ -6189,7 +6189,7 @@
                 <a:solidFill>
                   <a:srgbClr val="163548"/>
                 </a:solidFill>
-                <a:latin typeface="Aptos"/>
+                <a:latin typeface="Arial"/>
               </a:defRPr>
             </a:pPr>
           </a:p>
@@ -6225,7 +6225,7 @@
                 <a:solidFill>
                   <a:srgbClr val="037E83"/>
                 </a:solidFill>
-                <a:latin typeface="Aptos"/>
+                <a:latin typeface="Arial"/>
               </a:defRPr>
             </a:pPr>
             <a:r>
@@ -6264,7 +6264,7 @@
                 <a:solidFill>
                   <a:srgbClr val="163548"/>
                 </a:solidFill>
-                <a:latin typeface="Aptos"/>
+                <a:latin typeface="Arial"/>
               </a:defRPr>
             </a:pPr>
             <a:r>
@@ -6320,7 +6320,7 @@
                 <a:solidFill>
                   <a:srgbClr val="163548"/>
                 </a:solidFill>
-                <a:latin typeface="Aptos"/>
+                <a:latin typeface="Arial"/>
               </a:defRPr>
             </a:pPr>
           </a:p>
@@ -6356,7 +6356,7 @@
                 <a:solidFill>
                   <a:srgbClr val="037E83"/>
                 </a:solidFill>
-                <a:latin typeface="Aptos"/>
+                <a:latin typeface="Arial"/>
               </a:defRPr>
             </a:pPr>
             <a:r>
@@ -6395,7 +6395,7 @@
                 <a:solidFill>
                   <a:srgbClr val="163548"/>
                 </a:solidFill>
-                <a:latin typeface="Aptos"/>
+                <a:latin typeface="Arial"/>
               </a:defRPr>
             </a:pPr>
             <a:r>
@@ -6434,7 +6434,7 @@
                 <a:solidFill>
                   <a:srgbClr val="53717B"/>
                 </a:solidFill>
-                <a:latin typeface="Aptos"/>
+                <a:latin typeface="Arial"/>
               </a:defRPr>
             </a:pPr>
             <a:r>
@@ -6499,7 +6499,7 @@
                 <a:solidFill>
                   <a:srgbClr val="037E83"/>
                 </a:solidFill>
-                <a:latin typeface="Aptos"/>
+                <a:latin typeface="Arial"/>
               </a:defRPr>
             </a:pPr>
             <a:r>
@@ -6538,7 +6538,7 @@
                 <a:solidFill>
                   <a:srgbClr val="112C3D"/>
                 </a:solidFill>
-                <a:latin typeface="Aptos"/>
+                <a:latin typeface="Arial"/>
               </a:defRPr>
             </a:pPr>
             <a:r>
@@ -6577,7 +6577,7 @@
                 <a:solidFill>
                   <a:srgbClr val="53717B"/>
                 </a:solidFill>
-                <a:latin typeface="Aptos"/>
+                <a:latin typeface="Arial"/>
               </a:defRPr>
             </a:pPr>
             <a:r>
@@ -6616,7 +6616,7 @@
                 <a:solidFill>
                   <a:srgbClr val="037E83"/>
                 </a:solidFill>
-                <a:latin typeface="Aptos"/>
+                <a:latin typeface="Arial"/>
               </a:defRPr>
             </a:pPr>
             <a:r>
@@ -6672,7 +6672,7 @@
                 <a:solidFill>
                   <a:srgbClr val="163548"/>
                 </a:solidFill>
-                <a:latin typeface="Aptos"/>
+                <a:latin typeface="Arial"/>
               </a:defRPr>
             </a:pPr>
           </a:p>
@@ -6708,7 +6708,7 @@
                 <a:solidFill>
                   <a:srgbClr val="037E83"/>
                 </a:solidFill>
-                <a:latin typeface="Aptos"/>
+                <a:latin typeface="Arial"/>
               </a:defRPr>
             </a:pPr>
             <a:r>
@@ -6747,7 +6747,7 @@
                 <a:solidFill>
                   <a:srgbClr val="163548"/>
                 </a:solidFill>
-                <a:latin typeface="Aptos"/>
+                <a:latin typeface="Arial"/>
               </a:defRPr>
             </a:pPr>
             <a:r>
@@ -6803,7 +6803,7 @@
                 <a:solidFill>
                   <a:srgbClr val="163548"/>
                 </a:solidFill>
-                <a:latin typeface="Aptos"/>
+                <a:latin typeface="Arial"/>
               </a:defRPr>
             </a:pPr>
           </a:p>
@@ -6839,7 +6839,7 @@
                 <a:solidFill>
                   <a:srgbClr val="037E83"/>
                 </a:solidFill>
-                <a:latin typeface="Aptos"/>
+                <a:latin typeface="Arial"/>
               </a:defRPr>
             </a:pPr>
             <a:r>
@@ -6878,7 +6878,7 @@
                 <a:solidFill>
                   <a:srgbClr val="163548"/>
                 </a:solidFill>
-                <a:latin typeface="Aptos"/>
+                <a:latin typeface="Arial"/>
               </a:defRPr>
             </a:pPr>
             <a:r>
@@ -6934,7 +6934,7 @@
                 <a:solidFill>
                   <a:srgbClr val="163548"/>
                 </a:solidFill>
-                <a:latin typeface="Aptos"/>
+                <a:latin typeface="Arial"/>
               </a:defRPr>
             </a:pPr>
           </a:p>
@@ -6970,7 +6970,7 @@
                 <a:solidFill>
                   <a:srgbClr val="037E83"/>
                 </a:solidFill>
-                <a:latin typeface="Aptos"/>
+                <a:latin typeface="Arial"/>
               </a:defRPr>
             </a:pPr>
             <a:r>
@@ -7009,7 +7009,7 @@
                 <a:solidFill>
                   <a:srgbClr val="163548"/>
                 </a:solidFill>
-                <a:latin typeface="Aptos"/>
+                <a:latin typeface="Arial"/>
               </a:defRPr>
             </a:pPr>
             <a:r>
@@ -7048,7 +7048,7 @@
                 <a:solidFill>
                   <a:srgbClr val="53717B"/>
                 </a:solidFill>
-                <a:latin typeface="Aptos"/>
+                <a:latin typeface="Arial"/>
               </a:defRPr>
             </a:pPr>
             <a:r>
@@ -7113,7 +7113,7 @@
                 <a:solidFill>
                   <a:srgbClr val="037E83"/>
                 </a:solidFill>
-                <a:latin typeface="Aptos"/>
+                <a:latin typeface="Arial"/>
               </a:defRPr>
             </a:pPr>
             <a:r>
@@ -7152,7 +7152,7 @@
                 <a:solidFill>
                   <a:srgbClr val="112C3D"/>
                 </a:solidFill>
-                <a:latin typeface="Aptos"/>
+                <a:latin typeface="Arial"/>
               </a:defRPr>
             </a:pPr>
             <a:r>
@@ -7191,7 +7191,7 @@
                 <a:solidFill>
                   <a:srgbClr val="53717B"/>
                 </a:solidFill>
-                <a:latin typeface="Aptos"/>
+                <a:latin typeface="Arial"/>
               </a:defRPr>
             </a:pPr>
             <a:r>
@@ -7230,7 +7230,7 @@
                 <a:solidFill>
                   <a:srgbClr val="037E83"/>
                 </a:solidFill>
-                <a:latin typeface="Aptos"/>
+                <a:latin typeface="Arial"/>
               </a:defRPr>
             </a:pPr>
             <a:r>
@@ -7286,7 +7286,7 @@
                 <a:solidFill>
                   <a:srgbClr val="163548"/>
                 </a:solidFill>
-                <a:latin typeface="Aptos"/>
+                <a:latin typeface="Arial"/>
               </a:defRPr>
             </a:pPr>
           </a:p>
@@ -7322,7 +7322,7 @@
                 <a:solidFill>
                   <a:srgbClr val="037E83"/>
                 </a:solidFill>
-                <a:latin typeface="Aptos"/>
+                <a:latin typeface="Arial"/>
               </a:defRPr>
             </a:pPr>
             <a:r>
@@ -7338,7 +7338,7 @@
                 <a:solidFill>
                   <a:srgbClr val="037E83"/>
                 </a:solidFill>
-                <a:latin typeface="Aptos"/>
+                <a:latin typeface="Arial"/>
               </a:defRPr>
             </a:pPr>
             <a:r>
@@ -7377,7 +7377,7 @@
                 <a:solidFill>
                   <a:srgbClr val="163548"/>
                 </a:solidFill>
-                <a:latin typeface="Aptos"/>
+                <a:latin typeface="Arial"/>
               </a:defRPr>
             </a:pPr>
             <a:r>
@@ -7433,7 +7433,7 @@
                 <a:solidFill>
                   <a:srgbClr val="163548"/>
                 </a:solidFill>
-                <a:latin typeface="Aptos"/>
+                <a:latin typeface="Arial"/>
               </a:defRPr>
             </a:pPr>
           </a:p>
@@ -7469,7 +7469,7 @@
                 <a:solidFill>
                   <a:srgbClr val="037E83"/>
                 </a:solidFill>
-                <a:latin typeface="Aptos"/>
+                <a:latin typeface="Arial"/>
               </a:defRPr>
             </a:pPr>
             <a:r>
@@ -7485,7 +7485,7 @@
                 <a:solidFill>
                   <a:srgbClr val="037E83"/>
                 </a:solidFill>
-                <a:latin typeface="Aptos"/>
+                <a:latin typeface="Arial"/>
               </a:defRPr>
             </a:pPr>
             <a:r>
@@ -7524,7 +7524,7 @@
                 <a:solidFill>
                   <a:srgbClr val="163548"/>
                 </a:solidFill>
-                <a:latin typeface="Aptos"/>
+                <a:latin typeface="Arial"/>
               </a:defRPr>
             </a:pPr>
             <a:r>
@@ -7580,7 +7580,7 @@
                 <a:solidFill>
                   <a:srgbClr val="163548"/>
                 </a:solidFill>
-                <a:latin typeface="Aptos"/>
+                <a:latin typeface="Arial"/>
               </a:defRPr>
             </a:pPr>
           </a:p>
@@ -7616,7 +7616,7 @@
                 <a:solidFill>
                   <a:srgbClr val="037E83"/>
                 </a:solidFill>
-                <a:latin typeface="Aptos"/>
+                <a:latin typeface="Arial"/>
               </a:defRPr>
             </a:pPr>
             <a:r>
@@ -7632,7 +7632,7 @@
                 <a:solidFill>
                   <a:srgbClr val="037E83"/>
                 </a:solidFill>
-                <a:latin typeface="Aptos"/>
+                <a:latin typeface="Arial"/>
               </a:defRPr>
             </a:pPr>
             <a:r>
@@ -7671,7 +7671,7 @@
                 <a:solidFill>
                   <a:srgbClr val="163548"/>
                 </a:solidFill>
-                <a:latin typeface="Aptos"/>
+                <a:latin typeface="Arial"/>
               </a:defRPr>
             </a:pPr>
             <a:r>
@@ -7710,7 +7710,7 @@
                 <a:solidFill>
                   <a:srgbClr val="53717B"/>
                 </a:solidFill>
-                <a:latin typeface="Aptos"/>
+                <a:latin typeface="Arial"/>
               </a:defRPr>
             </a:pPr>
             <a:r>
@@ -7775,7 +7775,7 @@
                 <a:solidFill>
                   <a:srgbClr val="037E83"/>
                 </a:solidFill>
-                <a:latin typeface="Aptos"/>
+                <a:latin typeface="Arial"/>
               </a:defRPr>
             </a:pPr>
             <a:r>
@@ -7814,7 +7814,7 @@
                 <a:solidFill>
                   <a:srgbClr val="112C3D"/>
                 </a:solidFill>
-                <a:latin typeface="Aptos"/>
+                <a:latin typeface="Arial"/>
               </a:defRPr>
             </a:pPr>
             <a:r>
@@ -7853,7 +7853,7 @@
                 <a:solidFill>
                   <a:srgbClr val="53717B"/>
                 </a:solidFill>
-                <a:latin typeface="Aptos"/>
+                <a:latin typeface="Arial"/>
               </a:defRPr>
             </a:pPr>
             <a:r>
@@ -7892,7 +7892,7 @@
                 <a:solidFill>
                   <a:srgbClr val="037E83"/>
                 </a:solidFill>
-                <a:latin typeface="Aptos"/>
+                <a:latin typeface="Arial"/>
               </a:defRPr>
             </a:pPr>
             <a:r>
@@ -7948,7 +7948,7 @@
                 <a:solidFill>
                   <a:srgbClr val="163548"/>
                 </a:solidFill>
-                <a:latin typeface="Aptos"/>
+                <a:latin typeface="Arial"/>
               </a:defRPr>
             </a:pPr>
           </a:p>
@@ -7984,7 +7984,7 @@
                 <a:solidFill>
                   <a:srgbClr val="037E83"/>
                 </a:solidFill>
-                <a:latin typeface="Aptos"/>
+                <a:latin typeface="Arial"/>
               </a:defRPr>
             </a:pPr>
             <a:r>
@@ -8023,7 +8023,7 @@
                 <a:solidFill>
                   <a:srgbClr val="163548"/>
                 </a:solidFill>
-                <a:latin typeface="Aptos"/>
+                <a:latin typeface="Arial"/>
               </a:defRPr>
             </a:pPr>
             <a:r>
@@ -8079,7 +8079,7 @@
                 <a:solidFill>
                   <a:srgbClr val="163548"/>
                 </a:solidFill>
-                <a:latin typeface="Aptos"/>
+                <a:latin typeface="Arial"/>
               </a:defRPr>
             </a:pPr>
           </a:p>
@@ -8115,7 +8115,7 @@
                 <a:solidFill>
                   <a:srgbClr val="037E83"/>
                 </a:solidFill>
-                <a:latin typeface="Aptos"/>
+                <a:latin typeface="Arial"/>
               </a:defRPr>
             </a:pPr>
             <a:r>
@@ -8154,7 +8154,7 @@
                 <a:solidFill>
                   <a:srgbClr val="163548"/>
                 </a:solidFill>
-                <a:latin typeface="Aptos"/>
+                <a:latin typeface="Arial"/>
               </a:defRPr>
             </a:pPr>
             <a:r>
@@ -8210,7 +8210,7 @@
                 <a:solidFill>
                   <a:srgbClr val="163548"/>
                 </a:solidFill>
-                <a:latin typeface="Aptos"/>
+                <a:latin typeface="Arial"/>
               </a:defRPr>
             </a:pPr>
           </a:p>
@@ -8246,7 +8246,7 @@
                 <a:solidFill>
                   <a:srgbClr val="037E83"/>
                 </a:solidFill>
-                <a:latin typeface="Aptos"/>
+                <a:latin typeface="Arial"/>
               </a:defRPr>
             </a:pPr>
             <a:r>
@@ -8285,7 +8285,7 @@
                 <a:solidFill>
                   <a:srgbClr val="163548"/>
                 </a:solidFill>
-                <a:latin typeface="Aptos"/>
+                <a:latin typeface="Arial"/>
               </a:defRPr>
             </a:pPr>
             <a:r>
@@ -8350,7 +8350,7 @@
                 <a:solidFill>
                   <a:srgbClr val="037E83"/>
                 </a:solidFill>
-                <a:latin typeface="Aptos"/>
+                <a:latin typeface="Arial"/>
               </a:defRPr>
             </a:pPr>
             <a:r>
@@ -8389,7 +8389,7 @@
                 <a:solidFill>
                   <a:srgbClr val="112C3D"/>
                 </a:solidFill>
-                <a:latin typeface="Aptos"/>
+                <a:latin typeface="Arial"/>
               </a:defRPr>
             </a:pPr>
             <a:r>
@@ -8428,7 +8428,7 @@
                 <a:solidFill>
                   <a:srgbClr val="53717B"/>
                 </a:solidFill>
-                <a:latin typeface="Aptos"/>
+                <a:latin typeface="Arial"/>
               </a:defRPr>
             </a:pPr>
             <a:r>
@@ -8467,7 +8467,7 @@
                 <a:solidFill>
                   <a:srgbClr val="037E83"/>
                 </a:solidFill>
-                <a:latin typeface="Aptos"/>
+                <a:latin typeface="Arial"/>
               </a:defRPr>
             </a:pPr>
             <a:r>
@@ -8523,7 +8523,7 @@
                 <a:solidFill>
                   <a:srgbClr val="163548"/>
                 </a:solidFill>
-                <a:latin typeface="Aptos"/>
+                <a:latin typeface="Arial"/>
               </a:defRPr>
             </a:pPr>
           </a:p>
@@ -8559,7 +8559,7 @@
                 <a:solidFill>
                   <a:srgbClr val="037E83"/>
                 </a:solidFill>
-                <a:latin typeface="Aptos"/>
+                <a:latin typeface="Arial"/>
               </a:defRPr>
             </a:pPr>
             <a:r>
@@ -8598,7 +8598,7 @@
                 <a:solidFill>
                   <a:srgbClr val="163548"/>
                 </a:solidFill>
-                <a:latin typeface="Aptos"/>
+                <a:latin typeface="Arial"/>
               </a:defRPr>
             </a:pPr>
             <a:r>
@@ -8654,7 +8654,7 @@
                 <a:solidFill>
                   <a:srgbClr val="163548"/>
                 </a:solidFill>
-                <a:latin typeface="Aptos"/>
+                <a:latin typeface="Arial"/>
               </a:defRPr>
             </a:pPr>
           </a:p>
@@ -8690,7 +8690,7 @@
                 <a:solidFill>
                   <a:srgbClr val="037E83"/>
                 </a:solidFill>
-                <a:latin typeface="Aptos"/>
+                <a:latin typeface="Arial"/>
               </a:defRPr>
             </a:pPr>
             <a:r>
@@ -8729,7 +8729,7 @@
                 <a:solidFill>
                   <a:srgbClr val="163548"/>
                 </a:solidFill>
-                <a:latin typeface="Aptos"/>
+                <a:latin typeface="Arial"/>
               </a:defRPr>
             </a:pPr>
             <a:r>
@@ -8785,7 +8785,7 @@
                 <a:solidFill>
                   <a:srgbClr val="163548"/>
                 </a:solidFill>
-                <a:latin typeface="Aptos"/>
+                <a:latin typeface="Arial"/>
               </a:defRPr>
             </a:pPr>
           </a:p>
@@ -8821,7 +8821,7 @@
                 <a:solidFill>
                   <a:srgbClr val="037E83"/>
                 </a:solidFill>
-                <a:latin typeface="Aptos"/>
+                <a:latin typeface="Arial"/>
               </a:defRPr>
             </a:pPr>
             <a:r>
@@ -8860,7 +8860,7 @@
                 <a:solidFill>
                   <a:srgbClr val="163548"/>
                 </a:solidFill>
-                <a:latin typeface="Aptos"/>
+                <a:latin typeface="Arial"/>
               </a:defRPr>
             </a:pPr>
             <a:r>
@@ -8899,7 +8899,7 @@
                 <a:solidFill>
                   <a:srgbClr val="53717B"/>
                 </a:solidFill>
-                <a:latin typeface="Aptos"/>
+                <a:latin typeface="Arial"/>
               </a:defRPr>
             </a:pPr>
             <a:r>
@@ -8964,7 +8964,7 @@
                 <a:solidFill>
                   <a:srgbClr val="037E83"/>
                 </a:solidFill>
-                <a:latin typeface="Aptos"/>
+                <a:latin typeface="Arial"/>
               </a:defRPr>
             </a:pPr>
             <a:r>
@@ -9003,7 +9003,7 @@
                 <a:solidFill>
                   <a:srgbClr val="112C3D"/>
                 </a:solidFill>
-                <a:latin typeface="Aptos"/>
+                <a:latin typeface="Arial"/>
               </a:defRPr>
             </a:pPr>
             <a:r>
@@ -9042,7 +9042,7 @@
                 <a:solidFill>
                   <a:srgbClr val="53717B"/>
                 </a:solidFill>
-                <a:latin typeface="Aptos"/>
+                <a:latin typeface="Arial"/>
               </a:defRPr>
             </a:pPr>
             <a:r>
@@ -9081,7 +9081,7 @@
                 <a:solidFill>
                   <a:srgbClr val="037E83"/>
                 </a:solidFill>
-                <a:latin typeface="Aptos"/>
+                <a:latin typeface="Arial"/>
               </a:defRPr>
             </a:pPr>
             <a:r>
@@ -9137,7 +9137,7 @@
                 <a:solidFill>
                   <a:srgbClr val="163548"/>
                 </a:solidFill>
-                <a:latin typeface="Aptos"/>
+                <a:latin typeface="Arial"/>
               </a:defRPr>
             </a:pPr>
           </a:p>
@@ -9173,7 +9173,7 @@
                 <a:solidFill>
                   <a:srgbClr val="037E83"/>
                 </a:solidFill>
-                <a:latin typeface="Aptos"/>
+                <a:latin typeface="Arial"/>
               </a:defRPr>
             </a:pPr>
             <a:r>
@@ -9212,7 +9212,7 @@
                 <a:solidFill>
                   <a:srgbClr val="163548"/>
                 </a:solidFill>
-                <a:latin typeface="Aptos"/>
+                <a:latin typeface="Arial"/>
               </a:defRPr>
             </a:pPr>
             <a:r>
@@ -9268,7 +9268,7 @@
                 <a:solidFill>
                   <a:srgbClr val="163548"/>
                 </a:solidFill>
-                <a:latin typeface="Aptos"/>
+                <a:latin typeface="Arial"/>
               </a:defRPr>
             </a:pPr>
           </a:p>
@@ -9304,7 +9304,7 @@
                 <a:solidFill>
                   <a:srgbClr val="037E83"/>
                 </a:solidFill>
-                <a:latin typeface="Aptos"/>
+                <a:latin typeface="Arial"/>
               </a:defRPr>
             </a:pPr>
             <a:r>
@@ -9343,7 +9343,7 @@
                 <a:solidFill>
                   <a:srgbClr val="163548"/>
                 </a:solidFill>
-                <a:latin typeface="Aptos"/>
+                <a:latin typeface="Arial"/>
               </a:defRPr>
             </a:pPr>
             <a:r>
@@ -9399,7 +9399,7 @@
                 <a:solidFill>
                   <a:srgbClr val="163548"/>
                 </a:solidFill>
-                <a:latin typeface="Aptos"/>
+                <a:latin typeface="Arial"/>
               </a:defRPr>
             </a:pPr>
           </a:p>
@@ -9435,7 +9435,7 @@
                 <a:solidFill>
                   <a:srgbClr val="037E83"/>
                 </a:solidFill>
-                <a:latin typeface="Aptos"/>
+                <a:latin typeface="Arial"/>
               </a:defRPr>
             </a:pPr>
             <a:r>
@@ -9474,7 +9474,7 @@
                 <a:solidFill>
                   <a:srgbClr val="163548"/>
                 </a:solidFill>
-                <a:latin typeface="Aptos"/>
+                <a:latin typeface="Arial"/>
               </a:defRPr>
             </a:pPr>
             <a:r>
@@ -9539,7 +9539,7 @@
                 <a:solidFill>
                   <a:srgbClr val="037E83"/>
                 </a:solidFill>
-                <a:latin typeface="Aptos"/>
+                <a:latin typeface="Arial"/>
               </a:defRPr>
             </a:pPr>
             <a:r>
@@ -9578,7 +9578,7 @@
                 <a:solidFill>
                   <a:srgbClr val="112C3D"/>
                 </a:solidFill>
-                <a:latin typeface="Aptos"/>
+                <a:latin typeface="Arial"/>
               </a:defRPr>
             </a:pPr>
             <a:r>
@@ -9617,7 +9617,7 @@
                 <a:solidFill>
                   <a:srgbClr val="53717B"/>
                 </a:solidFill>
-                <a:latin typeface="Aptos"/>
+                <a:latin typeface="Arial"/>
               </a:defRPr>
             </a:pPr>
             <a:r>
@@ -9656,7 +9656,7 @@
                 <a:solidFill>
                   <a:srgbClr val="037E83"/>
                 </a:solidFill>
-                <a:latin typeface="Aptos"/>
+                <a:latin typeface="Arial"/>
               </a:defRPr>
             </a:pPr>
             <a:r>
@@ -9712,7 +9712,7 @@
                 <a:solidFill>
                   <a:srgbClr val="163548"/>
                 </a:solidFill>
-                <a:latin typeface="Aptos"/>
+                <a:latin typeface="Arial"/>
               </a:defRPr>
             </a:pPr>
           </a:p>
@@ -9748,7 +9748,7 @@
                 <a:solidFill>
                   <a:srgbClr val="037E83"/>
                 </a:solidFill>
-                <a:latin typeface="Aptos"/>
+                <a:latin typeface="Arial"/>
               </a:defRPr>
             </a:pPr>
             <a:r>
@@ -9787,7 +9787,7 @@
                 <a:solidFill>
                   <a:srgbClr val="163548"/>
                 </a:solidFill>
-                <a:latin typeface="Aptos"/>
+                <a:latin typeface="Arial"/>
               </a:defRPr>
             </a:pPr>
             <a:r>
@@ -9843,7 +9843,7 @@
                 <a:solidFill>
                   <a:srgbClr val="163548"/>
                 </a:solidFill>
-                <a:latin typeface="Aptos"/>
+                <a:latin typeface="Arial"/>
               </a:defRPr>
             </a:pPr>
           </a:p>
@@ -9879,7 +9879,7 @@
                 <a:solidFill>
                   <a:srgbClr val="037E83"/>
                 </a:solidFill>
-                <a:latin typeface="Aptos"/>
+                <a:latin typeface="Arial"/>
               </a:defRPr>
             </a:pPr>
             <a:r>
@@ -9918,7 +9918,7 @@
                 <a:solidFill>
                   <a:srgbClr val="163548"/>
                 </a:solidFill>
-                <a:latin typeface="Aptos"/>
+                <a:latin typeface="Arial"/>
               </a:defRPr>
             </a:pPr>
             <a:r>
@@ -9974,7 +9974,7 @@
                 <a:solidFill>
                   <a:srgbClr val="163548"/>
                 </a:solidFill>
-                <a:latin typeface="Aptos"/>
+                <a:latin typeface="Arial"/>
               </a:defRPr>
             </a:pPr>
           </a:p>
@@ -10010,7 +10010,7 @@
                 <a:solidFill>
                   <a:srgbClr val="037E83"/>
                 </a:solidFill>
-                <a:latin typeface="Aptos"/>
+                <a:latin typeface="Arial"/>
               </a:defRPr>
             </a:pPr>
             <a:r>
@@ -10049,7 +10049,7 @@
                 <a:solidFill>
                   <a:srgbClr val="163548"/>
                 </a:solidFill>
-                <a:latin typeface="Aptos"/>
+                <a:latin typeface="Arial"/>
               </a:defRPr>
             </a:pPr>
             <a:r>
@@ -10105,7 +10105,7 @@
                 <a:solidFill>
                   <a:srgbClr val="163548"/>
                 </a:solidFill>
-                <a:latin typeface="Aptos"/>
+                <a:latin typeface="Arial"/>
               </a:defRPr>
             </a:pPr>
           </a:p>
@@ -10141,7 +10141,7 @@
                 <a:solidFill>
                   <a:srgbClr val="037E83"/>
                 </a:solidFill>
-                <a:latin typeface="Aptos"/>
+                <a:latin typeface="Arial"/>
               </a:defRPr>
             </a:pPr>
             <a:r>
@@ -10180,7 +10180,7 @@
                 <a:solidFill>
                   <a:srgbClr val="163548"/>
                 </a:solidFill>
-                <a:latin typeface="Aptos"/>
+                <a:latin typeface="Arial"/>
               </a:defRPr>
             </a:pPr>
             <a:r>
@@ -10236,7 +10236,7 @@
                 <a:solidFill>
                   <a:srgbClr val="163548"/>
                 </a:solidFill>
-                <a:latin typeface="Aptos"/>
+                <a:latin typeface="Arial"/>
               </a:defRPr>
             </a:pPr>
           </a:p>
@@ -10272,7 +10272,7 @@
                 <a:solidFill>
                   <a:srgbClr val="037E83"/>
                 </a:solidFill>
-                <a:latin typeface="Aptos"/>
+                <a:latin typeface="Arial"/>
               </a:defRPr>
             </a:pPr>
             <a:r>
@@ -10311,7 +10311,7 @@
                 <a:solidFill>
                   <a:srgbClr val="163548"/>
                 </a:solidFill>
-                <a:latin typeface="Aptos"/>
+                <a:latin typeface="Arial"/>
               </a:defRPr>
             </a:pPr>
             <a:r>
@@ -10367,7 +10367,7 @@
                 <a:solidFill>
                   <a:srgbClr val="163548"/>
                 </a:solidFill>
-                <a:latin typeface="Aptos"/>
+                <a:latin typeface="Arial"/>
               </a:defRPr>
             </a:pPr>
           </a:p>
@@ -10403,7 +10403,7 @@
                 <a:solidFill>
                   <a:srgbClr val="037E83"/>
                 </a:solidFill>
-                <a:latin typeface="Aptos"/>
+                <a:latin typeface="Arial"/>
               </a:defRPr>
             </a:pPr>
             <a:r>
@@ -10442,7 +10442,7 @@
                 <a:solidFill>
                   <a:srgbClr val="163548"/>
                 </a:solidFill>
-                <a:latin typeface="Aptos"/>
+                <a:latin typeface="Arial"/>
               </a:defRPr>
             </a:pPr>
             <a:r>
@@ -10507,7 +10507,7 @@
                 <a:solidFill>
                   <a:srgbClr val="037E83"/>
                 </a:solidFill>
-                <a:latin typeface="Aptos"/>
+                <a:latin typeface="Arial"/>
               </a:defRPr>
             </a:pPr>
             <a:r>
@@ -10546,7 +10546,7 @@
                 <a:solidFill>
                   <a:srgbClr val="112C3D"/>
                 </a:solidFill>
-                <a:latin typeface="Aptos"/>
+                <a:latin typeface="Arial"/>
               </a:defRPr>
             </a:pPr>
             <a:r>
@@ -10585,7 +10585,7 @@
                 <a:solidFill>
                   <a:srgbClr val="53717B"/>
                 </a:solidFill>
-                <a:latin typeface="Aptos"/>
+                <a:latin typeface="Arial"/>
               </a:defRPr>
             </a:pPr>
             <a:r>
@@ -10624,7 +10624,7 @@
                 <a:solidFill>
                   <a:srgbClr val="037E83"/>
                 </a:solidFill>
-                <a:latin typeface="Aptos"/>
+                <a:latin typeface="Arial"/>
               </a:defRPr>
             </a:pPr>
             <a:r>
@@ -10680,7 +10680,7 @@
                 <a:solidFill>
                   <a:srgbClr val="163548"/>
                 </a:solidFill>
-                <a:latin typeface="Aptos"/>
+                <a:latin typeface="Arial"/>
               </a:defRPr>
             </a:pPr>
           </a:p>
@@ -10716,7 +10716,7 @@
                 <a:solidFill>
                   <a:srgbClr val="037E83"/>
                 </a:solidFill>
-                <a:latin typeface="Aptos"/>
+                <a:latin typeface="Arial"/>
               </a:defRPr>
             </a:pPr>
             <a:r>
@@ -10755,7 +10755,7 @@
                 <a:solidFill>
                   <a:srgbClr val="163548"/>
                 </a:solidFill>
-                <a:latin typeface="Aptos"/>
+                <a:latin typeface="Arial"/>
               </a:defRPr>
             </a:pPr>
             <a:r>
@@ -10811,7 +10811,7 @@
                 <a:solidFill>
                   <a:srgbClr val="163548"/>
                 </a:solidFill>
-                <a:latin typeface="Aptos"/>
+                <a:latin typeface="Arial"/>
               </a:defRPr>
             </a:pPr>
           </a:p>
@@ -10847,7 +10847,7 @@
                 <a:solidFill>
                   <a:srgbClr val="037E83"/>
                 </a:solidFill>
-                <a:latin typeface="Aptos"/>
+                <a:latin typeface="Arial"/>
               </a:defRPr>
             </a:pPr>
             <a:r>
@@ -10886,7 +10886,7 @@
                 <a:solidFill>
                   <a:srgbClr val="163548"/>
                 </a:solidFill>
-                <a:latin typeface="Aptos"/>
+                <a:latin typeface="Arial"/>
               </a:defRPr>
             </a:pPr>
             <a:r>
@@ -10942,7 +10942,7 @@
                 <a:solidFill>
                   <a:srgbClr val="163548"/>
                 </a:solidFill>
-                <a:latin typeface="Aptos"/>
+                <a:latin typeface="Arial"/>
               </a:defRPr>
             </a:pPr>
           </a:p>
@@ -10978,7 +10978,7 @@
                 <a:solidFill>
                   <a:srgbClr val="037E83"/>
                 </a:solidFill>
-                <a:latin typeface="Aptos"/>
+                <a:latin typeface="Arial"/>
               </a:defRPr>
             </a:pPr>
             <a:r>
@@ -11017,7 +11017,7 @@
                 <a:solidFill>
                   <a:srgbClr val="163548"/>
                 </a:solidFill>
-                <a:latin typeface="Aptos"/>
+                <a:latin typeface="Arial"/>
               </a:defRPr>
             </a:pPr>
             <a:r>
@@ -11056,7 +11056,7 @@
                 <a:solidFill>
                   <a:srgbClr val="53717B"/>
                 </a:solidFill>
-                <a:latin typeface="Aptos"/>
+                <a:latin typeface="Arial"/>
               </a:defRPr>
             </a:pPr>
             <a:r>
@@ -11121,7 +11121,7 @@
                 <a:solidFill>
                   <a:srgbClr val="037E83"/>
                 </a:solidFill>
-                <a:latin typeface="Aptos"/>
+                <a:latin typeface="Arial"/>
               </a:defRPr>
             </a:pPr>
             <a:r>
@@ -11160,7 +11160,7 @@
                 <a:solidFill>
                   <a:srgbClr val="112C3D"/>
                 </a:solidFill>
-                <a:latin typeface="Aptos"/>
+                <a:latin typeface="Arial"/>
               </a:defRPr>
             </a:pPr>
             <a:r>
@@ -11199,7 +11199,7 @@
                 <a:solidFill>
                   <a:srgbClr val="53717B"/>
                 </a:solidFill>
-                <a:latin typeface="Aptos"/>
+                <a:latin typeface="Arial"/>
               </a:defRPr>
             </a:pPr>
             <a:r>
@@ -11238,7 +11238,7 @@
                 <a:solidFill>
                   <a:srgbClr val="037E83"/>
                 </a:solidFill>
-                <a:latin typeface="Aptos"/>
+                <a:latin typeface="Arial"/>
               </a:defRPr>
             </a:pPr>
             <a:r>
@@ -11294,7 +11294,7 @@
                 <a:solidFill>
                   <a:srgbClr val="163548"/>
                 </a:solidFill>
-                <a:latin typeface="Aptos"/>
+                <a:latin typeface="Arial"/>
               </a:defRPr>
             </a:pPr>
           </a:p>
@@ -11330,7 +11330,7 @@
                 <a:solidFill>
                   <a:srgbClr val="037E83"/>
                 </a:solidFill>
-                <a:latin typeface="Aptos"/>
+                <a:latin typeface="Arial"/>
               </a:defRPr>
             </a:pPr>
             <a:r>
@@ -11369,7 +11369,7 @@
                 <a:solidFill>
                   <a:srgbClr val="163548"/>
                 </a:solidFill>
-                <a:latin typeface="Aptos"/>
+                <a:latin typeface="Arial"/>
               </a:defRPr>
             </a:pPr>
             <a:r>
@@ -11425,7 +11425,7 @@
                 <a:solidFill>
                   <a:srgbClr val="163548"/>
                 </a:solidFill>
-                <a:latin typeface="Aptos"/>
+                <a:latin typeface="Arial"/>
               </a:defRPr>
             </a:pPr>
           </a:p>
@@ -11461,7 +11461,7 @@
                 <a:solidFill>
                   <a:srgbClr val="037E83"/>
                 </a:solidFill>
-                <a:latin typeface="Aptos"/>
+                <a:latin typeface="Arial"/>
               </a:defRPr>
             </a:pPr>
             <a:r>
@@ -11500,7 +11500,7 @@
                 <a:solidFill>
                   <a:srgbClr val="163548"/>
                 </a:solidFill>
-                <a:latin typeface="Aptos"/>
+                <a:latin typeface="Arial"/>
               </a:defRPr>
             </a:pPr>
             <a:r>
@@ -11556,7 +11556,7 @@
                 <a:solidFill>
                   <a:srgbClr val="163548"/>
                 </a:solidFill>
-                <a:latin typeface="Aptos"/>
+                <a:latin typeface="Arial"/>
               </a:defRPr>
             </a:pPr>
           </a:p>
@@ -11592,7 +11592,7 @@
                 <a:solidFill>
                   <a:srgbClr val="037E83"/>
                 </a:solidFill>
-                <a:latin typeface="Aptos"/>
+                <a:latin typeface="Arial"/>
               </a:defRPr>
             </a:pPr>
             <a:r>
@@ -11631,7 +11631,7 @@
                 <a:solidFill>
                   <a:srgbClr val="163548"/>
                 </a:solidFill>
-                <a:latin typeface="Aptos"/>
+                <a:latin typeface="Arial"/>
               </a:defRPr>
             </a:pPr>
             <a:r>
@@ -11670,7 +11670,7 @@
                 <a:solidFill>
                   <a:srgbClr val="53717B"/>
                 </a:solidFill>
-                <a:latin typeface="Aptos"/>
+                <a:latin typeface="Arial"/>
               </a:defRPr>
             </a:pPr>
             <a:r>
@@ -11735,7 +11735,7 @@
                 <a:solidFill>
                   <a:srgbClr val="037E83"/>
                 </a:solidFill>
-                <a:latin typeface="Aptos"/>
+                <a:latin typeface="Arial"/>
               </a:defRPr>
             </a:pPr>
             <a:r>
@@ -11774,7 +11774,7 @@
                 <a:solidFill>
                   <a:srgbClr val="112C3D"/>
                 </a:solidFill>
-                <a:latin typeface="Aptos"/>
+                <a:latin typeface="Arial"/>
               </a:defRPr>
             </a:pPr>
             <a:r>
@@ -11813,7 +11813,7 @@
                 <a:solidFill>
                   <a:srgbClr val="53717B"/>
                 </a:solidFill>
-                <a:latin typeface="Aptos"/>
+                <a:latin typeface="Arial"/>
               </a:defRPr>
             </a:pPr>
             <a:r>
@@ -11852,7 +11852,7 @@
                 <a:solidFill>
                   <a:srgbClr val="037E83"/>
                 </a:solidFill>
-                <a:latin typeface="Aptos"/>
+                <a:latin typeface="Arial"/>
               </a:defRPr>
             </a:pPr>
             <a:r>
@@ -11908,7 +11908,7 @@
                 <a:solidFill>
                   <a:srgbClr val="163548"/>
                 </a:solidFill>
-                <a:latin typeface="Aptos"/>
+                <a:latin typeface="Arial"/>
               </a:defRPr>
             </a:pPr>
           </a:p>
@@ -11944,7 +11944,7 @@
                 <a:solidFill>
                   <a:srgbClr val="037E83"/>
                 </a:solidFill>
-                <a:latin typeface="Aptos"/>
+                <a:latin typeface="Arial"/>
               </a:defRPr>
             </a:pPr>
             <a:r>
@@ -11983,7 +11983,7 @@
                 <a:solidFill>
                   <a:srgbClr val="163548"/>
                 </a:solidFill>
-                <a:latin typeface="Aptos"/>
+                <a:latin typeface="Arial"/>
               </a:defRPr>
             </a:pPr>
             <a:r>
@@ -12039,7 +12039,7 @@
                 <a:solidFill>
                   <a:srgbClr val="163548"/>
                 </a:solidFill>
-                <a:latin typeface="Aptos"/>
+                <a:latin typeface="Arial"/>
               </a:defRPr>
             </a:pPr>
           </a:p>
@@ -12075,7 +12075,7 @@
                 <a:solidFill>
                   <a:srgbClr val="037E83"/>
                 </a:solidFill>
-                <a:latin typeface="Aptos"/>
+                <a:latin typeface="Arial"/>
               </a:defRPr>
             </a:pPr>
             <a:r>
@@ -12114,7 +12114,7 @@
                 <a:solidFill>
                   <a:srgbClr val="163548"/>
                 </a:solidFill>
-                <a:latin typeface="Aptos"/>
+                <a:latin typeface="Arial"/>
               </a:defRPr>
             </a:pPr>
             <a:r>
@@ -12170,7 +12170,7 @@
                 <a:solidFill>
                   <a:srgbClr val="163548"/>
                 </a:solidFill>
-                <a:latin typeface="Aptos"/>
+                <a:latin typeface="Arial"/>
               </a:defRPr>
             </a:pPr>
           </a:p>
@@ -12206,7 +12206,7 @@
                 <a:solidFill>
                   <a:srgbClr val="037E83"/>
                 </a:solidFill>
-                <a:latin typeface="Aptos"/>
+                <a:latin typeface="Arial"/>
               </a:defRPr>
             </a:pPr>
             <a:r>
@@ -12245,7 +12245,7 @@
                 <a:solidFill>
                   <a:srgbClr val="163548"/>
                 </a:solidFill>
-                <a:latin typeface="Aptos"/>
+                <a:latin typeface="Arial"/>
               </a:defRPr>
             </a:pPr>
             <a:r>
@@ -12284,7 +12284,7 @@
                 <a:solidFill>
                   <a:srgbClr val="53717B"/>
                 </a:solidFill>
-                <a:latin typeface="Aptos"/>
+                <a:latin typeface="Arial"/>
               </a:defRPr>
             </a:pPr>
             <a:r>
@@ -12349,7 +12349,7 @@
                 <a:solidFill>
                   <a:srgbClr val="037E83"/>
                 </a:solidFill>
-                <a:latin typeface="Aptos"/>
+                <a:latin typeface="Arial"/>
               </a:defRPr>
             </a:pPr>
             <a:r>
@@ -12388,7 +12388,7 @@
                 <a:solidFill>
                   <a:srgbClr val="112C3D"/>
                 </a:solidFill>
-                <a:latin typeface="Aptos"/>
+                <a:latin typeface="Arial"/>
               </a:defRPr>
             </a:pPr>
             <a:r>
@@ -12427,7 +12427,7 @@
                 <a:solidFill>
                   <a:srgbClr val="53717B"/>
                 </a:solidFill>
-                <a:latin typeface="Aptos"/>
+                <a:latin typeface="Arial"/>
               </a:defRPr>
             </a:pPr>
             <a:r>
@@ -12466,7 +12466,7 @@
                 <a:solidFill>
                   <a:srgbClr val="037E83"/>
                 </a:solidFill>
-                <a:latin typeface="Aptos"/>
+                <a:latin typeface="Arial"/>
               </a:defRPr>
             </a:pPr>
             <a:r>
@@ -12522,7 +12522,7 @@
                 <a:solidFill>
                   <a:srgbClr val="163548"/>
                 </a:solidFill>
-                <a:latin typeface="Aptos"/>
+                <a:latin typeface="Arial"/>
               </a:defRPr>
             </a:pPr>
           </a:p>
@@ -12558,7 +12558,7 @@
                 <a:solidFill>
                   <a:srgbClr val="037E83"/>
                 </a:solidFill>
-                <a:latin typeface="Aptos"/>
+                <a:latin typeface="Arial"/>
               </a:defRPr>
             </a:pPr>
             <a:r>
@@ -12597,7 +12597,7 @@
                 <a:solidFill>
                   <a:srgbClr val="163548"/>
                 </a:solidFill>
-                <a:latin typeface="Aptos"/>
+                <a:latin typeface="Arial"/>
               </a:defRPr>
             </a:pPr>
             <a:r>
@@ -12653,7 +12653,7 @@
                 <a:solidFill>
                   <a:srgbClr val="163548"/>
                 </a:solidFill>
-                <a:latin typeface="Aptos"/>
+                <a:latin typeface="Arial"/>
               </a:defRPr>
             </a:pPr>
           </a:p>
@@ -12689,7 +12689,7 @@
                 <a:solidFill>
                   <a:srgbClr val="037E83"/>
                 </a:solidFill>
-                <a:latin typeface="Aptos"/>
+                <a:latin typeface="Arial"/>
               </a:defRPr>
             </a:pPr>
             <a:r>
@@ -12728,7 +12728,7 @@
                 <a:solidFill>
                   <a:srgbClr val="163548"/>
                 </a:solidFill>
-                <a:latin typeface="Aptos"/>
+                <a:latin typeface="Arial"/>
               </a:defRPr>
             </a:pPr>
             <a:r>
@@ -12784,7 +12784,7 @@
                 <a:solidFill>
                   <a:srgbClr val="163548"/>
                 </a:solidFill>
-                <a:latin typeface="Aptos"/>
+                <a:latin typeface="Arial"/>
               </a:defRPr>
             </a:pPr>
           </a:p>
@@ -12820,7 +12820,7 @@
                 <a:solidFill>
                   <a:srgbClr val="037E83"/>
                 </a:solidFill>
-                <a:latin typeface="Aptos"/>
+                <a:latin typeface="Arial"/>
               </a:defRPr>
             </a:pPr>
             <a:r>
@@ -12859,7 +12859,7 @@
                 <a:solidFill>
                   <a:srgbClr val="163548"/>
                 </a:solidFill>
-                <a:latin typeface="Aptos"/>
+                <a:latin typeface="Arial"/>
               </a:defRPr>
             </a:pPr>
             <a:r>
@@ -12924,7 +12924,7 @@
                 <a:solidFill>
                   <a:srgbClr val="037E83"/>
                 </a:solidFill>
-                <a:latin typeface="Aptos"/>
+                <a:latin typeface="Arial"/>
               </a:defRPr>
             </a:pPr>
             <a:r>
@@ -12963,7 +12963,7 @@
                 <a:solidFill>
                   <a:srgbClr val="112C3D"/>
                 </a:solidFill>
-                <a:latin typeface="Aptos"/>
+                <a:latin typeface="Arial"/>
               </a:defRPr>
             </a:pPr>
             <a:r>
@@ -13002,7 +13002,7 @@
                 <a:solidFill>
                   <a:srgbClr val="53717B"/>
                 </a:solidFill>
-                <a:latin typeface="Aptos"/>
+                <a:latin typeface="Arial"/>
               </a:defRPr>
             </a:pPr>
             <a:r>
@@ -13041,7 +13041,7 @@
                 <a:solidFill>
                   <a:srgbClr val="037E83"/>
                 </a:solidFill>
-                <a:latin typeface="Aptos"/>
+                <a:latin typeface="Arial"/>
               </a:defRPr>
             </a:pPr>
             <a:r>
@@ -13097,7 +13097,7 @@
                 <a:solidFill>
                   <a:srgbClr val="163548"/>
                 </a:solidFill>
-                <a:latin typeface="Aptos"/>
+                <a:latin typeface="Arial"/>
               </a:defRPr>
             </a:pPr>
           </a:p>
@@ -13133,7 +13133,7 @@
                 <a:solidFill>
                   <a:srgbClr val="037E83"/>
                 </a:solidFill>
-                <a:latin typeface="Aptos"/>
+                <a:latin typeface="Arial"/>
               </a:defRPr>
             </a:pPr>
             <a:r>
@@ -13172,11 +13172,11 @@
                 <a:solidFill>
                   <a:srgbClr val="163548"/>
                 </a:solidFill>
-                <a:latin typeface="Aptos"/>
-              </a:defRPr>
-            </a:pPr>
-            <a:r>
-              <a:t>Atomic cutover completed with 412,139 rows: 114,940 item and 297,199 PO/GRN. Authenticated API ranking/filter checks passed.</a:t>
+                <a:latin typeface="Arial"/>
+              </a:defRPr>
+            </a:pPr>
+            <a:r>
+              <a:t>412,139 source rows are live: 114,940 items and 297,199 PO/GRN rows. Search and filter checks passed.</a:t>
             </a:r>
           </a:p>
         </p:txBody>
@@ -13228,7 +13228,7 @@
                 <a:solidFill>
                   <a:srgbClr val="163548"/>
                 </a:solidFill>
-                <a:latin typeface="Aptos"/>
+                <a:latin typeface="Arial"/>
               </a:defRPr>
             </a:pPr>
           </a:p>
@@ -13264,7 +13264,7 @@
                 <a:solidFill>
                   <a:srgbClr val="037E83"/>
                 </a:solidFill>
-                <a:latin typeface="Aptos"/>
+                <a:latin typeface="Arial"/>
               </a:defRPr>
             </a:pPr>
             <a:r>
@@ -13303,7 +13303,7 @@
                 <a:solidFill>
                   <a:srgbClr val="163548"/>
                 </a:solidFill>
-                <a:latin typeface="Aptos"/>
+                <a:latin typeface="Arial"/>
               </a:defRPr>
             </a:pPr>
             <a:r>
@@ -13359,7 +13359,7 @@
                 <a:solidFill>
                   <a:srgbClr val="163548"/>
                 </a:solidFill>
-                <a:latin typeface="Aptos"/>
+                <a:latin typeface="Arial"/>
               </a:defRPr>
             </a:pPr>
           </a:p>
@@ -13395,7 +13395,7 @@
                 <a:solidFill>
                   <a:srgbClr val="037E83"/>
                 </a:solidFill>
-                <a:latin typeface="Aptos"/>
+                <a:latin typeface="Arial"/>
               </a:defRPr>
             </a:pPr>
             <a:r>
@@ -13434,7 +13434,7 @@
                 <a:solidFill>
                   <a:srgbClr val="163548"/>
                 </a:solidFill>
-                <a:latin typeface="Aptos"/>
+                <a:latin typeface="Arial"/>
               </a:defRPr>
             </a:pPr>
             <a:r>
@@ -13473,7 +13473,7 @@
                 <a:solidFill>
                   <a:srgbClr val="53717B"/>
                 </a:solidFill>
-                <a:latin typeface="Aptos"/>
+                <a:latin typeface="Arial"/>
               </a:defRPr>
             </a:pPr>
             <a:r>
@@ -13538,7 +13538,7 @@
                 <a:solidFill>
                   <a:srgbClr val="037E83"/>
                 </a:solidFill>
-                <a:latin typeface="Aptos"/>
+                <a:latin typeface="Arial"/>
               </a:defRPr>
             </a:pPr>
             <a:r>
@@ -13577,7 +13577,7 @@
                 <a:solidFill>
                   <a:srgbClr val="112C3D"/>
                 </a:solidFill>
-                <a:latin typeface="Aptos"/>
+                <a:latin typeface="Arial"/>
               </a:defRPr>
             </a:pPr>
             <a:r>
@@ -13616,7 +13616,7 @@
                 <a:solidFill>
                   <a:srgbClr val="53717B"/>
                 </a:solidFill>
-                <a:latin typeface="Aptos"/>
+                <a:latin typeface="Arial"/>
               </a:defRPr>
             </a:pPr>
             <a:r>
@@ -13655,7 +13655,7 @@
                 <a:solidFill>
                   <a:srgbClr val="037E83"/>
                 </a:solidFill>
-                <a:latin typeface="Aptos"/>
+                <a:latin typeface="Arial"/>
               </a:defRPr>
             </a:pPr>
             <a:r>
@@ -13711,7 +13711,7 @@
                 <a:solidFill>
                   <a:srgbClr val="163548"/>
                 </a:solidFill>
-                <a:latin typeface="Aptos"/>
+                <a:latin typeface="Arial"/>
               </a:defRPr>
             </a:pPr>
           </a:p>
@@ -13747,7 +13747,7 @@
                 <a:solidFill>
                   <a:srgbClr val="037E83"/>
                 </a:solidFill>
-                <a:latin typeface="Aptos"/>
+                <a:latin typeface="Arial"/>
               </a:defRPr>
             </a:pPr>
             <a:r>
@@ -13786,7 +13786,7 @@
                 <a:solidFill>
                   <a:srgbClr val="163548"/>
                 </a:solidFill>
-                <a:latin typeface="Aptos"/>
+                <a:latin typeface="Arial"/>
               </a:defRPr>
             </a:pPr>
             <a:r>
@@ -13842,7 +13842,7 @@
                 <a:solidFill>
                   <a:srgbClr val="163548"/>
                 </a:solidFill>
-                <a:latin typeface="Aptos"/>
+                <a:latin typeface="Arial"/>
               </a:defRPr>
             </a:pPr>
           </a:p>
@@ -13878,7 +13878,7 @@
                 <a:solidFill>
                   <a:srgbClr val="037E83"/>
                 </a:solidFill>
-                <a:latin typeface="Aptos"/>
+                <a:latin typeface="Arial"/>
               </a:defRPr>
             </a:pPr>
             <a:r>
@@ -13917,7 +13917,7 @@
                 <a:solidFill>
                   <a:srgbClr val="163548"/>
                 </a:solidFill>
-                <a:latin typeface="Aptos"/>
+                <a:latin typeface="Arial"/>
               </a:defRPr>
             </a:pPr>
             <a:r>
@@ -13973,7 +13973,7 @@
                 <a:solidFill>
                   <a:srgbClr val="163548"/>
                 </a:solidFill>
-                <a:latin typeface="Aptos"/>
+                <a:latin typeface="Arial"/>
               </a:defRPr>
             </a:pPr>
           </a:p>
@@ -14009,7 +14009,7 @@
                 <a:solidFill>
                   <a:srgbClr val="037E83"/>
                 </a:solidFill>
-                <a:latin typeface="Aptos"/>
+                <a:latin typeface="Arial"/>
               </a:defRPr>
             </a:pPr>
             <a:r>
@@ -14048,7 +14048,7 @@
                 <a:solidFill>
                   <a:srgbClr val="163548"/>
                 </a:solidFill>
-                <a:latin typeface="Aptos"/>
+                <a:latin typeface="Arial"/>
               </a:defRPr>
             </a:pPr>
             <a:r>
@@ -14087,7 +14087,7 @@
                 <a:solidFill>
                   <a:srgbClr val="53717B"/>
                 </a:solidFill>
-                <a:latin typeface="Aptos"/>
+                <a:latin typeface="Arial"/>
               </a:defRPr>
             </a:pPr>
             <a:r>

</xml_diff>